<commit_message>
Remove redundant rubric summary slide
</commit_message>
<xml_diff>
--- a/Term 1/Week 3/hackathon/presentation/MigrationHelp-Hackathon-3-final.pptx
+++ b/Term 1/Week 3/hackathon/presentation/MigrationHelp-Hackathon-3-final.pptx
@@ -2,21 +2,20 @@
 <file path=ppt/presentation.xml><?xml version="1.0" encoding="utf-8"?>
 <p:presentation xmlns:p="http://schemas.openxmlformats.org/presentationml/2006/main">
   <p:sldMasterIdLst>
-    <p:sldMasterId xmlns:r="http://schemas.openxmlformats.org/officeDocument/2006/relationships" id="2147483648" r:id="R70ec8b1495f842e3"/>
+    <p:sldMasterId xmlns:r="http://schemas.openxmlformats.org/officeDocument/2006/relationships" id="2147483648" r:id="Rd6848b1a3418485b"/>
   </p:sldMasterIdLst>
   <p:notesMasterIdLst>
-    <p:notesMasterId xmlns:r="http://schemas.openxmlformats.org/officeDocument/2006/relationships" r:id="Redd8267349a54cec"/>
+    <p:notesMasterId xmlns:r="http://schemas.openxmlformats.org/officeDocument/2006/relationships" r:id="R95ed1b50bd95472a"/>
   </p:notesMasterIdLst>
   <p:sldIdLst>
-    <p:sldId xmlns:r="http://schemas.openxmlformats.org/officeDocument/2006/relationships" id="256" r:id="R8c681381c68c4f39"/>
-    <p:sldId xmlns:r="http://schemas.openxmlformats.org/officeDocument/2006/relationships" id="257" r:id="Rc157ad819bab40f9"/>
-    <p:sldId xmlns:r="http://schemas.openxmlformats.org/officeDocument/2006/relationships" id="258" r:id="Re31e715ac5674b9a"/>
-    <p:sldId xmlns:r="http://schemas.openxmlformats.org/officeDocument/2006/relationships" id="259" r:id="Re9ff8df3c5074f40"/>
-    <p:sldId xmlns:r="http://schemas.openxmlformats.org/officeDocument/2006/relationships" id="260" r:id="Rbf44c06b46384152"/>
-    <p:sldId xmlns:r="http://schemas.openxmlformats.org/officeDocument/2006/relationships" id="261" r:id="R2637d025cdb04f55"/>
-    <p:sldId xmlns:r="http://schemas.openxmlformats.org/officeDocument/2006/relationships" id="262" r:id="R8e8e9da18efb4b15"/>
-    <p:sldId xmlns:r="http://schemas.openxmlformats.org/officeDocument/2006/relationships" id="263" r:id="Rc53ae1679f7e457c"/>
-    <p:sldId xmlns:r="http://schemas.openxmlformats.org/officeDocument/2006/relationships" id="264" r:id="R165642470c23418b"/>
+    <p:sldId xmlns:r="http://schemas.openxmlformats.org/officeDocument/2006/relationships" id="256" r:id="Ra32f40b606d54857"/>
+    <p:sldId xmlns:r="http://schemas.openxmlformats.org/officeDocument/2006/relationships" id="257" r:id="R0f4feb8aa8c74e97"/>
+    <p:sldId xmlns:r="http://schemas.openxmlformats.org/officeDocument/2006/relationships" id="258" r:id="R21f5e465f5e943fb"/>
+    <p:sldId xmlns:r="http://schemas.openxmlformats.org/officeDocument/2006/relationships" id="259" r:id="Re84314ce320c4ef2"/>
+    <p:sldId xmlns:r="http://schemas.openxmlformats.org/officeDocument/2006/relationships" id="260" r:id="R9dd879062f344adf"/>
+    <p:sldId xmlns:r="http://schemas.openxmlformats.org/officeDocument/2006/relationships" id="261" r:id="R6fbbb28cad1f4aea"/>
+    <p:sldId xmlns:r="http://schemas.openxmlformats.org/officeDocument/2006/relationships" id="262" r:id="R3181eb4a4be84430"/>
+    <p:sldId xmlns:r="http://schemas.openxmlformats.org/officeDocument/2006/relationships" id="263" r:id="R05a27f34af3c4eed"/>
   </p:sldIdLst>
   <p:sldSz cx="12192000" cy="6858000"/>
   <p:notesSz cx="6858000" cy="9144000"/>
@@ -985,76 +984,6 @@
 </p:notes>
 </file>
 
-<file path=ppt/notesSlides/notesSlide9.xml><?xml version="1.0" encoding="utf-8"?>
-<p:notes xmlns:p="http://schemas.openxmlformats.org/presentationml/2006/main">
-  <p:cSld>
-    <p:spTree>
-      <p:nvGrpSpPr>
-        <p:cNvPr id="1" name=""/>
-        <p:cNvGrpSpPr/>
-        <p:nvPr/>
-      </p:nvGrpSpPr>
-      <p:grpSpPr>
-        <a:xfrm xmlns:a="http://schemas.openxmlformats.org/drawingml/2006/main"/>
-      </p:grpSpPr>
-      <p:sp>
-        <p:nvSpPr>
-          <p:cNvPr id="2" name="Slide Image Placeholder 1"/>
-          <p:cNvSpPr>
-            <a:spLocks xmlns:a="http://schemas.openxmlformats.org/drawingml/2006/main" noGrp="1"/>
-          </p:cNvSpPr>
-          <p:nvPr>
-            <p:ph type="sldImg" idx="0"/>
-          </p:nvPr>
-        </p:nvSpPr>
-        <p:spPr/>
-      </p:sp>
-      <p:sp>
-        <p:nvSpPr>
-          <p:cNvPr id="3" name="Notes Placeholder 2"/>
-          <p:cNvSpPr>
-            <a:spLocks xmlns:a="http://schemas.openxmlformats.org/drawingml/2006/main" noGrp="1"/>
-          </p:cNvSpPr>
-          <p:nvPr>
-            <p:ph type="body" idx="1"/>
-          </p:nvPr>
-        </p:nvSpPr>
-        <p:spPr/>
-        <p:txBody>
-          <a:bodyPr xmlns:a="http://schemas.openxmlformats.org/drawingml/2006/main"/>
-          <a:lstStyle xmlns:a="http://schemas.openxmlformats.org/drawingml/2006/main"/>
-          <a:p xmlns:a="http://schemas.openxmlformats.org/drawingml/2006/main">
-            <a:r>
-              <a:t>Use this slide as the final checklist before submitting. The repository also contains README.md, ETHICAL_REFLECTION.md, RUBRIC_EVIDENCE.md, HOW_THE_CODE_WORKS.md, the application, tests and demo. Team roles: Quinten van Ingen developed the concept and initial idea. Maximilian Lopez implemented and tested the Python application and prepared the technical submission with AI assistance disclosed in the README.</a:t>
-            </a:r>
-          </a:p>
-        </p:txBody>
-      </p:sp>
-      <p:sp>
-        <p:nvSpPr>
-          <p:cNvPr id="4" name="Slide Number Placeholder 3"/>
-          <p:cNvSpPr>
-            <a:spLocks xmlns:a="http://schemas.openxmlformats.org/drawingml/2006/main" noGrp="1"/>
-          </p:cNvSpPr>
-          <p:nvPr>
-            <p:ph type="sldNum" idx="5"/>
-          </p:nvPr>
-        </p:nvSpPr>
-        <p:spPr/>
-        <p:txBody>
-          <a:bodyPr xmlns:a="http://schemas.openxmlformats.org/drawingml/2006/main"/>
-          <a:lstStyle xmlns:a="http://schemas.openxmlformats.org/drawingml/2006/main"/>
-          <a:p xmlns:a="http://schemas.openxmlformats.org/drawingml/2006/main"/>
-        </p:txBody>
-      </p:sp>
-    </p:spTree>
-  </p:cSld>
-  <p:clrMapOvr>
-    <a:masterClrMapping xmlns:a="http://schemas.openxmlformats.org/drawingml/2006/main"/>
-  </p:clrMapOvr>
-</p:notes>
-</file>
-
 <file path=ppt/slideLayouts/slideLayout1.xml><?xml version="1.0" encoding="utf-8"?>
 <p:sldLayout xmlns:p="http://schemas.openxmlformats.org/presentationml/2006/main" type="title">
   <p:cSld name="Title Slide">
@@ -1093,7 +1022,7 @@
   </p:cSld>
   <p:clrMap bg1="lt1" tx1="dk1" bg2="lt2" tx2="dk2" accent1="accent1" accent2="accent2" accent3="accent3" accent4="accent4" accent5="accent5" accent6="accent6" hlink="hlink" folHlink="folHlink"/>
   <p:sldLayoutIdLst>
-    <p:sldLayoutId xmlns:r="http://schemas.openxmlformats.org/officeDocument/2006/relationships" id="2147483649" r:id="Rc55eb636cb6e4f40"/>
+    <p:sldLayoutId xmlns:r="http://schemas.openxmlformats.org/officeDocument/2006/relationships" id="2147483649" r:id="Rca1a56def80546e4"/>
   </p:sldLayoutIdLst>
   <p:txStyles>
     <p:titleStyle>
@@ -1644,7 +1573,7 @@
           <p:cNvPr id="9" name="">
             <a:extLst xmlns:a="http://schemas.openxmlformats.org/drawingml/2006/main">
               <a:ext uri="{FF2B5EF4-FFF2-40B4-BE49-F238E27FC236}">
-                <a16:creationId xmlns:a16="http://schemas.microsoft.com/office/drawing/2014/main" id="{1DD670F4-F2C7-4677-BE54-CC720F2BF573}"/>
+                <a16:creationId xmlns:a16="http://schemas.microsoft.com/office/drawing/2014/main" id="{E6932B2F-10BB-42D0-A1E5-8BBB2A4193C1}"/>
               </a:ext>
             </a:extLst>
           </p:cNvPr>
@@ -1701,7 +1630,7 @@
           <p:cNvPr id="2" name="">
             <a:extLst xmlns:a="http://schemas.openxmlformats.org/drawingml/2006/main">
               <a:ext uri="{FF2B5EF4-FFF2-40B4-BE49-F238E27FC236}">
-                <a16:creationId xmlns:a16="http://schemas.microsoft.com/office/drawing/2014/main" id="{A9050F06-DA6B-450F-8606-CC10E3F18C93}"/>
+                <a16:creationId xmlns:a16="http://schemas.microsoft.com/office/drawing/2014/main" id="{601A4D6F-4D73-42BC-96F2-E2039EE9C4F3}"/>
               </a:ext>
             </a:extLst>
           </p:cNvPr>
@@ -1758,7 +1687,7 @@
           <p:cNvPr id="3" name="">
             <a:extLst xmlns:a="http://schemas.openxmlformats.org/drawingml/2006/main">
               <a:ext uri="{FF2B5EF4-FFF2-40B4-BE49-F238E27FC236}">
-                <a16:creationId xmlns:a16="http://schemas.microsoft.com/office/drawing/2014/main" id="{416DFB40-8D84-4BF9-9730-B9BC048612CF}"/>
+                <a16:creationId xmlns:a16="http://schemas.microsoft.com/office/drawing/2014/main" id="{F3A65757-2425-41EE-BFCE-C90B4DA81C97}"/>
               </a:ext>
             </a:extLst>
           </p:cNvPr>
@@ -1815,7 +1744,7 @@
           <p:cNvPr id="4" name="">
             <a:extLst xmlns:a="http://schemas.openxmlformats.org/drawingml/2006/main">
               <a:ext uri="{FF2B5EF4-FFF2-40B4-BE49-F238E27FC236}">
-                <a16:creationId xmlns:a16="http://schemas.microsoft.com/office/drawing/2014/main" id="{BC9BCA27-9A7F-438B-8583-F3A32550E307}"/>
+                <a16:creationId xmlns:a16="http://schemas.microsoft.com/office/drawing/2014/main" id="{8A9B0FEB-271A-4891-B195-671335AFDB01}"/>
               </a:ext>
             </a:extLst>
           </p:cNvPr>
@@ -1846,7 +1775,7 @@
           <p:cNvPr id="5" name="">
             <a:extLst xmlns:a="http://schemas.openxmlformats.org/drawingml/2006/main">
               <a:ext uri="{FF2B5EF4-FFF2-40B4-BE49-F238E27FC236}">
-                <a16:creationId xmlns:a16="http://schemas.microsoft.com/office/drawing/2014/main" id="{B520AA1C-03C6-44E4-A373-3AF9B7F5AD4C}"/>
+                <a16:creationId xmlns:a16="http://schemas.microsoft.com/office/drawing/2014/main" id="{334EBB9D-A7FF-426A-A8A5-0F5AAD575C49}"/>
               </a:ext>
             </a:extLst>
           </p:cNvPr>
@@ -1903,7 +1832,7 @@
           <p:cNvPr id="6" name="">
             <a:extLst xmlns:a="http://schemas.openxmlformats.org/drawingml/2006/main">
               <a:ext uri="{FF2B5EF4-FFF2-40B4-BE49-F238E27FC236}">
-                <a16:creationId xmlns:a16="http://schemas.microsoft.com/office/drawing/2014/main" id="{EA35C6AA-031D-40F5-A40B-72BC79187074}"/>
+                <a16:creationId xmlns:a16="http://schemas.microsoft.com/office/drawing/2014/main" id="{0A3A41BC-7A5F-41B3-BB0D-C30AFECE714C}"/>
               </a:ext>
             </a:extLst>
           </p:cNvPr>
@@ -1960,7 +1889,7 @@
           <p:cNvPr id="7" name="">
             <a:extLst xmlns:a="http://schemas.openxmlformats.org/drawingml/2006/main">
               <a:ext uri="{FF2B5EF4-FFF2-40B4-BE49-F238E27FC236}">
-                <a16:creationId xmlns:a16="http://schemas.microsoft.com/office/drawing/2014/main" id="{E33FC1A9-86BF-46A6-B9E9-0B1AAC808EF3}"/>
+                <a16:creationId xmlns:a16="http://schemas.microsoft.com/office/drawing/2014/main" id="{06E1C19B-230F-4043-8DD8-39133E8272E4}"/>
               </a:ext>
             </a:extLst>
           </p:cNvPr>
@@ -2017,7 +1946,7 @@
           <p:cNvPr id="8" name="">
             <a:extLst xmlns:a="http://schemas.openxmlformats.org/drawingml/2006/main">
               <a:ext uri="{FF2B5EF4-FFF2-40B4-BE49-F238E27FC236}">
-                <a16:creationId xmlns:a16="http://schemas.microsoft.com/office/drawing/2014/main" id="{612E882A-75B7-40EC-ADB7-20855912F22F}"/>
+                <a16:creationId xmlns:a16="http://schemas.microsoft.com/office/drawing/2014/main" id="{2DC3D7B4-D744-45B8-A1B3-514D625A428B}"/>
               </a:ext>
             </a:extLst>
           </p:cNvPr>
@@ -2072,7 +2001,7 @@
     </p:spTree>
     <p:extLst>
       <p:ext uri="{BB962C8B-B14F-4D97-AF65-F5344CB8AC3E}">
-        <p14:creationId xmlns:p14="http://schemas.microsoft.com/office/powerpoint/2010/main" val="107584915"/>
+        <p14:creationId xmlns:p14="http://schemas.microsoft.com/office/powerpoint/2010/main" val="699486017"/>
       </p:ext>
     </p:extLst>
   </p:cSld>
@@ -2103,7 +2032,7 @@
           <p:cNvPr id="17" name="">
             <a:extLst xmlns:a="http://schemas.openxmlformats.org/drawingml/2006/main">
               <a:ext uri="{FF2B5EF4-FFF2-40B4-BE49-F238E27FC236}">
-                <a16:creationId xmlns:a16="http://schemas.microsoft.com/office/drawing/2014/main" id="{6CF74244-3ECF-4B8F-B122-0EF954FEAAA5}"/>
+                <a16:creationId xmlns:a16="http://schemas.microsoft.com/office/drawing/2014/main" id="{388A7767-7E8E-4D37-8B54-26AB0BDAD600}"/>
               </a:ext>
             </a:extLst>
           </p:cNvPr>
@@ -2160,7 +2089,7 @@
           <p:cNvPr id="2" name="">
             <a:extLst xmlns:a="http://schemas.openxmlformats.org/drawingml/2006/main">
               <a:ext uri="{FF2B5EF4-FFF2-40B4-BE49-F238E27FC236}">
-                <a16:creationId xmlns:a16="http://schemas.microsoft.com/office/drawing/2014/main" id="{CB2D5BBB-326B-4231-B1FE-73C0959F4073}"/>
+                <a16:creationId xmlns:a16="http://schemas.microsoft.com/office/drawing/2014/main" id="{80ABF021-009F-4A96-8C64-8AA7EF89E768}"/>
               </a:ext>
             </a:extLst>
           </p:cNvPr>
@@ -2217,7 +2146,7 @@
           <p:cNvPr id="3" name="">
             <a:extLst xmlns:a="http://schemas.openxmlformats.org/drawingml/2006/main">
               <a:ext uri="{FF2B5EF4-FFF2-40B4-BE49-F238E27FC236}">
-                <a16:creationId xmlns:a16="http://schemas.microsoft.com/office/drawing/2014/main" id="{57A49A7C-9D23-449D-B65C-D571F8A371F4}"/>
+                <a16:creationId xmlns:a16="http://schemas.microsoft.com/office/drawing/2014/main" id="{782EBF28-2BBF-4487-AC10-7309545C7C28}"/>
               </a:ext>
             </a:extLst>
           </p:cNvPr>
@@ -2248,7 +2177,7 @@
           <p:cNvPr id="4" name="">
             <a:extLst xmlns:a="http://schemas.openxmlformats.org/drawingml/2006/main">
               <a:ext uri="{FF2B5EF4-FFF2-40B4-BE49-F238E27FC236}">
-                <a16:creationId xmlns:a16="http://schemas.microsoft.com/office/drawing/2014/main" id="{5BA8875C-14EE-4375-854B-FDF1E99C2B2F}"/>
+                <a16:creationId xmlns:a16="http://schemas.microsoft.com/office/drawing/2014/main" id="{C49D3473-103A-4087-AF75-6DDC3E9A6D05}"/>
               </a:ext>
             </a:extLst>
           </p:cNvPr>
@@ -2305,7 +2234,7 @@
           <p:cNvPr id="5" name="">
             <a:extLst xmlns:a="http://schemas.openxmlformats.org/drawingml/2006/main">
               <a:ext uri="{FF2B5EF4-FFF2-40B4-BE49-F238E27FC236}">
-                <a16:creationId xmlns:a16="http://schemas.microsoft.com/office/drawing/2014/main" id="{12623B63-3779-419C-9BCA-32F5BF60993F}"/>
+                <a16:creationId xmlns:a16="http://schemas.microsoft.com/office/drawing/2014/main" id="{BEF7C4E5-22EA-4AEA-B6AB-E399BC2B5130}"/>
               </a:ext>
             </a:extLst>
           </p:cNvPr>
@@ -2338,7 +2267,7 @@
           <p:cNvPr id="6" name="">
             <a:extLst xmlns:a="http://schemas.openxmlformats.org/drawingml/2006/main">
               <a:ext uri="{FF2B5EF4-FFF2-40B4-BE49-F238E27FC236}">
-                <a16:creationId xmlns:a16="http://schemas.microsoft.com/office/drawing/2014/main" id="{BA0B4919-C46A-48B5-8415-EB16938AB0EB}"/>
+                <a16:creationId xmlns:a16="http://schemas.microsoft.com/office/drawing/2014/main" id="{58FFA5E2-D5AA-4645-8ED3-EC3856F54C61}"/>
               </a:ext>
             </a:extLst>
           </p:cNvPr>
@@ -2395,7 +2324,7 @@
           <p:cNvPr id="7" name="">
             <a:extLst xmlns:a="http://schemas.openxmlformats.org/drawingml/2006/main">
               <a:ext uri="{FF2B5EF4-FFF2-40B4-BE49-F238E27FC236}">
-                <a16:creationId xmlns:a16="http://schemas.microsoft.com/office/drawing/2014/main" id="{E9BF2989-5BB4-43CE-8630-4187364C1B96}"/>
+                <a16:creationId xmlns:a16="http://schemas.microsoft.com/office/drawing/2014/main" id="{7CBC8801-6F7B-4C59-9BA9-CA6CB04141EF}"/>
               </a:ext>
             </a:extLst>
           </p:cNvPr>
@@ -2452,7 +2381,7 @@
           <p:cNvPr id="8" name="">
             <a:extLst xmlns:a="http://schemas.openxmlformats.org/drawingml/2006/main">
               <a:ext uri="{FF2B5EF4-FFF2-40B4-BE49-F238E27FC236}">
-                <a16:creationId xmlns:a16="http://schemas.microsoft.com/office/drawing/2014/main" id="{37DFC2C2-5048-4B20-BE1A-B70E05D72DFC}"/>
+                <a16:creationId xmlns:a16="http://schemas.microsoft.com/office/drawing/2014/main" id="{C7157606-92C9-42E0-8589-DCEE1B6ADC2D}"/>
               </a:ext>
             </a:extLst>
           </p:cNvPr>
@@ -2485,7 +2414,7 @@
           <p:cNvPr id="9" name="">
             <a:extLst xmlns:a="http://schemas.openxmlformats.org/drawingml/2006/main">
               <a:ext uri="{FF2B5EF4-FFF2-40B4-BE49-F238E27FC236}">
-                <a16:creationId xmlns:a16="http://schemas.microsoft.com/office/drawing/2014/main" id="{981C0C8C-0747-4A54-A61C-F71B23BE6D31}"/>
+                <a16:creationId xmlns:a16="http://schemas.microsoft.com/office/drawing/2014/main" id="{18807E81-4CB1-4720-87DA-FBE8AEC4FA49}"/>
               </a:ext>
             </a:extLst>
           </p:cNvPr>
@@ -2542,7 +2471,7 @@
           <p:cNvPr id="10" name="">
             <a:extLst xmlns:a="http://schemas.openxmlformats.org/drawingml/2006/main">
               <a:ext uri="{FF2B5EF4-FFF2-40B4-BE49-F238E27FC236}">
-                <a16:creationId xmlns:a16="http://schemas.microsoft.com/office/drawing/2014/main" id="{567F762C-9167-4AE9-AE27-54F590DD7954}"/>
+                <a16:creationId xmlns:a16="http://schemas.microsoft.com/office/drawing/2014/main" id="{33F832BA-F90C-466D-9C94-0085641A40BD}"/>
               </a:ext>
             </a:extLst>
           </p:cNvPr>
@@ -2599,7 +2528,7 @@
           <p:cNvPr id="11" name="">
             <a:extLst xmlns:a="http://schemas.openxmlformats.org/drawingml/2006/main">
               <a:ext uri="{FF2B5EF4-FFF2-40B4-BE49-F238E27FC236}">
-                <a16:creationId xmlns:a16="http://schemas.microsoft.com/office/drawing/2014/main" id="{73700153-1340-443F-B2F7-63B80A1239EF}"/>
+                <a16:creationId xmlns:a16="http://schemas.microsoft.com/office/drawing/2014/main" id="{67908D5A-19A3-429C-85F3-996BB409960F}"/>
               </a:ext>
             </a:extLst>
           </p:cNvPr>
@@ -2632,7 +2561,7 @@
           <p:cNvPr id="12" name="">
             <a:extLst xmlns:a="http://schemas.openxmlformats.org/drawingml/2006/main">
               <a:ext uri="{FF2B5EF4-FFF2-40B4-BE49-F238E27FC236}">
-                <a16:creationId xmlns:a16="http://schemas.microsoft.com/office/drawing/2014/main" id="{7563E4A5-1E8A-49F9-9E79-FB93A8C81EF0}"/>
+                <a16:creationId xmlns:a16="http://schemas.microsoft.com/office/drawing/2014/main" id="{901413CB-A44C-47A1-BE00-FE30E2526E2E}"/>
               </a:ext>
             </a:extLst>
           </p:cNvPr>
@@ -2689,7 +2618,7 @@
           <p:cNvPr id="13" name="">
             <a:extLst xmlns:a="http://schemas.openxmlformats.org/drawingml/2006/main">
               <a:ext uri="{FF2B5EF4-FFF2-40B4-BE49-F238E27FC236}">
-                <a16:creationId xmlns:a16="http://schemas.microsoft.com/office/drawing/2014/main" id="{FC0228DA-1736-40FF-900C-256CA90EFBFC}"/>
+                <a16:creationId xmlns:a16="http://schemas.microsoft.com/office/drawing/2014/main" id="{CA0FD724-07C5-4A1D-B9CD-FB26533D060C}"/>
               </a:ext>
             </a:extLst>
           </p:cNvPr>
@@ -2746,7 +2675,7 @@
           <p:cNvPr id="14" name="">
             <a:extLst xmlns:a="http://schemas.openxmlformats.org/drawingml/2006/main">
               <a:ext uri="{FF2B5EF4-FFF2-40B4-BE49-F238E27FC236}">
-                <a16:creationId xmlns:a16="http://schemas.microsoft.com/office/drawing/2014/main" id="{B325EFE6-B016-42EF-B739-7B655D3F1C4C}"/>
+                <a16:creationId xmlns:a16="http://schemas.microsoft.com/office/drawing/2014/main" id="{33679F9D-5974-4028-88FF-7CF3D08571A0}"/>
               </a:ext>
             </a:extLst>
           </p:cNvPr>
@@ -2781,7 +2710,7 @@
           <p:cNvPr id="15" name="">
             <a:extLst xmlns:a="http://schemas.openxmlformats.org/drawingml/2006/main">
               <a:ext uri="{FF2B5EF4-FFF2-40B4-BE49-F238E27FC236}">
-                <a16:creationId xmlns:a16="http://schemas.microsoft.com/office/drawing/2014/main" id="{EE1C3DF5-7D1D-4FD5-8A57-A3BD0BC518DC}"/>
+                <a16:creationId xmlns:a16="http://schemas.microsoft.com/office/drawing/2014/main" id="{90F80482-A5AD-4DCC-ACBA-FE1ECB40AEB9}"/>
               </a:ext>
             </a:extLst>
           </p:cNvPr>
@@ -2838,7 +2767,7 @@
           <p:cNvPr id="16" name="">
             <a:extLst xmlns:a="http://schemas.openxmlformats.org/drawingml/2006/main">
               <a:ext uri="{FF2B5EF4-FFF2-40B4-BE49-F238E27FC236}">
-                <a16:creationId xmlns:a16="http://schemas.microsoft.com/office/drawing/2014/main" id="{275B9FB9-0196-44F1-BB52-24546BD10E79}"/>
+                <a16:creationId xmlns:a16="http://schemas.microsoft.com/office/drawing/2014/main" id="{9BD1162F-68D6-4088-B27D-678ADD4D55F6}"/>
               </a:ext>
             </a:extLst>
           </p:cNvPr>
@@ -2893,7 +2822,7 @@
     </p:spTree>
     <p:extLst>
       <p:ext uri="{BB962C8B-B14F-4D97-AF65-F5344CB8AC3E}">
-        <p14:creationId xmlns:p14="http://schemas.microsoft.com/office/powerpoint/2010/main" val="1012409943"/>
+        <p14:creationId xmlns:p14="http://schemas.microsoft.com/office/powerpoint/2010/main" val="1245200976"/>
       </p:ext>
     </p:extLst>
   </p:cSld>
@@ -2924,7 +2853,7 @@
           <p:cNvPr id="15" name="">
             <a:extLst xmlns:a="http://schemas.openxmlformats.org/drawingml/2006/main">
               <a:ext uri="{FF2B5EF4-FFF2-40B4-BE49-F238E27FC236}">
-                <a16:creationId xmlns:a16="http://schemas.microsoft.com/office/drawing/2014/main" id="{EAE6CB9D-965A-4118-AC88-126FF635B426}"/>
+                <a16:creationId xmlns:a16="http://schemas.microsoft.com/office/drawing/2014/main" id="{308FB85B-3AC2-477D-A666-D9765096E600}"/>
               </a:ext>
             </a:extLst>
           </p:cNvPr>
@@ -2981,7 +2910,7 @@
           <p:cNvPr id="2" name="">
             <a:extLst xmlns:a="http://schemas.openxmlformats.org/drawingml/2006/main">
               <a:ext uri="{FF2B5EF4-FFF2-40B4-BE49-F238E27FC236}">
-                <a16:creationId xmlns:a16="http://schemas.microsoft.com/office/drawing/2014/main" id="{CD699C04-47C6-4538-A48B-61B61D353D66}"/>
+                <a16:creationId xmlns:a16="http://schemas.microsoft.com/office/drawing/2014/main" id="{5415736E-716A-443C-8F9C-86209C174D52}"/>
               </a:ext>
             </a:extLst>
           </p:cNvPr>
@@ -3038,7 +2967,7 @@
           <p:cNvPr id="3" name="">
             <a:extLst xmlns:a="http://schemas.openxmlformats.org/drawingml/2006/main">
               <a:ext uri="{FF2B5EF4-FFF2-40B4-BE49-F238E27FC236}">
-                <a16:creationId xmlns:a16="http://schemas.microsoft.com/office/drawing/2014/main" id="{A90F006F-3706-4DA4-8886-6A170013A97B}"/>
+                <a16:creationId xmlns:a16="http://schemas.microsoft.com/office/drawing/2014/main" id="{8CBAAB1D-294C-42D0-9522-CDC20AAE96DF}"/>
               </a:ext>
             </a:extLst>
           </p:cNvPr>
@@ -3069,7 +2998,7 @@
           <p:cNvPr id="4" name="">
             <a:extLst xmlns:a="http://schemas.openxmlformats.org/drawingml/2006/main">
               <a:ext uri="{FF2B5EF4-FFF2-40B4-BE49-F238E27FC236}">
-                <a16:creationId xmlns:a16="http://schemas.microsoft.com/office/drawing/2014/main" id="{5ED17D66-4899-4909-BE29-534E6E192C28}"/>
+                <a16:creationId xmlns:a16="http://schemas.microsoft.com/office/drawing/2014/main" id="{A94220A4-6EAD-4D8C-BEFA-8EC928F2F0CB}"/>
               </a:ext>
             </a:extLst>
           </p:cNvPr>
@@ -3104,7 +3033,7 @@
           <p:cNvPr id="5" name="">
             <a:extLst xmlns:a="http://schemas.openxmlformats.org/drawingml/2006/main">
               <a:ext uri="{FF2B5EF4-FFF2-40B4-BE49-F238E27FC236}">
-                <a16:creationId xmlns:a16="http://schemas.microsoft.com/office/drawing/2014/main" id="{F8664D99-E7DA-4CE4-8AC2-0BF3F1248F96}"/>
+                <a16:creationId xmlns:a16="http://schemas.microsoft.com/office/drawing/2014/main" id="{0EF8700E-ABBA-4298-BDA0-55A2219F1D82}"/>
               </a:ext>
             </a:extLst>
           </p:cNvPr>
@@ -3161,7 +3090,7 @@
           <p:cNvPr id="6" name="">
             <a:extLst xmlns:a="http://schemas.openxmlformats.org/drawingml/2006/main">
               <a:ext uri="{FF2B5EF4-FFF2-40B4-BE49-F238E27FC236}">
-                <a16:creationId xmlns:a16="http://schemas.microsoft.com/office/drawing/2014/main" id="{736E00E3-ACC6-4EBE-9E89-D21A43AEAB3A}"/>
+                <a16:creationId xmlns:a16="http://schemas.microsoft.com/office/drawing/2014/main" id="{C24AC537-7BB4-44F6-B988-CB7EFA3A21B7}"/>
               </a:ext>
             </a:extLst>
           </p:cNvPr>
@@ -3218,7 +3147,7 @@
           <p:cNvPr id="7" name="">
             <a:extLst xmlns:a="http://schemas.openxmlformats.org/drawingml/2006/main">
               <a:ext uri="{FF2B5EF4-FFF2-40B4-BE49-F238E27FC236}">
-                <a16:creationId xmlns:a16="http://schemas.microsoft.com/office/drawing/2014/main" id="{1520C830-46AC-4F58-B1AF-7636C04A9A20}"/>
+                <a16:creationId xmlns:a16="http://schemas.microsoft.com/office/drawing/2014/main" id="{1CB0F1B8-8643-456F-95A5-24D07C6F385A}"/>
               </a:ext>
             </a:extLst>
           </p:cNvPr>
@@ -3275,7 +3204,7 @@
           <p:cNvPr id="8" name="">
             <a:extLst xmlns:a="http://schemas.openxmlformats.org/drawingml/2006/main">
               <a:ext uri="{FF2B5EF4-FFF2-40B4-BE49-F238E27FC236}">
-                <a16:creationId xmlns:a16="http://schemas.microsoft.com/office/drawing/2014/main" id="{9D27E8E5-0C23-4A26-95E1-5F1C9995E455}"/>
+                <a16:creationId xmlns:a16="http://schemas.microsoft.com/office/drawing/2014/main" id="{E925E9CA-BD1B-4B8F-B8D1-A8D241E6B6CB}"/>
               </a:ext>
             </a:extLst>
           </p:cNvPr>
@@ -3378,7 +3307,7 @@
           <p:cNvPr id="9" name="">
             <a:extLst xmlns:a="http://schemas.openxmlformats.org/drawingml/2006/main">
               <a:ext uri="{FF2B5EF4-FFF2-40B4-BE49-F238E27FC236}">
-                <a16:creationId xmlns:a16="http://schemas.microsoft.com/office/drawing/2014/main" id="{3981F7C9-01D8-4E81-BC75-B6B1F9A04223}"/>
+                <a16:creationId xmlns:a16="http://schemas.microsoft.com/office/drawing/2014/main" id="{955A5482-77F2-43D6-9C9D-043D2EB1301E}"/>
               </a:ext>
             </a:extLst>
           </p:cNvPr>
@@ -3435,7 +3364,7 @@
           <p:cNvPr id="10" name="">
             <a:extLst xmlns:a="http://schemas.openxmlformats.org/drawingml/2006/main">
               <a:ext uri="{FF2B5EF4-FFF2-40B4-BE49-F238E27FC236}">
-                <a16:creationId xmlns:a16="http://schemas.microsoft.com/office/drawing/2014/main" id="{364A34D1-EC80-4F47-AD30-7A1175E68F62}"/>
+                <a16:creationId xmlns:a16="http://schemas.microsoft.com/office/drawing/2014/main" id="{CBFE61D0-44FB-40E8-8F78-9AA13C8F659A}"/>
               </a:ext>
             </a:extLst>
           </p:cNvPr>
@@ -3470,7 +3399,7 @@
           <p:cNvPr id="11" name="">
             <a:extLst xmlns:a="http://schemas.openxmlformats.org/drawingml/2006/main">
               <a:ext uri="{FF2B5EF4-FFF2-40B4-BE49-F238E27FC236}">
-                <a16:creationId xmlns:a16="http://schemas.microsoft.com/office/drawing/2014/main" id="{DC9EE827-CF6C-40AE-A47D-FC1BE3C60B33}"/>
+                <a16:creationId xmlns:a16="http://schemas.microsoft.com/office/drawing/2014/main" id="{F04A770B-82C8-409B-9BBF-DCDAB3101567}"/>
               </a:ext>
             </a:extLst>
           </p:cNvPr>
@@ -3527,7 +3456,7 @@
           <p:cNvPr id="12" name="">
             <a:extLst xmlns:a="http://schemas.openxmlformats.org/drawingml/2006/main">
               <a:ext uri="{FF2B5EF4-FFF2-40B4-BE49-F238E27FC236}">
-                <a16:creationId xmlns:a16="http://schemas.microsoft.com/office/drawing/2014/main" id="{83650A5A-407F-4D0E-A09A-5A261CA19F0A}"/>
+                <a16:creationId xmlns:a16="http://schemas.microsoft.com/office/drawing/2014/main" id="{A8E44AE9-ACF3-456C-8C0B-044993AAB536}"/>
               </a:ext>
             </a:extLst>
           </p:cNvPr>
@@ -3676,7 +3605,7 @@
           <p:cNvPr id="13" name="">
             <a:extLst xmlns:a="http://schemas.openxmlformats.org/drawingml/2006/main">
               <a:ext uri="{FF2B5EF4-FFF2-40B4-BE49-F238E27FC236}">
-                <a16:creationId xmlns:a16="http://schemas.microsoft.com/office/drawing/2014/main" id="{DBDB2EED-81A7-4A58-BF5A-3E9715C66757}"/>
+                <a16:creationId xmlns:a16="http://schemas.microsoft.com/office/drawing/2014/main" id="{922841B1-DFFE-42BF-A10F-B920E46906A3}"/>
               </a:ext>
             </a:extLst>
           </p:cNvPr>
@@ -3733,7 +3662,7 @@
           <p:cNvPr id="14" name="">
             <a:extLst xmlns:a="http://schemas.openxmlformats.org/drawingml/2006/main">
               <a:ext uri="{FF2B5EF4-FFF2-40B4-BE49-F238E27FC236}">
-                <a16:creationId xmlns:a16="http://schemas.microsoft.com/office/drawing/2014/main" id="{FDF2377E-E2A7-4728-A5D2-3433A3599D69}"/>
+                <a16:creationId xmlns:a16="http://schemas.microsoft.com/office/drawing/2014/main" id="{21219C4D-9143-404E-8363-7CA409315C24}"/>
               </a:ext>
             </a:extLst>
           </p:cNvPr>
@@ -3788,7 +3717,7 @@
     </p:spTree>
     <p:extLst>
       <p:ext uri="{BB962C8B-B14F-4D97-AF65-F5344CB8AC3E}">
-        <p14:creationId xmlns:p14="http://schemas.microsoft.com/office/powerpoint/2010/main" val="969296903"/>
+        <p14:creationId xmlns:p14="http://schemas.microsoft.com/office/powerpoint/2010/main" val="679383959"/>
       </p:ext>
     </p:extLst>
   </p:cSld>
@@ -3819,7 +3748,7 @@
           <p:cNvPr id="16" name="">
             <a:extLst xmlns:a="http://schemas.openxmlformats.org/drawingml/2006/main">
               <a:ext uri="{FF2B5EF4-FFF2-40B4-BE49-F238E27FC236}">
-                <a16:creationId xmlns:a16="http://schemas.microsoft.com/office/drawing/2014/main" id="{B42D8148-6B22-4E20-B595-36D71C471D2A}"/>
+                <a16:creationId xmlns:a16="http://schemas.microsoft.com/office/drawing/2014/main" id="{862C2C37-D85E-415D-B809-73CDAF045A6A}"/>
               </a:ext>
             </a:extLst>
           </p:cNvPr>
@@ -3876,7 +3805,7 @@
           <p:cNvPr id="2" name="">
             <a:extLst xmlns:a="http://schemas.openxmlformats.org/drawingml/2006/main">
               <a:ext uri="{FF2B5EF4-FFF2-40B4-BE49-F238E27FC236}">
-                <a16:creationId xmlns:a16="http://schemas.microsoft.com/office/drawing/2014/main" id="{6098C529-FD26-4F0A-A7CF-2BCC0660E85F}"/>
+                <a16:creationId xmlns:a16="http://schemas.microsoft.com/office/drawing/2014/main" id="{6FE95FA4-E363-4BAC-883D-A1FD528DE832}"/>
               </a:ext>
             </a:extLst>
           </p:cNvPr>
@@ -3933,7 +3862,7 @@
           <p:cNvPr id="3" name="">
             <a:extLst xmlns:a="http://schemas.openxmlformats.org/drawingml/2006/main">
               <a:ext uri="{FF2B5EF4-FFF2-40B4-BE49-F238E27FC236}">
-                <a16:creationId xmlns:a16="http://schemas.microsoft.com/office/drawing/2014/main" id="{6845D6C1-F31E-4C94-B516-08A4FA1E6FCB}"/>
+                <a16:creationId xmlns:a16="http://schemas.microsoft.com/office/drawing/2014/main" id="{CFCC4C29-0DCA-4688-8F1A-05BE1CED9242}"/>
               </a:ext>
             </a:extLst>
           </p:cNvPr>
@@ -3968,7 +3897,7 @@
           <p:nvPr/>
         </p:nvPicPr>
         <p:blipFill>
-          <a:blip xmlns:r="http://schemas.openxmlformats.org/officeDocument/2006/relationships" xmlns:a="http://schemas.openxmlformats.org/drawingml/2006/main" r:embed="R2877c162346c4a22"/>
+          <a:blip xmlns:r="http://schemas.openxmlformats.org/officeDocument/2006/relationships" xmlns:a="http://schemas.openxmlformats.org/drawingml/2006/main" r:embed="Rc8be199bca244eb7"/>
           <a:srcRect xmlns:a="http://schemas.openxmlformats.org/drawingml/2006/main" l="0" t="3659" r="0" b="3659"/>
           <a:stretch xmlns:a="http://schemas.openxmlformats.org/drawingml/2006/main">
             <a:fillRect l="0" t="0" r="0" b="0"/>
@@ -3991,7 +3920,7 @@
           <p:cNvPr id="5" name="">
             <a:extLst xmlns:a="http://schemas.openxmlformats.org/drawingml/2006/main">
               <a:ext uri="{FF2B5EF4-FFF2-40B4-BE49-F238E27FC236}">
-                <a16:creationId xmlns:a16="http://schemas.microsoft.com/office/drawing/2014/main" id="{C11489DB-159A-4CF4-9E35-8F9C40CC5793}"/>
+                <a16:creationId xmlns:a16="http://schemas.microsoft.com/office/drawing/2014/main" id="{70A1CED1-4BC2-4825-8B26-411FD6A91C4B}"/>
               </a:ext>
             </a:extLst>
           </p:cNvPr>
@@ -4024,7 +3953,7 @@
           <p:cNvPr id="6" name="">
             <a:extLst xmlns:a="http://schemas.openxmlformats.org/drawingml/2006/main">
               <a:ext uri="{FF2B5EF4-FFF2-40B4-BE49-F238E27FC236}">
-                <a16:creationId xmlns:a16="http://schemas.microsoft.com/office/drawing/2014/main" id="{41BA4C72-E09B-43B2-91BA-80D349BFEC84}"/>
+                <a16:creationId xmlns:a16="http://schemas.microsoft.com/office/drawing/2014/main" id="{565A2CF0-88B5-4487-BE75-77E21227F1EA}"/>
               </a:ext>
             </a:extLst>
           </p:cNvPr>
@@ -4081,7 +4010,7 @@
           <p:cNvPr id="7" name="">
             <a:extLst xmlns:a="http://schemas.openxmlformats.org/drawingml/2006/main">
               <a:ext uri="{FF2B5EF4-FFF2-40B4-BE49-F238E27FC236}">
-                <a16:creationId xmlns:a16="http://schemas.microsoft.com/office/drawing/2014/main" id="{97E077B6-5FE0-41B7-BB8A-BC2F89E14D84}"/>
+                <a16:creationId xmlns:a16="http://schemas.microsoft.com/office/drawing/2014/main" id="{7B07A512-3D84-4617-982B-2BE8D81BCB39}"/>
               </a:ext>
             </a:extLst>
           </p:cNvPr>
@@ -4138,7 +4067,7 @@
           <p:cNvPr id="8" name="">
             <a:extLst xmlns:a="http://schemas.openxmlformats.org/drawingml/2006/main">
               <a:ext uri="{FF2B5EF4-FFF2-40B4-BE49-F238E27FC236}">
-                <a16:creationId xmlns:a16="http://schemas.microsoft.com/office/drawing/2014/main" id="{CCFEB788-335A-4FB0-BAC4-AACB9BDA55B2}"/>
+                <a16:creationId xmlns:a16="http://schemas.microsoft.com/office/drawing/2014/main" id="{E37E9349-A2DE-4E75-B2C5-6AF3954F99A8}"/>
               </a:ext>
             </a:extLst>
           </p:cNvPr>
@@ -4195,7 +4124,7 @@
           <p:cNvPr id="9" name="">
             <a:extLst xmlns:a="http://schemas.openxmlformats.org/drawingml/2006/main">
               <a:ext uri="{FF2B5EF4-FFF2-40B4-BE49-F238E27FC236}">
-                <a16:creationId xmlns:a16="http://schemas.microsoft.com/office/drawing/2014/main" id="{BAC28DF0-0867-402F-BB7C-033ACB74A163}"/>
+                <a16:creationId xmlns:a16="http://schemas.microsoft.com/office/drawing/2014/main" id="{E0DDE6DF-8930-4B6F-982E-6E270E7E842D}"/>
               </a:ext>
             </a:extLst>
           </p:cNvPr>
@@ -4252,7 +4181,7 @@
           <p:cNvPr id="10" name="">
             <a:extLst xmlns:a="http://schemas.openxmlformats.org/drawingml/2006/main">
               <a:ext uri="{FF2B5EF4-FFF2-40B4-BE49-F238E27FC236}">
-                <a16:creationId xmlns:a16="http://schemas.microsoft.com/office/drawing/2014/main" id="{CEC61FAD-3B23-4B1B-ABF1-189C41DFC342}"/>
+                <a16:creationId xmlns:a16="http://schemas.microsoft.com/office/drawing/2014/main" id="{88F7CC36-5D11-4400-BB51-CDAC6F3F8A11}"/>
               </a:ext>
             </a:extLst>
           </p:cNvPr>
@@ -4309,7 +4238,7 @@
           <p:cNvPr id="11" name="">
             <a:extLst xmlns:a="http://schemas.openxmlformats.org/drawingml/2006/main">
               <a:ext uri="{FF2B5EF4-FFF2-40B4-BE49-F238E27FC236}">
-                <a16:creationId xmlns:a16="http://schemas.microsoft.com/office/drawing/2014/main" id="{3FFCF6D2-B7EF-4F37-B448-C9BEDD28831C}"/>
+                <a16:creationId xmlns:a16="http://schemas.microsoft.com/office/drawing/2014/main" id="{046FB030-C132-438E-9339-CB24C119980C}"/>
               </a:ext>
             </a:extLst>
           </p:cNvPr>
@@ -4366,7 +4295,7 @@
           <p:cNvPr id="12" name="">
             <a:extLst xmlns:a="http://schemas.openxmlformats.org/drawingml/2006/main">
               <a:ext uri="{FF2B5EF4-FFF2-40B4-BE49-F238E27FC236}">
-                <a16:creationId xmlns:a16="http://schemas.microsoft.com/office/drawing/2014/main" id="{050991AB-0B8C-4934-9F0D-FE07DE59C3F5}"/>
+                <a16:creationId xmlns:a16="http://schemas.microsoft.com/office/drawing/2014/main" id="{7210E6AE-9F60-4F03-A66A-5B8EAE7FDC8D}"/>
               </a:ext>
             </a:extLst>
           </p:cNvPr>
@@ -4423,7 +4352,7 @@
           <p:cNvPr id="13" name="">
             <a:extLst xmlns:a="http://schemas.openxmlformats.org/drawingml/2006/main">
               <a:ext uri="{FF2B5EF4-FFF2-40B4-BE49-F238E27FC236}">
-                <a16:creationId xmlns:a16="http://schemas.microsoft.com/office/drawing/2014/main" id="{1A35D4C2-8AC2-4028-AE3A-C20A238EF3D4}"/>
+                <a16:creationId xmlns:a16="http://schemas.microsoft.com/office/drawing/2014/main" id="{30B6256E-CB45-4D28-82EA-CF0D10DAF8DB}"/>
               </a:ext>
             </a:extLst>
           </p:cNvPr>
@@ -4480,7 +4409,7 @@
           <p:cNvPr id="14" name="">
             <a:extLst xmlns:a="http://schemas.openxmlformats.org/drawingml/2006/main">
               <a:ext uri="{FF2B5EF4-FFF2-40B4-BE49-F238E27FC236}">
-                <a16:creationId xmlns:a16="http://schemas.microsoft.com/office/drawing/2014/main" id="{6943C01E-E39C-4FCB-9FB1-1404D57D69F6}"/>
+                <a16:creationId xmlns:a16="http://schemas.microsoft.com/office/drawing/2014/main" id="{CC875E46-8597-48AF-9B92-AAE1714B5436}"/>
               </a:ext>
             </a:extLst>
           </p:cNvPr>
@@ -4537,7 +4466,7 @@
           <p:cNvPr id="15" name="">
             <a:extLst xmlns:a="http://schemas.openxmlformats.org/drawingml/2006/main">
               <a:ext uri="{FF2B5EF4-FFF2-40B4-BE49-F238E27FC236}">
-                <a16:creationId xmlns:a16="http://schemas.microsoft.com/office/drawing/2014/main" id="{7A8A1F7F-C1EB-4AC9-B10C-360E36C5B069}"/>
+                <a16:creationId xmlns:a16="http://schemas.microsoft.com/office/drawing/2014/main" id="{239D052F-A5AF-41A8-83E1-F8653EF7F11D}"/>
               </a:ext>
             </a:extLst>
           </p:cNvPr>
@@ -4592,7 +4521,7 @@
     </p:spTree>
     <p:extLst>
       <p:ext uri="{BB962C8B-B14F-4D97-AF65-F5344CB8AC3E}">
-        <p14:creationId xmlns:p14="http://schemas.microsoft.com/office/powerpoint/2010/main" val="1508766648"/>
+        <p14:creationId xmlns:p14="http://schemas.microsoft.com/office/powerpoint/2010/main" val="953533108"/>
       </p:ext>
     </p:extLst>
   </p:cSld>
@@ -4623,7 +4552,7 @@
           <p:cNvPr id="19" name="">
             <a:extLst xmlns:a="http://schemas.openxmlformats.org/drawingml/2006/main">
               <a:ext uri="{FF2B5EF4-FFF2-40B4-BE49-F238E27FC236}">
-                <a16:creationId xmlns:a16="http://schemas.microsoft.com/office/drawing/2014/main" id="{A3BF1DCC-9374-4ED4-A7AB-F299E81DD7FB}"/>
+                <a16:creationId xmlns:a16="http://schemas.microsoft.com/office/drawing/2014/main" id="{6C4D806D-830B-4AAC-B8BD-E3EDFABA7FCA}"/>
               </a:ext>
             </a:extLst>
           </p:cNvPr>
@@ -4680,7 +4609,7 @@
           <p:cNvPr id="2" name="">
             <a:extLst xmlns:a="http://schemas.openxmlformats.org/drawingml/2006/main">
               <a:ext uri="{FF2B5EF4-FFF2-40B4-BE49-F238E27FC236}">
-                <a16:creationId xmlns:a16="http://schemas.microsoft.com/office/drawing/2014/main" id="{BA1EC092-A676-46EB-8A66-F20BC28AC78E}"/>
+                <a16:creationId xmlns:a16="http://schemas.microsoft.com/office/drawing/2014/main" id="{8AF42746-832D-4FFB-B39D-F281AF47CD11}"/>
               </a:ext>
             </a:extLst>
           </p:cNvPr>
@@ -4737,7 +4666,7 @@
           <p:cNvPr id="3" name="">
             <a:extLst xmlns:a="http://schemas.openxmlformats.org/drawingml/2006/main">
               <a:ext uri="{FF2B5EF4-FFF2-40B4-BE49-F238E27FC236}">
-                <a16:creationId xmlns:a16="http://schemas.microsoft.com/office/drawing/2014/main" id="{57207AAA-2801-4C2F-B011-94AA075B953E}"/>
+                <a16:creationId xmlns:a16="http://schemas.microsoft.com/office/drawing/2014/main" id="{179491D9-37FB-4774-9C08-F9775E18B4CD}"/>
               </a:ext>
             </a:extLst>
           </p:cNvPr>
@@ -4768,7 +4697,7 @@
           <p:cNvPr id="4" name="">
             <a:extLst xmlns:a="http://schemas.openxmlformats.org/drawingml/2006/main">
               <a:ext uri="{FF2B5EF4-FFF2-40B4-BE49-F238E27FC236}">
-                <a16:creationId xmlns:a16="http://schemas.microsoft.com/office/drawing/2014/main" id="{F653A5E2-F14E-4F02-92CE-D738D84EB90D}"/>
+                <a16:creationId xmlns:a16="http://schemas.microsoft.com/office/drawing/2014/main" id="{F2E53206-FED6-42DA-AC5B-CD19DEDFA68A}"/>
               </a:ext>
             </a:extLst>
           </p:cNvPr>
@@ -4825,7 +4754,7 @@
           <p:cNvPr id="5" name="">
             <a:extLst xmlns:a="http://schemas.openxmlformats.org/drawingml/2006/main">
               <a:ext uri="{FF2B5EF4-FFF2-40B4-BE49-F238E27FC236}">
-                <a16:creationId xmlns:a16="http://schemas.microsoft.com/office/drawing/2014/main" id="{DFB85A2D-1976-460B-A9AE-93918ABCD9A5}"/>
+                <a16:creationId xmlns:a16="http://schemas.microsoft.com/office/drawing/2014/main" id="{02101BEF-9FC5-46DB-B753-ADE68C58B866}"/>
               </a:ext>
             </a:extLst>
           </p:cNvPr>
@@ -4858,7 +4787,7 @@
           <p:cNvPr id="6" name="">
             <a:extLst xmlns:a="http://schemas.openxmlformats.org/drawingml/2006/main">
               <a:ext uri="{FF2B5EF4-FFF2-40B4-BE49-F238E27FC236}">
-                <a16:creationId xmlns:a16="http://schemas.microsoft.com/office/drawing/2014/main" id="{F610F65B-59AC-403A-A652-1CD8B3BD11D3}"/>
+                <a16:creationId xmlns:a16="http://schemas.microsoft.com/office/drawing/2014/main" id="{D6443EAE-218B-444C-BF16-AA30B73DF905}"/>
               </a:ext>
             </a:extLst>
           </p:cNvPr>
@@ -5270,7 +5199,7 @@
           <p:cNvPr id="7" name="">
             <a:extLst xmlns:a="http://schemas.openxmlformats.org/drawingml/2006/main">
               <a:ext uri="{FF2B5EF4-FFF2-40B4-BE49-F238E27FC236}">
-                <a16:creationId xmlns:a16="http://schemas.microsoft.com/office/drawing/2014/main" id="{D5C1EE39-389E-44AA-AF31-1143DDEBC107}"/>
+                <a16:creationId xmlns:a16="http://schemas.microsoft.com/office/drawing/2014/main" id="{28FA783C-8429-4F05-8620-A6818554404C}"/>
               </a:ext>
             </a:extLst>
           </p:cNvPr>
@@ -5327,7 +5256,7 @@
           <p:cNvPr id="8" name="">
             <a:extLst xmlns:a="http://schemas.openxmlformats.org/drawingml/2006/main">
               <a:ext uri="{FF2B5EF4-FFF2-40B4-BE49-F238E27FC236}">
-                <a16:creationId xmlns:a16="http://schemas.microsoft.com/office/drawing/2014/main" id="{F44F5B4F-2E8D-40C1-B337-D2DCD5B13D28}"/>
+                <a16:creationId xmlns:a16="http://schemas.microsoft.com/office/drawing/2014/main" id="{D0A2DD86-D6C9-492B-B73D-D0EC3FAE7D8B}"/>
               </a:ext>
             </a:extLst>
           </p:cNvPr>
@@ -5384,7 +5313,7 @@
           <p:cNvPr id="9" name="">
             <a:extLst xmlns:a="http://schemas.openxmlformats.org/drawingml/2006/main">
               <a:ext uri="{FF2B5EF4-FFF2-40B4-BE49-F238E27FC236}">
-                <a16:creationId xmlns:a16="http://schemas.microsoft.com/office/drawing/2014/main" id="{F6A01DD8-2C51-423D-8656-AEF0380AD113}"/>
+                <a16:creationId xmlns:a16="http://schemas.microsoft.com/office/drawing/2014/main" id="{81FB360C-6BE3-4F14-A60A-AB1B9C3C4142}"/>
               </a:ext>
             </a:extLst>
           </p:cNvPr>
@@ -5441,7 +5370,7 @@
           <p:cNvPr id="10" name="">
             <a:extLst xmlns:a="http://schemas.openxmlformats.org/drawingml/2006/main">
               <a:ext uri="{FF2B5EF4-FFF2-40B4-BE49-F238E27FC236}">
-                <a16:creationId xmlns:a16="http://schemas.microsoft.com/office/drawing/2014/main" id="{5C0D84ED-4CFA-410B-BD67-5268D12C29C1}"/>
+                <a16:creationId xmlns:a16="http://schemas.microsoft.com/office/drawing/2014/main" id="{0BF1908A-A157-49C4-9D7B-0FA731BE1B87}"/>
               </a:ext>
             </a:extLst>
           </p:cNvPr>
@@ -5498,7 +5427,7 @@
           <p:cNvPr id="11" name="">
             <a:extLst xmlns:a="http://schemas.openxmlformats.org/drawingml/2006/main">
               <a:ext uri="{FF2B5EF4-FFF2-40B4-BE49-F238E27FC236}">
-                <a16:creationId xmlns:a16="http://schemas.microsoft.com/office/drawing/2014/main" id="{8C4B83B8-61FF-44A9-AF21-07C11377E059}"/>
+                <a16:creationId xmlns:a16="http://schemas.microsoft.com/office/drawing/2014/main" id="{917F36ED-3042-4E77-B577-6954362E1CE8}"/>
               </a:ext>
             </a:extLst>
           </p:cNvPr>
@@ -5555,7 +5484,7 @@
           <p:cNvPr id="12" name="">
             <a:extLst xmlns:a="http://schemas.openxmlformats.org/drawingml/2006/main">
               <a:ext uri="{FF2B5EF4-FFF2-40B4-BE49-F238E27FC236}">
-                <a16:creationId xmlns:a16="http://schemas.microsoft.com/office/drawing/2014/main" id="{54A05AC9-F36E-4E0F-98D0-128E566561C7}"/>
+                <a16:creationId xmlns:a16="http://schemas.microsoft.com/office/drawing/2014/main" id="{12D43BC2-C52F-47C2-B48C-113783E58996}"/>
               </a:ext>
             </a:extLst>
           </p:cNvPr>
@@ -5612,7 +5541,7 @@
           <p:cNvPr id="13" name="">
             <a:extLst xmlns:a="http://schemas.openxmlformats.org/drawingml/2006/main">
               <a:ext uri="{FF2B5EF4-FFF2-40B4-BE49-F238E27FC236}">
-                <a16:creationId xmlns:a16="http://schemas.microsoft.com/office/drawing/2014/main" id="{B5C46EAD-8980-46C3-8C0F-5353A33BF1DA}"/>
+                <a16:creationId xmlns:a16="http://schemas.microsoft.com/office/drawing/2014/main" id="{CD42D825-7412-4F7F-A3D9-0797233E8D7E}"/>
               </a:ext>
             </a:extLst>
           </p:cNvPr>
@@ -5669,7 +5598,7 @@
           <p:cNvPr id="14" name="">
             <a:extLst xmlns:a="http://schemas.openxmlformats.org/drawingml/2006/main">
               <a:ext uri="{FF2B5EF4-FFF2-40B4-BE49-F238E27FC236}">
-                <a16:creationId xmlns:a16="http://schemas.microsoft.com/office/drawing/2014/main" id="{A3FC5231-3812-4643-9952-3A55A73C0024}"/>
+                <a16:creationId xmlns:a16="http://schemas.microsoft.com/office/drawing/2014/main" id="{E7A579EA-8719-4036-B27C-ADDFF83FF5FA}"/>
               </a:ext>
             </a:extLst>
           </p:cNvPr>
@@ -5726,7 +5655,7 @@
           <p:cNvPr id="15" name="">
             <a:extLst xmlns:a="http://schemas.openxmlformats.org/drawingml/2006/main">
               <a:ext uri="{FF2B5EF4-FFF2-40B4-BE49-F238E27FC236}">
-                <a16:creationId xmlns:a16="http://schemas.microsoft.com/office/drawing/2014/main" id="{F353CEFF-BB05-476C-8BA4-206816E85956}"/>
+                <a16:creationId xmlns:a16="http://schemas.microsoft.com/office/drawing/2014/main" id="{3356C2CB-E7D4-4193-8AD3-A694466B6C13}"/>
               </a:ext>
             </a:extLst>
           </p:cNvPr>
@@ -5783,7 +5712,7 @@
           <p:cNvPr id="16" name="">
             <a:extLst xmlns:a="http://schemas.openxmlformats.org/drawingml/2006/main">
               <a:ext uri="{FF2B5EF4-FFF2-40B4-BE49-F238E27FC236}">
-                <a16:creationId xmlns:a16="http://schemas.microsoft.com/office/drawing/2014/main" id="{1F32B398-C105-41E1-A1CE-F9CC59239DE0}"/>
+                <a16:creationId xmlns:a16="http://schemas.microsoft.com/office/drawing/2014/main" id="{AB0E49A4-4C26-4D50-9B17-CB76FFC21172}"/>
               </a:ext>
             </a:extLst>
           </p:cNvPr>
@@ -5840,7 +5769,7 @@
           <p:cNvPr id="17" name="">
             <a:extLst xmlns:a="http://schemas.openxmlformats.org/drawingml/2006/main">
               <a:ext uri="{FF2B5EF4-FFF2-40B4-BE49-F238E27FC236}">
-                <a16:creationId xmlns:a16="http://schemas.microsoft.com/office/drawing/2014/main" id="{6B5B4858-14C1-4996-9297-6C859A83DCA4}"/>
+                <a16:creationId xmlns:a16="http://schemas.microsoft.com/office/drawing/2014/main" id="{CEF5BF50-041E-453F-81E7-5065D0D31E69}"/>
               </a:ext>
             </a:extLst>
           </p:cNvPr>
@@ -5897,7 +5826,7 @@
           <p:cNvPr id="18" name="">
             <a:extLst xmlns:a="http://schemas.openxmlformats.org/drawingml/2006/main">
               <a:ext uri="{FF2B5EF4-FFF2-40B4-BE49-F238E27FC236}">
-                <a16:creationId xmlns:a16="http://schemas.microsoft.com/office/drawing/2014/main" id="{2B4F61AF-F27F-4D87-93E2-06841E232F96}"/>
+                <a16:creationId xmlns:a16="http://schemas.microsoft.com/office/drawing/2014/main" id="{B08DF3CF-834C-43BF-AC85-6E0256B3857A}"/>
               </a:ext>
             </a:extLst>
           </p:cNvPr>
@@ -5952,7 +5881,7 @@
     </p:spTree>
     <p:extLst>
       <p:ext uri="{BB962C8B-B14F-4D97-AF65-F5344CB8AC3E}">
-        <p14:creationId xmlns:p14="http://schemas.microsoft.com/office/powerpoint/2010/main" val="1839427354"/>
+        <p14:creationId xmlns:p14="http://schemas.microsoft.com/office/powerpoint/2010/main" val="680481391"/>
       </p:ext>
     </p:extLst>
   </p:cSld>
@@ -5983,7 +5912,7 @@
           <p:cNvPr id="41" name="">
             <a:extLst xmlns:a="http://schemas.openxmlformats.org/drawingml/2006/main">
               <a:ext uri="{FF2B5EF4-FFF2-40B4-BE49-F238E27FC236}">
-                <a16:creationId xmlns:a16="http://schemas.microsoft.com/office/drawing/2014/main" id="{6E57E61F-0796-460A-97E2-A52F925035D8}"/>
+                <a16:creationId xmlns:a16="http://schemas.microsoft.com/office/drawing/2014/main" id="{66CA8C7A-90A7-4B16-8639-93F4B6BA31C8}"/>
               </a:ext>
             </a:extLst>
           </p:cNvPr>
@@ -6040,7 +5969,7 @@
           <p:cNvPr id="2" name="">
             <a:extLst xmlns:a="http://schemas.openxmlformats.org/drawingml/2006/main">
               <a:ext uri="{FF2B5EF4-FFF2-40B4-BE49-F238E27FC236}">
-                <a16:creationId xmlns:a16="http://schemas.microsoft.com/office/drawing/2014/main" id="{D568841D-3B7C-4E7E-8D39-B4E2E6C55098}"/>
+                <a16:creationId xmlns:a16="http://schemas.microsoft.com/office/drawing/2014/main" id="{0A41649B-D144-4EB2-AA34-C71C86ECADBC}"/>
               </a:ext>
             </a:extLst>
           </p:cNvPr>
@@ -6097,7 +6026,7 @@
           <p:cNvPr id="3" name="">
             <a:extLst xmlns:a="http://schemas.openxmlformats.org/drawingml/2006/main">
               <a:ext uri="{FF2B5EF4-FFF2-40B4-BE49-F238E27FC236}">
-                <a16:creationId xmlns:a16="http://schemas.microsoft.com/office/drawing/2014/main" id="{41A43A5C-6127-489A-BD5E-2D83E283E7BC}"/>
+                <a16:creationId xmlns:a16="http://schemas.microsoft.com/office/drawing/2014/main" id="{C6913901-C2A1-4EC6-BDA1-4E1F77597B88}"/>
               </a:ext>
             </a:extLst>
           </p:cNvPr>
@@ -6128,7 +6057,7 @@
           <p:cNvPr id="4" name="">
             <a:extLst xmlns:a="http://schemas.openxmlformats.org/drawingml/2006/main">
               <a:ext uri="{FF2B5EF4-FFF2-40B4-BE49-F238E27FC236}">
-                <a16:creationId xmlns:a16="http://schemas.microsoft.com/office/drawing/2014/main" id="{78BA3D15-E172-4BD4-905F-DD198675E754}"/>
+                <a16:creationId xmlns:a16="http://schemas.microsoft.com/office/drawing/2014/main" id="{77542FFF-30B9-45E8-9614-F0347F52D914}"/>
               </a:ext>
             </a:extLst>
           </p:cNvPr>
@@ -6185,7 +6114,7 @@
           <p:cNvPr id="5" name="">
             <a:extLst xmlns:a="http://schemas.openxmlformats.org/drawingml/2006/main">
               <a:ext uri="{FF2B5EF4-FFF2-40B4-BE49-F238E27FC236}">
-                <a16:creationId xmlns:a16="http://schemas.microsoft.com/office/drawing/2014/main" id="{BBB27384-31F0-4286-89E5-96DFBD59BB11}"/>
+                <a16:creationId xmlns:a16="http://schemas.microsoft.com/office/drawing/2014/main" id="{6ED441BB-7A60-4078-B358-2DBB26235B60}"/>
               </a:ext>
             </a:extLst>
           </p:cNvPr>
@@ -6220,7 +6149,7 @@
           <p:cNvPr id="6" name="">
             <a:extLst xmlns:a="http://schemas.openxmlformats.org/drawingml/2006/main">
               <a:ext uri="{FF2B5EF4-FFF2-40B4-BE49-F238E27FC236}">
-                <a16:creationId xmlns:a16="http://schemas.microsoft.com/office/drawing/2014/main" id="{6145DB50-3731-491C-8FA1-10CC3F52EF17}"/>
+                <a16:creationId xmlns:a16="http://schemas.microsoft.com/office/drawing/2014/main" id="{2FD821F5-8729-4327-88E0-C97470725591}"/>
               </a:ext>
             </a:extLst>
           </p:cNvPr>
@@ -6253,7 +6182,7 @@
           <p:cNvPr id="7" name="">
             <a:extLst xmlns:a="http://schemas.openxmlformats.org/drawingml/2006/main">
               <a:ext uri="{FF2B5EF4-FFF2-40B4-BE49-F238E27FC236}">
-                <a16:creationId xmlns:a16="http://schemas.microsoft.com/office/drawing/2014/main" id="{78754B07-6D7C-4212-86F4-B88692E8A3A9}"/>
+                <a16:creationId xmlns:a16="http://schemas.microsoft.com/office/drawing/2014/main" id="{77C77DED-9FEC-4E5D-BC0E-2783E63C013F}"/>
               </a:ext>
             </a:extLst>
           </p:cNvPr>
@@ -6310,7 +6239,7 @@
           <p:cNvPr id="8" name="">
             <a:extLst xmlns:a="http://schemas.openxmlformats.org/drawingml/2006/main">
               <a:ext uri="{FF2B5EF4-FFF2-40B4-BE49-F238E27FC236}">
-                <a16:creationId xmlns:a16="http://schemas.microsoft.com/office/drawing/2014/main" id="{B14A58B3-4E1B-4548-B51B-860F63D29303}"/>
+                <a16:creationId xmlns:a16="http://schemas.microsoft.com/office/drawing/2014/main" id="{4F63CB9E-E1CB-4C60-AC4A-FF98C31CD615}"/>
               </a:ext>
             </a:extLst>
           </p:cNvPr>
@@ -6367,7 +6296,7 @@
           <p:cNvPr id="9" name="">
             <a:extLst xmlns:a="http://schemas.openxmlformats.org/drawingml/2006/main">
               <a:ext uri="{FF2B5EF4-FFF2-40B4-BE49-F238E27FC236}">
-                <a16:creationId xmlns:a16="http://schemas.microsoft.com/office/drawing/2014/main" id="{8C346A0E-1331-4326-A068-4590EC0A33FB}"/>
+                <a16:creationId xmlns:a16="http://schemas.microsoft.com/office/drawing/2014/main" id="{26BE3DC9-F675-4C0A-BE6C-EC65ADF7A6C6}"/>
               </a:ext>
             </a:extLst>
           </p:cNvPr>
@@ -6424,7 +6353,7 @@
           <p:cNvPr id="10" name="">
             <a:extLst xmlns:a="http://schemas.openxmlformats.org/drawingml/2006/main">
               <a:ext uri="{FF2B5EF4-FFF2-40B4-BE49-F238E27FC236}">
-                <a16:creationId xmlns:a16="http://schemas.microsoft.com/office/drawing/2014/main" id="{0D891208-9C29-433B-8AD4-63CAA632DA8C}"/>
+                <a16:creationId xmlns:a16="http://schemas.microsoft.com/office/drawing/2014/main" id="{12805413-53E6-4C1F-80B1-4782FB1CDFD4}"/>
               </a:ext>
             </a:extLst>
           </p:cNvPr>
@@ -6481,7 +6410,7 @@
           <p:cNvPr id="11" name="">
             <a:extLst xmlns:a="http://schemas.openxmlformats.org/drawingml/2006/main">
               <a:ext uri="{FF2B5EF4-FFF2-40B4-BE49-F238E27FC236}">
-                <a16:creationId xmlns:a16="http://schemas.microsoft.com/office/drawing/2014/main" id="{F4A19E05-1847-4D5C-B5E3-908B967A94CD}"/>
+                <a16:creationId xmlns:a16="http://schemas.microsoft.com/office/drawing/2014/main" id="{BC952135-02B3-4668-BD2D-FC8BC8C1FCF0}"/>
               </a:ext>
             </a:extLst>
           </p:cNvPr>
@@ -6516,7 +6445,7 @@
           <p:cNvPr id="12" name="">
             <a:extLst xmlns:a="http://schemas.openxmlformats.org/drawingml/2006/main">
               <a:ext uri="{FF2B5EF4-FFF2-40B4-BE49-F238E27FC236}">
-                <a16:creationId xmlns:a16="http://schemas.microsoft.com/office/drawing/2014/main" id="{A886AEE1-9C70-4E47-8385-2562E03DD948}"/>
+                <a16:creationId xmlns:a16="http://schemas.microsoft.com/office/drawing/2014/main" id="{FC89C0FF-34E4-4DD2-8EB1-55313FCE653E}"/>
               </a:ext>
             </a:extLst>
           </p:cNvPr>
@@ -6549,7 +6478,7 @@
           <p:cNvPr id="13" name="">
             <a:extLst xmlns:a="http://schemas.openxmlformats.org/drawingml/2006/main">
               <a:ext uri="{FF2B5EF4-FFF2-40B4-BE49-F238E27FC236}">
-                <a16:creationId xmlns:a16="http://schemas.microsoft.com/office/drawing/2014/main" id="{9C06677B-92B3-4FB9-A50E-DB14B23F5A52}"/>
+                <a16:creationId xmlns:a16="http://schemas.microsoft.com/office/drawing/2014/main" id="{9C96B7E8-4EA0-4012-AE72-2B9A635C0181}"/>
               </a:ext>
             </a:extLst>
           </p:cNvPr>
@@ -6606,7 +6535,7 @@
           <p:cNvPr id="14" name="">
             <a:extLst xmlns:a="http://schemas.openxmlformats.org/drawingml/2006/main">
               <a:ext uri="{FF2B5EF4-FFF2-40B4-BE49-F238E27FC236}">
-                <a16:creationId xmlns:a16="http://schemas.microsoft.com/office/drawing/2014/main" id="{E2C4D836-D2E9-469A-87CD-B9F2CA8D16F4}"/>
+                <a16:creationId xmlns:a16="http://schemas.microsoft.com/office/drawing/2014/main" id="{2DC659B7-846F-4483-84AD-24435D38BF16}"/>
               </a:ext>
             </a:extLst>
           </p:cNvPr>
@@ -6663,7 +6592,7 @@
           <p:cNvPr id="15" name="">
             <a:extLst xmlns:a="http://schemas.openxmlformats.org/drawingml/2006/main">
               <a:ext uri="{FF2B5EF4-FFF2-40B4-BE49-F238E27FC236}">
-                <a16:creationId xmlns:a16="http://schemas.microsoft.com/office/drawing/2014/main" id="{A63DB7E4-2A17-4C3E-9072-A9B171443F83}"/>
+                <a16:creationId xmlns:a16="http://schemas.microsoft.com/office/drawing/2014/main" id="{0DA0BE4B-DD35-47E8-891C-2B495808F5F1}"/>
               </a:ext>
             </a:extLst>
           </p:cNvPr>
@@ -6720,7 +6649,7 @@
           <p:cNvPr id="16" name="">
             <a:extLst xmlns:a="http://schemas.openxmlformats.org/drawingml/2006/main">
               <a:ext uri="{FF2B5EF4-FFF2-40B4-BE49-F238E27FC236}">
-                <a16:creationId xmlns:a16="http://schemas.microsoft.com/office/drawing/2014/main" id="{ECA711F8-8BC8-4ABB-91BB-656C770B0497}"/>
+                <a16:creationId xmlns:a16="http://schemas.microsoft.com/office/drawing/2014/main" id="{AB009BFF-1114-43EB-89BB-3FAA8C271ECB}"/>
               </a:ext>
             </a:extLst>
           </p:cNvPr>
@@ -6777,7 +6706,7 @@
           <p:cNvPr id="17" name="">
             <a:extLst xmlns:a="http://schemas.openxmlformats.org/drawingml/2006/main">
               <a:ext uri="{FF2B5EF4-FFF2-40B4-BE49-F238E27FC236}">
-                <a16:creationId xmlns:a16="http://schemas.microsoft.com/office/drawing/2014/main" id="{4BC344E4-0673-440D-A454-3F12580E3EA0}"/>
+                <a16:creationId xmlns:a16="http://schemas.microsoft.com/office/drawing/2014/main" id="{EAB0907D-5AFC-40D3-9106-6DBE523FAFF0}"/>
               </a:ext>
             </a:extLst>
           </p:cNvPr>
@@ -6812,7 +6741,7 @@
           <p:cNvPr id="18" name="">
             <a:extLst xmlns:a="http://schemas.openxmlformats.org/drawingml/2006/main">
               <a:ext uri="{FF2B5EF4-FFF2-40B4-BE49-F238E27FC236}">
-                <a16:creationId xmlns:a16="http://schemas.microsoft.com/office/drawing/2014/main" id="{21028395-C59D-434B-A393-09A4D1EB9BC4}"/>
+                <a16:creationId xmlns:a16="http://schemas.microsoft.com/office/drawing/2014/main" id="{554D6EDE-DAC5-40D4-929D-408BFFDE06A6}"/>
               </a:ext>
             </a:extLst>
           </p:cNvPr>
@@ -6845,7 +6774,7 @@
           <p:cNvPr id="19" name="">
             <a:extLst xmlns:a="http://schemas.openxmlformats.org/drawingml/2006/main">
               <a:ext uri="{FF2B5EF4-FFF2-40B4-BE49-F238E27FC236}">
-                <a16:creationId xmlns:a16="http://schemas.microsoft.com/office/drawing/2014/main" id="{3DC049A8-4060-4AAA-A730-AFFA31AC025D}"/>
+                <a16:creationId xmlns:a16="http://schemas.microsoft.com/office/drawing/2014/main" id="{D3109C4F-652B-450F-B68F-7F9F36FBF3F1}"/>
               </a:ext>
             </a:extLst>
           </p:cNvPr>
@@ -6902,7 +6831,7 @@
           <p:cNvPr id="20" name="">
             <a:extLst xmlns:a="http://schemas.openxmlformats.org/drawingml/2006/main">
               <a:ext uri="{FF2B5EF4-FFF2-40B4-BE49-F238E27FC236}">
-                <a16:creationId xmlns:a16="http://schemas.microsoft.com/office/drawing/2014/main" id="{E5D8A8BF-458C-4CD0-AF2E-B199D6297D91}"/>
+                <a16:creationId xmlns:a16="http://schemas.microsoft.com/office/drawing/2014/main" id="{2E61D152-2F55-49A7-A5C6-386AE8AB057A}"/>
               </a:ext>
             </a:extLst>
           </p:cNvPr>
@@ -6959,7 +6888,7 @@
           <p:cNvPr id="21" name="">
             <a:extLst xmlns:a="http://schemas.openxmlformats.org/drawingml/2006/main">
               <a:ext uri="{FF2B5EF4-FFF2-40B4-BE49-F238E27FC236}">
-                <a16:creationId xmlns:a16="http://schemas.microsoft.com/office/drawing/2014/main" id="{E220B52A-C969-48CF-9E0A-0174E06E8191}"/>
+                <a16:creationId xmlns:a16="http://schemas.microsoft.com/office/drawing/2014/main" id="{4C796ACA-F5FB-4293-9C28-0BA5FDA936EF}"/>
               </a:ext>
             </a:extLst>
           </p:cNvPr>
@@ -7016,7 +6945,7 @@
           <p:cNvPr id="22" name="">
             <a:extLst xmlns:a="http://schemas.openxmlformats.org/drawingml/2006/main">
               <a:ext uri="{FF2B5EF4-FFF2-40B4-BE49-F238E27FC236}">
-                <a16:creationId xmlns:a16="http://schemas.microsoft.com/office/drawing/2014/main" id="{A2889C44-4922-46A8-B8DE-F02A625E0182}"/>
+                <a16:creationId xmlns:a16="http://schemas.microsoft.com/office/drawing/2014/main" id="{43C0A266-9EA9-46D0-BDE2-AB1CC172AB95}"/>
               </a:ext>
             </a:extLst>
           </p:cNvPr>
@@ -7073,7 +7002,7 @@
           <p:cNvPr id="23" name="">
             <a:extLst xmlns:a="http://schemas.openxmlformats.org/drawingml/2006/main">
               <a:ext uri="{FF2B5EF4-FFF2-40B4-BE49-F238E27FC236}">
-                <a16:creationId xmlns:a16="http://schemas.microsoft.com/office/drawing/2014/main" id="{B84DCFFF-C0CA-4034-80CC-47C5064EEB61}"/>
+                <a16:creationId xmlns:a16="http://schemas.microsoft.com/office/drawing/2014/main" id="{6C22765E-46DC-42F9-9266-11DFAC1FA83B}"/>
               </a:ext>
             </a:extLst>
           </p:cNvPr>
@@ -7108,7 +7037,7 @@
           <p:cNvPr id="24" name="">
             <a:extLst xmlns:a="http://schemas.openxmlformats.org/drawingml/2006/main">
               <a:ext uri="{FF2B5EF4-FFF2-40B4-BE49-F238E27FC236}">
-                <a16:creationId xmlns:a16="http://schemas.microsoft.com/office/drawing/2014/main" id="{8AD85511-A48F-4C3D-AC6E-326188CFFB5D}"/>
+                <a16:creationId xmlns:a16="http://schemas.microsoft.com/office/drawing/2014/main" id="{D8169FFD-E89A-434E-8C37-AE84583ED286}"/>
               </a:ext>
             </a:extLst>
           </p:cNvPr>
@@ -7141,7 +7070,7 @@
           <p:cNvPr id="25" name="">
             <a:extLst xmlns:a="http://schemas.openxmlformats.org/drawingml/2006/main">
               <a:ext uri="{FF2B5EF4-FFF2-40B4-BE49-F238E27FC236}">
-                <a16:creationId xmlns:a16="http://schemas.microsoft.com/office/drawing/2014/main" id="{1674F726-88AE-468C-9B7B-F0B07C50A4B1}"/>
+                <a16:creationId xmlns:a16="http://schemas.microsoft.com/office/drawing/2014/main" id="{FF205D92-9FC7-4B76-BD94-71E5C945EC97}"/>
               </a:ext>
             </a:extLst>
           </p:cNvPr>
@@ -7198,7 +7127,7 @@
           <p:cNvPr id="26" name="">
             <a:extLst xmlns:a="http://schemas.openxmlformats.org/drawingml/2006/main">
               <a:ext uri="{FF2B5EF4-FFF2-40B4-BE49-F238E27FC236}">
-                <a16:creationId xmlns:a16="http://schemas.microsoft.com/office/drawing/2014/main" id="{A084925E-2D64-45F8-9666-7993BEA68FAC}"/>
+                <a16:creationId xmlns:a16="http://schemas.microsoft.com/office/drawing/2014/main" id="{09734781-2D3F-48A5-8AE9-0917308B7E16}"/>
               </a:ext>
             </a:extLst>
           </p:cNvPr>
@@ -7255,7 +7184,7 @@
           <p:cNvPr id="27" name="">
             <a:extLst xmlns:a="http://schemas.openxmlformats.org/drawingml/2006/main">
               <a:ext uri="{FF2B5EF4-FFF2-40B4-BE49-F238E27FC236}">
-                <a16:creationId xmlns:a16="http://schemas.microsoft.com/office/drawing/2014/main" id="{E9D3C929-CD88-4112-A726-24A5460B4F2F}"/>
+                <a16:creationId xmlns:a16="http://schemas.microsoft.com/office/drawing/2014/main" id="{59EA4592-491C-4EF1-A5D2-51990BC1AF1F}"/>
               </a:ext>
             </a:extLst>
           </p:cNvPr>
@@ -7312,7 +7241,7 @@
           <p:cNvPr id="28" name="">
             <a:extLst xmlns:a="http://schemas.openxmlformats.org/drawingml/2006/main">
               <a:ext uri="{FF2B5EF4-FFF2-40B4-BE49-F238E27FC236}">
-                <a16:creationId xmlns:a16="http://schemas.microsoft.com/office/drawing/2014/main" id="{A78D643D-140A-45B1-A945-432327E13566}"/>
+                <a16:creationId xmlns:a16="http://schemas.microsoft.com/office/drawing/2014/main" id="{C29F15F7-8206-4041-92CA-39C13C0E102B}"/>
               </a:ext>
             </a:extLst>
           </p:cNvPr>
@@ -7369,7 +7298,7 @@
           <p:cNvPr id="29" name="">
             <a:extLst xmlns:a="http://schemas.openxmlformats.org/drawingml/2006/main">
               <a:ext uri="{FF2B5EF4-FFF2-40B4-BE49-F238E27FC236}">
-                <a16:creationId xmlns:a16="http://schemas.microsoft.com/office/drawing/2014/main" id="{7B96F749-4392-43BE-9CEF-BC9CEA169A75}"/>
+                <a16:creationId xmlns:a16="http://schemas.microsoft.com/office/drawing/2014/main" id="{735872E5-73ED-47F9-9F55-746DF41DC22B}"/>
               </a:ext>
             </a:extLst>
           </p:cNvPr>
@@ -7404,7 +7333,7 @@
           <p:cNvPr id="30" name="">
             <a:extLst xmlns:a="http://schemas.openxmlformats.org/drawingml/2006/main">
               <a:ext uri="{FF2B5EF4-FFF2-40B4-BE49-F238E27FC236}">
-                <a16:creationId xmlns:a16="http://schemas.microsoft.com/office/drawing/2014/main" id="{E46D24CD-F938-4DA6-A842-02A8713261FF}"/>
+                <a16:creationId xmlns:a16="http://schemas.microsoft.com/office/drawing/2014/main" id="{5F448AF3-AC30-4C3B-A1AC-C765BEFD8176}"/>
               </a:ext>
             </a:extLst>
           </p:cNvPr>
@@ -7437,7 +7366,7 @@
           <p:cNvPr id="31" name="">
             <a:extLst xmlns:a="http://schemas.openxmlformats.org/drawingml/2006/main">
               <a:ext uri="{FF2B5EF4-FFF2-40B4-BE49-F238E27FC236}">
-                <a16:creationId xmlns:a16="http://schemas.microsoft.com/office/drawing/2014/main" id="{661378DE-73F2-4C81-8914-0122C2C8DBDA}"/>
+                <a16:creationId xmlns:a16="http://schemas.microsoft.com/office/drawing/2014/main" id="{F489DF83-D714-4B7D-BE91-3990B88B6BB7}"/>
               </a:ext>
             </a:extLst>
           </p:cNvPr>
@@ -7494,7 +7423,7 @@
           <p:cNvPr id="32" name="">
             <a:extLst xmlns:a="http://schemas.openxmlformats.org/drawingml/2006/main">
               <a:ext uri="{FF2B5EF4-FFF2-40B4-BE49-F238E27FC236}">
-                <a16:creationId xmlns:a16="http://schemas.microsoft.com/office/drawing/2014/main" id="{FFADED79-8CE2-45C2-8A4F-364B835C71D6}"/>
+                <a16:creationId xmlns:a16="http://schemas.microsoft.com/office/drawing/2014/main" id="{BABA81F2-4967-47DF-8985-593E50773A5A}"/>
               </a:ext>
             </a:extLst>
           </p:cNvPr>
@@ -7551,7 +7480,7 @@
           <p:cNvPr id="33" name="">
             <a:extLst xmlns:a="http://schemas.openxmlformats.org/drawingml/2006/main">
               <a:ext uri="{FF2B5EF4-FFF2-40B4-BE49-F238E27FC236}">
-                <a16:creationId xmlns:a16="http://schemas.microsoft.com/office/drawing/2014/main" id="{126D8044-48D9-433A-B014-B131043DAD56}"/>
+                <a16:creationId xmlns:a16="http://schemas.microsoft.com/office/drawing/2014/main" id="{1D74F838-B57B-4F3B-83F3-BE81059E665B}"/>
               </a:ext>
             </a:extLst>
           </p:cNvPr>
@@ -7608,7 +7537,7 @@
           <p:cNvPr id="34" name="">
             <a:extLst xmlns:a="http://schemas.openxmlformats.org/drawingml/2006/main">
               <a:ext uri="{FF2B5EF4-FFF2-40B4-BE49-F238E27FC236}">
-                <a16:creationId xmlns:a16="http://schemas.microsoft.com/office/drawing/2014/main" id="{BB11FEFD-1A42-458B-84EB-06810760F2A9}"/>
+                <a16:creationId xmlns:a16="http://schemas.microsoft.com/office/drawing/2014/main" id="{670F60E1-75C6-4812-AEB7-E8147B5282D7}"/>
               </a:ext>
             </a:extLst>
           </p:cNvPr>
@@ -7765,7 +7694,7 @@
           <p:cNvPr id="39" name="">
             <a:extLst xmlns:a="http://schemas.openxmlformats.org/drawingml/2006/main">
               <a:ext uri="{FF2B5EF4-FFF2-40B4-BE49-F238E27FC236}">
-                <a16:creationId xmlns:a16="http://schemas.microsoft.com/office/drawing/2014/main" id="{C5C9C4FB-18BD-47AE-8ECB-09E53DB10676}"/>
+                <a16:creationId xmlns:a16="http://schemas.microsoft.com/office/drawing/2014/main" id="{69091303-CCB1-4A47-8BE7-495EEF3DF44E}"/>
               </a:ext>
             </a:extLst>
           </p:cNvPr>
@@ -7800,7 +7729,7 @@
           <p:cNvPr id="40" name="">
             <a:extLst xmlns:a="http://schemas.openxmlformats.org/drawingml/2006/main">
               <a:ext uri="{FF2B5EF4-FFF2-40B4-BE49-F238E27FC236}">
-                <a16:creationId xmlns:a16="http://schemas.microsoft.com/office/drawing/2014/main" id="{D9710961-1FA3-41B2-8C00-DD9869641319}"/>
+                <a16:creationId xmlns:a16="http://schemas.microsoft.com/office/drawing/2014/main" id="{773FD68F-85DA-40BB-AFC0-B24B4EE903EA}"/>
               </a:ext>
             </a:extLst>
           </p:cNvPr>
@@ -7855,7 +7784,7 @@
     </p:spTree>
     <p:extLst>
       <p:ext uri="{BB962C8B-B14F-4D97-AF65-F5344CB8AC3E}">
-        <p14:creationId xmlns:p14="http://schemas.microsoft.com/office/powerpoint/2010/main" val="914749189"/>
+        <p14:creationId xmlns:p14="http://schemas.microsoft.com/office/powerpoint/2010/main" val="793518973"/>
       </p:ext>
     </p:extLst>
   </p:cSld>
@@ -7886,7 +7815,7 @@
           <p:cNvPr id="25" name="">
             <a:extLst xmlns:a="http://schemas.openxmlformats.org/drawingml/2006/main">
               <a:ext uri="{FF2B5EF4-FFF2-40B4-BE49-F238E27FC236}">
-                <a16:creationId xmlns:a16="http://schemas.microsoft.com/office/drawing/2014/main" id="{E673CC63-99B3-476C-A1D0-BDA7EFBF7EC0}"/>
+                <a16:creationId xmlns:a16="http://schemas.microsoft.com/office/drawing/2014/main" id="{74849934-21A0-421C-8200-88CB81E93CC0}"/>
               </a:ext>
             </a:extLst>
           </p:cNvPr>
@@ -7943,7 +7872,7 @@
           <p:cNvPr id="2" name="">
             <a:extLst xmlns:a="http://schemas.openxmlformats.org/drawingml/2006/main">
               <a:ext uri="{FF2B5EF4-FFF2-40B4-BE49-F238E27FC236}">
-                <a16:creationId xmlns:a16="http://schemas.microsoft.com/office/drawing/2014/main" id="{8C586FAC-E9AC-4A53-9348-C97064520812}"/>
+                <a16:creationId xmlns:a16="http://schemas.microsoft.com/office/drawing/2014/main" id="{C88BDA1F-EF7C-4BF8-A8B3-02C5B6E1B213}"/>
               </a:ext>
             </a:extLst>
           </p:cNvPr>
@@ -8000,7 +7929,7 @@
           <p:cNvPr id="3" name="">
             <a:extLst xmlns:a="http://schemas.openxmlformats.org/drawingml/2006/main">
               <a:ext uri="{FF2B5EF4-FFF2-40B4-BE49-F238E27FC236}">
-                <a16:creationId xmlns:a16="http://schemas.microsoft.com/office/drawing/2014/main" id="{25CD9F66-286B-485A-B1C3-8869543BBDB2}"/>
+                <a16:creationId xmlns:a16="http://schemas.microsoft.com/office/drawing/2014/main" id="{9A8396D4-D6B1-47AF-8A06-11F6503FCD8D}"/>
               </a:ext>
             </a:extLst>
           </p:cNvPr>
@@ -8031,7 +7960,7 @@
           <p:cNvPr id="4" name="">
             <a:extLst xmlns:a="http://schemas.openxmlformats.org/drawingml/2006/main">
               <a:ext uri="{FF2B5EF4-FFF2-40B4-BE49-F238E27FC236}">
-                <a16:creationId xmlns:a16="http://schemas.microsoft.com/office/drawing/2014/main" id="{D21261E3-6FA9-4B95-AEF2-EEB06FC160D0}"/>
+                <a16:creationId xmlns:a16="http://schemas.microsoft.com/office/drawing/2014/main" id="{E527150E-D030-4EC3-9001-D0650135A0F2}"/>
               </a:ext>
             </a:extLst>
           </p:cNvPr>
@@ -8064,7 +7993,7 @@
           <p:cNvPr id="5" name="">
             <a:extLst xmlns:a="http://schemas.openxmlformats.org/drawingml/2006/main">
               <a:ext uri="{FF2B5EF4-FFF2-40B4-BE49-F238E27FC236}">
-                <a16:creationId xmlns:a16="http://schemas.microsoft.com/office/drawing/2014/main" id="{5241DE87-F344-4105-B5E1-F91DC2726B67}"/>
+                <a16:creationId xmlns:a16="http://schemas.microsoft.com/office/drawing/2014/main" id="{1F01F40A-1BD2-4FD2-8465-B8AF04403FFA}"/>
               </a:ext>
             </a:extLst>
           </p:cNvPr>
@@ -8121,7 +8050,7 @@
           <p:cNvPr id="6" name="">
             <a:extLst xmlns:a="http://schemas.openxmlformats.org/drawingml/2006/main">
               <a:ext uri="{FF2B5EF4-FFF2-40B4-BE49-F238E27FC236}">
-                <a16:creationId xmlns:a16="http://schemas.microsoft.com/office/drawing/2014/main" id="{419B5B2F-0CF7-4A19-9013-DB14E9AEDA54}"/>
+                <a16:creationId xmlns:a16="http://schemas.microsoft.com/office/drawing/2014/main" id="{BD1B00E6-864F-4B7F-A30A-6B9282AF17C5}"/>
               </a:ext>
             </a:extLst>
           </p:cNvPr>
@@ -8178,7 +8107,7 @@
           <p:cNvPr id="7" name="">
             <a:extLst xmlns:a="http://schemas.openxmlformats.org/drawingml/2006/main">
               <a:ext uri="{FF2B5EF4-FFF2-40B4-BE49-F238E27FC236}">
-                <a16:creationId xmlns:a16="http://schemas.microsoft.com/office/drawing/2014/main" id="{B2E66432-6FEB-44A3-9F6D-140F9245AFFB}"/>
+                <a16:creationId xmlns:a16="http://schemas.microsoft.com/office/drawing/2014/main" id="{87297BAF-D20E-423C-B7D1-F2581C079C72}"/>
               </a:ext>
             </a:extLst>
           </p:cNvPr>
@@ -8235,7 +8164,7 @@
           <p:cNvPr id="8" name="">
             <a:extLst xmlns:a="http://schemas.openxmlformats.org/drawingml/2006/main">
               <a:ext uri="{FF2B5EF4-FFF2-40B4-BE49-F238E27FC236}">
-                <a16:creationId xmlns:a16="http://schemas.microsoft.com/office/drawing/2014/main" id="{F0E1833E-22D5-400A-AFC7-3AD24C39DD70}"/>
+                <a16:creationId xmlns:a16="http://schemas.microsoft.com/office/drawing/2014/main" id="{DBEBF16B-8805-4714-8B08-2835DD557F92}"/>
               </a:ext>
             </a:extLst>
           </p:cNvPr>
@@ -8268,7 +8197,7 @@
           <p:cNvPr id="9" name="">
             <a:extLst xmlns:a="http://schemas.openxmlformats.org/drawingml/2006/main">
               <a:ext uri="{FF2B5EF4-FFF2-40B4-BE49-F238E27FC236}">
-                <a16:creationId xmlns:a16="http://schemas.microsoft.com/office/drawing/2014/main" id="{7C25C900-F1E8-466A-BC9A-B40E6A442531}"/>
+                <a16:creationId xmlns:a16="http://schemas.microsoft.com/office/drawing/2014/main" id="{577DEED9-F979-4A46-80DE-4B4A1B3490F7}"/>
               </a:ext>
             </a:extLst>
           </p:cNvPr>
@@ -8325,7 +8254,7 @@
           <p:cNvPr id="10" name="">
             <a:extLst xmlns:a="http://schemas.openxmlformats.org/drawingml/2006/main">
               <a:ext uri="{FF2B5EF4-FFF2-40B4-BE49-F238E27FC236}">
-                <a16:creationId xmlns:a16="http://schemas.microsoft.com/office/drawing/2014/main" id="{226458F8-9707-412C-A61F-D3C3B2642834}"/>
+                <a16:creationId xmlns:a16="http://schemas.microsoft.com/office/drawing/2014/main" id="{5FC3D7E8-DF88-4A2D-A5CE-15AD329414EF}"/>
               </a:ext>
             </a:extLst>
           </p:cNvPr>
@@ -8382,7 +8311,7 @@
           <p:cNvPr id="11" name="">
             <a:extLst xmlns:a="http://schemas.openxmlformats.org/drawingml/2006/main">
               <a:ext uri="{FF2B5EF4-FFF2-40B4-BE49-F238E27FC236}">
-                <a16:creationId xmlns:a16="http://schemas.microsoft.com/office/drawing/2014/main" id="{C2082056-F064-4229-8425-AF8F33D03620}"/>
+                <a16:creationId xmlns:a16="http://schemas.microsoft.com/office/drawing/2014/main" id="{70CA467D-01BB-4A0D-9533-AD884F4ED3D5}"/>
               </a:ext>
             </a:extLst>
           </p:cNvPr>
@@ -8439,7 +8368,7 @@
           <p:cNvPr id="12" name="">
             <a:extLst xmlns:a="http://schemas.openxmlformats.org/drawingml/2006/main">
               <a:ext uri="{FF2B5EF4-FFF2-40B4-BE49-F238E27FC236}">
-                <a16:creationId xmlns:a16="http://schemas.microsoft.com/office/drawing/2014/main" id="{9227CC36-352A-4AA8-9A84-2D8A47E9DA0E}"/>
+                <a16:creationId xmlns:a16="http://schemas.microsoft.com/office/drawing/2014/main" id="{30952871-72BF-48E0-A652-5F6D26D16608}"/>
               </a:ext>
             </a:extLst>
           </p:cNvPr>
@@ -8472,7 +8401,7 @@
           <p:cNvPr id="13" name="">
             <a:extLst xmlns:a="http://schemas.openxmlformats.org/drawingml/2006/main">
               <a:ext uri="{FF2B5EF4-FFF2-40B4-BE49-F238E27FC236}">
-                <a16:creationId xmlns:a16="http://schemas.microsoft.com/office/drawing/2014/main" id="{6680F2BD-4FC5-4828-95F6-E2F9CB815817}"/>
+                <a16:creationId xmlns:a16="http://schemas.microsoft.com/office/drawing/2014/main" id="{BA7EC254-7E5F-4326-B572-6A020E9AB300}"/>
               </a:ext>
             </a:extLst>
           </p:cNvPr>
@@ -8529,7 +8458,7 @@
           <p:cNvPr id="14" name="">
             <a:extLst xmlns:a="http://schemas.openxmlformats.org/drawingml/2006/main">
               <a:ext uri="{FF2B5EF4-FFF2-40B4-BE49-F238E27FC236}">
-                <a16:creationId xmlns:a16="http://schemas.microsoft.com/office/drawing/2014/main" id="{2C3BE69B-856C-4973-A031-090E39359131}"/>
+                <a16:creationId xmlns:a16="http://schemas.microsoft.com/office/drawing/2014/main" id="{CCE36222-7191-4C2A-A5AA-E0D64C2AAA14}"/>
               </a:ext>
             </a:extLst>
           </p:cNvPr>
@@ -8586,7 +8515,7 @@
           <p:cNvPr id="15" name="">
             <a:extLst xmlns:a="http://schemas.openxmlformats.org/drawingml/2006/main">
               <a:ext uri="{FF2B5EF4-FFF2-40B4-BE49-F238E27FC236}">
-                <a16:creationId xmlns:a16="http://schemas.microsoft.com/office/drawing/2014/main" id="{139420A9-0EB8-4305-BD99-D5CE9184E3CA}"/>
+                <a16:creationId xmlns:a16="http://schemas.microsoft.com/office/drawing/2014/main" id="{BB8780DB-C7C6-4363-B43C-EBBDFF3229EA}"/>
               </a:ext>
             </a:extLst>
           </p:cNvPr>
@@ -8643,7 +8572,7 @@
           <p:cNvPr id="16" name="">
             <a:extLst xmlns:a="http://schemas.openxmlformats.org/drawingml/2006/main">
               <a:ext uri="{FF2B5EF4-FFF2-40B4-BE49-F238E27FC236}">
-                <a16:creationId xmlns:a16="http://schemas.microsoft.com/office/drawing/2014/main" id="{CFB8937A-46B5-4524-AEA1-A6E233561700}"/>
+                <a16:creationId xmlns:a16="http://schemas.microsoft.com/office/drawing/2014/main" id="{0A3DE1BE-547D-4894-826C-D95127182485}"/>
               </a:ext>
             </a:extLst>
           </p:cNvPr>
@@ -8700,7 +8629,7 @@
           <p:cNvPr id="17" name="">
             <a:extLst xmlns:a="http://schemas.openxmlformats.org/drawingml/2006/main">
               <a:ext uri="{FF2B5EF4-FFF2-40B4-BE49-F238E27FC236}">
-                <a16:creationId xmlns:a16="http://schemas.microsoft.com/office/drawing/2014/main" id="{198C47CF-2BF4-4449-ACB1-465B77504A1E}"/>
+                <a16:creationId xmlns:a16="http://schemas.microsoft.com/office/drawing/2014/main" id="{1EC3FB27-AB7F-49CD-BEF3-85E79BFC29EE}"/>
               </a:ext>
             </a:extLst>
           </p:cNvPr>
@@ -8757,7 +8686,7 @@
           <p:cNvPr id="18" name="">
             <a:extLst xmlns:a="http://schemas.openxmlformats.org/drawingml/2006/main">
               <a:ext uri="{FF2B5EF4-FFF2-40B4-BE49-F238E27FC236}">
-                <a16:creationId xmlns:a16="http://schemas.microsoft.com/office/drawing/2014/main" id="{54D56882-AA30-4986-96BA-085D556C4F27}"/>
+                <a16:creationId xmlns:a16="http://schemas.microsoft.com/office/drawing/2014/main" id="{3847BC2A-0E67-4C53-9D89-B55A95C21772}"/>
               </a:ext>
             </a:extLst>
           </p:cNvPr>
@@ -8814,7 +8743,7 @@
           <p:cNvPr id="19" name="">
             <a:extLst xmlns:a="http://schemas.openxmlformats.org/drawingml/2006/main">
               <a:ext uri="{FF2B5EF4-FFF2-40B4-BE49-F238E27FC236}">
-                <a16:creationId xmlns:a16="http://schemas.microsoft.com/office/drawing/2014/main" id="{05838E0E-A211-406A-A357-DBC30EB3FF88}"/>
+                <a16:creationId xmlns:a16="http://schemas.microsoft.com/office/drawing/2014/main" id="{ECC5BE46-B1AF-448B-8DB1-2AB6535A79C8}"/>
               </a:ext>
             </a:extLst>
           </p:cNvPr>
@@ -8871,7 +8800,7 @@
           <p:cNvPr id="20" name="">
             <a:extLst xmlns:a="http://schemas.openxmlformats.org/drawingml/2006/main">
               <a:ext uri="{FF2B5EF4-FFF2-40B4-BE49-F238E27FC236}">
-                <a16:creationId xmlns:a16="http://schemas.microsoft.com/office/drawing/2014/main" id="{5D31C6B9-AE2D-4730-8BF0-3797FA3FB8EA}"/>
+                <a16:creationId xmlns:a16="http://schemas.microsoft.com/office/drawing/2014/main" id="{BB0B4184-B3FC-41A8-84EF-A3B089A31A8B}"/>
               </a:ext>
             </a:extLst>
           </p:cNvPr>
@@ -8928,7 +8857,7 @@
           <p:cNvPr id="21" name="">
             <a:extLst xmlns:a="http://schemas.openxmlformats.org/drawingml/2006/main">
               <a:ext uri="{FF2B5EF4-FFF2-40B4-BE49-F238E27FC236}">
-                <a16:creationId xmlns:a16="http://schemas.microsoft.com/office/drawing/2014/main" id="{3DB0B52E-F333-4E14-8EE4-6E5416913265}"/>
+                <a16:creationId xmlns:a16="http://schemas.microsoft.com/office/drawing/2014/main" id="{A5BAA030-B41A-4B6C-B47B-D6CA033A74EA}"/>
               </a:ext>
             </a:extLst>
           </p:cNvPr>
@@ -8985,7 +8914,7 @@
           <p:cNvPr id="22" name="">
             <a:extLst xmlns:a="http://schemas.openxmlformats.org/drawingml/2006/main">
               <a:ext uri="{FF2B5EF4-FFF2-40B4-BE49-F238E27FC236}">
-                <a16:creationId xmlns:a16="http://schemas.microsoft.com/office/drawing/2014/main" id="{4DE0D934-E11C-48B6-9036-ECB4E24805E8}"/>
+                <a16:creationId xmlns:a16="http://schemas.microsoft.com/office/drawing/2014/main" id="{41E84728-7808-41E4-BDA5-9FCD0AF23EC7}"/>
               </a:ext>
             </a:extLst>
           </p:cNvPr>
@@ -9042,7 +8971,7 @@
           <p:cNvPr id="23" name="">
             <a:extLst xmlns:a="http://schemas.openxmlformats.org/drawingml/2006/main">
               <a:ext uri="{FF2B5EF4-FFF2-40B4-BE49-F238E27FC236}">
-                <a16:creationId xmlns:a16="http://schemas.microsoft.com/office/drawing/2014/main" id="{A9C8C402-C1B4-42FC-B7E1-528D3D2655F2}"/>
+                <a16:creationId xmlns:a16="http://schemas.microsoft.com/office/drawing/2014/main" id="{3E6F7012-D6A5-4DA3-9772-F7F4F4884653}"/>
               </a:ext>
             </a:extLst>
           </p:cNvPr>
@@ -9099,7 +9028,7 @@
           <p:cNvPr id="24" name="">
             <a:extLst xmlns:a="http://schemas.openxmlformats.org/drawingml/2006/main">
               <a:ext uri="{FF2B5EF4-FFF2-40B4-BE49-F238E27FC236}">
-                <a16:creationId xmlns:a16="http://schemas.microsoft.com/office/drawing/2014/main" id="{DD8ADF57-708A-461B-A2CD-442C03307B52}"/>
+                <a16:creationId xmlns:a16="http://schemas.microsoft.com/office/drawing/2014/main" id="{A8D3924D-BC85-4F80-8B1C-4B0E48753D27}"/>
               </a:ext>
             </a:extLst>
           </p:cNvPr>
@@ -9154,7 +9083,7 @@
     </p:spTree>
     <p:extLst>
       <p:ext uri="{BB962C8B-B14F-4D97-AF65-F5344CB8AC3E}">
-        <p14:creationId xmlns:p14="http://schemas.microsoft.com/office/powerpoint/2010/main" val="2049276481"/>
+        <p14:creationId xmlns:p14="http://schemas.microsoft.com/office/powerpoint/2010/main" val="157253405"/>
       </p:ext>
     </p:extLst>
   </p:cSld>
@@ -9185,7 +9114,7 @@
           <p:cNvPr id="31" name="">
             <a:extLst xmlns:a="http://schemas.openxmlformats.org/drawingml/2006/main">
               <a:ext uri="{FF2B5EF4-FFF2-40B4-BE49-F238E27FC236}">
-                <a16:creationId xmlns:a16="http://schemas.microsoft.com/office/drawing/2014/main" id="{423E4B7F-0C78-4B70-8B6C-C17C6D6CF018}"/>
+                <a16:creationId xmlns:a16="http://schemas.microsoft.com/office/drawing/2014/main" id="{93FF54E7-209D-4206-BC7B-FC1BA7D0C9B5}"/>
               </a:ext>
             </a:extLst>
           </p:cNvPr>
@@ -9242,7 +9171,7 @@
           <p:cNvPr id="2" name="">
             <a:extLst xmlns:a="http://schemas.openxmlformats.org/drawingml/2006/main">
               <a:ext uri="{FF2B5EF4-FFF2-40B4-BE49-F238E27FC236}">
-                <a16:creationId xmlns:a16="http://schemas.microsoft.com/office/drawing/2014/main" id="{0848AAC2-6C19-4DAA-B9A3-BC352F16DA26}"/>
+                <a16:creationId xmlns:a16="http://schemas.microsoft.com/office/drawing/2014/main" id="{82DA0545-173D-4A4D-B7E1-7F5C31F5CAE8}"/>
               </a:ext>
             </a:extLst>
           </p:cNvPr>
@@ -9299,7 +9228,7 @@
           <p:cNvPr id="3" name="">
             <a:extLst xmlns:a="http://schemas.openxmlformats.org/drawingml/2006/main">
               <a:ext uri="{FF2B5EF4-FFF2-40B4-BE49-F238E27FC236}">
-                <a16:creationId xmlns:a16="http://schemas.microsoft.com/office/drawing/2014/main" id="{140E8C76-4564-4A12-920D-AAB31418323D}"/>
+                <a16:creationId xmlns:a16="http://schemas.microsoft.com/office/drawing/2014/main" id="{89E8B16E-B838-470D-8BFF-4B2F0A9247D5}"/>
               </a:ext>
             </a:extLst>
           </p:cNvPr>
@@ -9330,7 +9259,7 @@
           <p:cNvPr id="4" name="">
             <a:extLst xmlns:a="http://schemas.openxmlformats.org/drawingml/2006/main">
               <a:ext uri="{FF2B5EF4-FFF2-40B4-BE49-F238E27FC236}">
-                <a16:creationId xmlns:a16="http://schemas.microsoft.com/office/drawing/2014/main" id="{CE62DF8A-928E-4FBA-87B0-E11141B7A307}"/>
+                <a16:creationId xmlns:a16="http://schemas.microsoft.com/office/drawing/2014/main" id="{537C17B7-832E-46D6-AD72-1820791596BB}"/>
               </a:ext>
             </a:extLst>
           </p:cNvPr>
@@ -9365,7 +9294,7 @@
           <p:cNvPr id="5" name="">
             <a:extLst xmlns:a="http://schemas.openxmlformats.org/drawingml/2006/main">
               <a:ext uri="{FF2B5EF4-FFF2-40B4-BE49-F238E27FC236}">
-                <a16:creationId xmlns:a16="http://schemas.microsoft.com/office/drawing/2014/main" id="{531FD7E0-0491-4647-B29E-DD0A58CB1B5B}"/>
+                <a16:creationId xmlns:a16="http://schemas.microsoft.com/office/drawing/2014/main" id="{A0EF51EC-4C59-46C4-861D-D73B19114C30}"/>
               </a:ext>
             </a:extLst>
           </p:cNvPr>
@@ -9422,7 +9351,7 @@
           <p:cNvPr id="6" name="">
             <a:extLst xmlns:a="http://schemas.openxmlformats.org/drawingml/2006/main">
               <a:ext uri="{FF2B5EF4-FFF2-40B4-BE49-F238E27FC236}">
-                <a16:creationId xmlns:a16="http://schemas.microsoft.com/office/drawing/2014/main" id="{5A0F9D35-7944-44BB-96B5-C2003CB13607}"/>
+                <a16:creationId xmlns:a16="http://schemas.microsoft.com/office/drawing/2014/main" id="{49B80550-42F2-42EE-B70D-E16229C3FC00}"/>
               </a:ext>
             </a:extLst>
           </p:cNvPr>
@@ -9479,7 +9408,7 @@
           <p:cNvPr id="7" name="">
             <a:extLst xmlns:a="http://schemas.openxmlformats.org/drawingml/2006/main">
               <a:ext uri="{FF2B5EF4-FFF2-40B4-BE49-F238E27FC236}">
-                <a16:creationId xmlns:a16="http://schemas.microsoft.com/office/drawing/2014/main" id="{F86D16A5-EB3E-4165-8CC3-0A03170ACC85}"/>
+                <a16:creationId xmlns:a16="http://schemas.microsoft.com/office/drawing/2014/main" id="{D14866B4-1A4C-421C-A678-10AFE5F5146C}"/>
               </a:ext>
             </a:extLst>
           </p:cNvPr>
@@ -9512,7 +9441,7 @@
           <p:cNvPr id="8" name="">
             <a:extLst xmlns:a="http://schemas.openxmlformats.org/drawingml/2006/main">
               <a:ext uri="{FF2B5EF4-FFF2-40B4-BE49-F238E27FC236}">
-                <a16:creationId xmlns:a16="http://schemas.microsoft.com/office/drawing/2014/main" id="{FDDF8443-C806-4DE0-ABDC-C77EFACD874E}"/>
+                <a16:creationId xmlns:a16="http://schemas.microsoft.com/office/drawing/2014/main" id="{3B65AF63-F535-4C8F-8CDC-760E13A571A4}"/>
               </a:ext>
             </a:extLst>
           </p:cNvPr>
@@ -9569,7 +9498,7 @@
           <p:cNvPr id="9" name="">
             <a:extLst xmlns:a="http://schemas.openxmlformats.org/drawingml/2006/main">
               <a:ext uri="{FF2B5EF4-FFF2-40B4-BE49-F238E27FC236}">
-                <a16:creationId xmlns:a16="http://schemas.microsoft.com/office/drawing/2014/main" id="{6B060491-EE46-4334-8772-F76CA290C678}"/>
+                <a16:creationId xmlns:a16="http://schemas.microsoft.com/office/drawing/2014/main" id="{7F635EEB-470E-4959-A562-C4F4D7828AC0}"/>
               </a:ext>
             </a:extLst>
           </p:cNvPr>
@@ -9626,7 +9555,7 @@
           <p:cNvPr id="10" name="">
             <a:extLst xmlns:a="http://schemas.openxmlformats.org/drawingml/2006/main">
               <a:ext uri="{FF2B5EF4-FFF2-40B4-BE49-F238E27FC236}">
-                <a16:creationId xmlns:a16="http://schemas.microsoft.com/office/drawing/2014/main" id="{96EBEF89-3B12-4A11-9503-3639B52BBE37}"/>
+                <a16:creationId xmlns:a16="http://schemas.microsoft.com/office/drawing/2014/main" id="{5DCBF8E2-7F15-4108-A2E8-2286720361C2}"/>
               </a:ext>
             </a:extLst>
           </p:cNvPr>
@@ -9683,7 +9612,7 @@
           <p:cNvPr id="11" name="">
             <a:extLst xmlns:a="http://schemas.openxmlformats.org/drawingml/2006/main">
               <a:ext uri="{FF2B5EF4-FFF2-40B4-BE49-F238E27FC236}">
-                <a16:creationId xmlns:a16="http://schemas.microsoft.com/office/drawing/2014/main" id="{574E6B36-F543-4D6E-BDF6-2E14B8DB88E5}"/>
+                <a16:creationId xmlns:a16="http://schemas.microsoft.com/office/drawing/2014/main" id="{8A08F61C-4A86-4A00-B3E4-E0B4A63AA969}"/>
               </a:ext>
             </a:extLst>
           </p:cNvPr>
@@ -9716,7 +9645,7 @@
           <p:cNvPr id="12" name="">
             <a:extLst xmlns:a="http://schemas.openxmlformats.org/drawingml/2006/main">
               <a:ext uri="{FF2B5EF4-FFF2-40B4-BE49-F238E27FC236}">
-                <a16:creationId xmlns:a16="http://schemas.microsoft.com/office/drawing/2014/main" id="{852417F3-E70B-4D91-8835-4CE2D208F51B}"/>
+                <a16:creationId xmlns:a16="http://schemas.microsoft.com/office/drawing/2014/main" id="{72033E10-FD1C-45C9-9747-ED8A528A31A3}"/>
               </a:ext>
             </a:extLst>
           </p:cNvPr>
@@ -9773,7 +9702,7 @@
           <p:cNvPr id="13" name="">
             <a:extLst xmlns:a="http://schemas.openxmlformats.org/drawingml/2006/main">
               <a:ext uri="{FF2B5EF4-FFF2-40B4-BE49-F238E27FC236}">
-                <a16:creationId xmlns:a16="http://schemas.microsoft.com/office/drawing/2014/main" id="{74515B06-32FD-4FCF-9A2F-3EFC9F1D6E69}"/>
+                <a16:creationId xmlns:a16="http://schemas.microsoft.com/office/drawing/2014/main" id="{E952CF1F-7C1E-4D9A-9D05-81F218AA4F4B}"/>
               </a:ext>
             </a:extLst>
           </p:cNvPr>
@@ -9830,7 +9759,7 @@
           <p:cNvPr id="14" name="">
             <a:extLst xmlns:a="http://schemas.openxmlformats.org/drawingml/2006/main">
               <a:ext uri="{FF2B5EF4-FFF2-40B4-BE49-F238E27FC236}">
-                <a16:creationId xmlns:a16="http://schemas.microsoft.com/office/drawing/2014/main" id="{7888205D-D1CA-4005-8065-B95B442E1876}"/>
+                <a16:creationId xmlns:a16="http://schemas.microsoft.com/office/drawing/2014/main" id="{0C08D252-F91D-475A-A5ED-16ACE06C5757}"/>
               </a:ext>
             </a:extLst>
           </p:cNvPr>
@@ -9887,7 +9816,7 @@
           <p:cNvPr id="15" name="">
             <a:extLst xmlns:a="http://schemas.openxmlformats.org/drawingml/2006/main">
               <a:ext uri="{FF2B5EF4-FFF2-40B4-BE49-F238E27FC236}">
-                <a16:creationId xmlns:a16="http://schemas.microsoft.com/office/drawing/2014/main" id="{619E91F3-5340-4EE3-9C31-FF224E414890}"/>
+                <a16:creationId xmlns:a16="http://schemas.microsoft.com/office/drawing/2014/main" id="{73343A3F-6942-4B54-BFCD-52B278B2F319}"/>
               </a:ext>
             </a:extLst>
           </p:cNvPr>
@@ -9920,7 +9849,7 @@
           <p:cNvPr id="16" name="">
             <a:extLst xmlns:a="http://schemas.openxmlformats.org/drawingml/2006/main">
               <a:ext uri="{FF2B5EF4-FFF2-40B4-BE49-F238E27FC236}">
-                <a16:creationId xmlns:a16="http://schemas.microsoft.com/office/drawing/2014/main" id="{B4EA90E7-C4B7-496E-8E01-B525389BBA54}"/>
+                <a16:creationId xmlns:a16="http://schemas.microsoft.com/office/drawing/2014/main" id="{F3244B83-1526-4B1A-BFCE-650E22A79DB6}"/>
               </a:ext>
             </a:extLst>
           </p:cNvPr>
@@ -9977,7 +9906,7 @@
           <p:cNvPr id="17" name="">
             <a:extLst xmlns:a="http://schemas.openxmlformats.org/drawingml/2006/main">
               <a:ext uri="{FF2B5EF4-FFF2-40B4-BE49-F238E27FC236}">
-                <a16:creationId xmlns:a16="http://schemas.microsoft.com/office/drawing/2014/main" id="{D3B5117F-DB5C-48E3-ACA9-E42A1A0490EA}"/>
+                <a16:creationId xmlns:a16="http://schemas.microsoft.com/office/drawing/2014/main" id="{D98E7B76-FE26-43D7-B877-959817F4B2C1}"/>
               </a:ext>
             </a:extLst>
           </p:cNvPr>
@@ -10034,7 +9963,7 @@
           <p:cNvPr id="18" name="">
             <a:extLst xmlns:a="http://schemas.openxmlformats.org/drawingml/2006/main">
               <a:ext uri="{FF2B5EF4-FFF2-40B4-BE49-F238E27FC236}">
-                <a16:creationId xmlns:a16="http://schemas.microsoft.com/office/drawing/2014/main" id="{00759A46-25ED-4AA9-B4CA-D4ABB119C93C}"/>
+                <a16:creationId xmlns:a16="http://schemas.microsoft.com/office/drawing/2014/main" id="{EF06F8FC-952E-4F5F-9254-60976E9CF4C6}"/>
               </a:ext>
             </a:extLst>
           </p:cNvPr>
@@ -10091,7 +10020,7 @@
           <p:cNvPr id="19" name="">
             <a:extLst xmlns:a="http://schemas.openxmlformats.org/drawingml/2006/main">
               <a:ext uri="{FF2B5EF4-FFF2-40B4-BE49-F238E27FC236}">
-                <a16:creationId xmlns:a16="http://schemas.microsoft.com/office/drawing/2014/main" id="{7A15ABE7-64A4-4D3A-A248-936A4B6B3C5B}"/>
+                <a16:creationId xmlns:a16="http://schemas.microsoft.com/office/drawing/2014/main" id="{02FC2312-83A5-40C5-9E76-2475106AF475}"/>
               </a:ext>
             </a:extLst>
           </p:cNvPr>
@@ -10124,7 +10053,7 @@
           <p:cNvPr id="20" name="">
             <a:extLst xmlns:a="http://schemas.openxmlformats.org/drawingml/2006/main">
               <a:ext uri="{FF2B5EF4-FFF2-40B4-BE49-F238E27FC236}">
-                <a16:creationId xmlns:a16="http://schemas.microsoft.com/office/drawing/2014/main" id="{7E69C6BC-4262-4ABD-B708-4EE9CAF0E8D3}"/>
+                <a16:creationId xmlns:a16="http://schemas.microsoft.com/office/drawing/2014/main" id="{1B910606-A792-4EE2-93FB-2A2A6D949E5D}"/>
               </a:ext>
             </a:extLst>
           </p:cNvPr>
@@ -10181,7 +10110,7 @@
           <p:cNvPr id="21" name="">
             <a:extLst xmlns:a="http://schemas.openxmlformats.org/drawingml/2006/main">
               <a:ext uri="{FF2B5EF4-FFF2-40B4-BE49-F238E27FC236}">
-                <a16:creationId xmlns:a16="http://schemas.microsoft.com/office/drawing/2014/main" id="{115CA792-9E82-4E3F-99A5-62A4B2AB4874}"/>
+                <a16:creationId xmlns:a16="http://schemas.microsoft.com/office/drawing/2014/main" id="{B93CF5E5-6CD7-4165-A9B4-A1B9AA18F29E}"/>
               </a:ext>
             </a:extLst>
           </p:cNvPr>
@@ -10238,7 +10167,7 @@
           <p:cNvPr id="22" name="">
             <a:extLst xmlns:a="http://schemas.openxmlformats.org/drawingml/2006/main">
               <a:ext uri="{FF2B5EF4-FFF2-40B4-BE49-F238E27FC236}">
-                <a16:creationId xmlns:a16="http://schemas.microsoft.com/office/drawing/2014/main" id="{A1CB1071-2021-4A19-86A9-D51297D4C3B3}"/>
+                <a16:creationId xmlns:a16="http://schemas.microsoft.com/office/drawing/2014/main" id="{33EBB5E0-E7D0-46F3-89EE-D6A4174C4FCF}"/>
               </a:ext>
             </a:extLst>
           </p:cNvPr>
@@ -10295,7 +10224,7 @@
           <p:cNvPr id="23" name="">
             <a:extLst xmlns:a="http://schemas.openxmlformats.org/drawingml/2006/main">
               <a:ext uri="{FF2B5EF4-FFF2-40B4-BE49-F238E27FC236}">
-                <a16:creationId xmlns:a16="http://schemas.microsoft.com/office/drawing/2014/main" id="{4EE8559F-ACD1-4B08-9805-FF3F0E2BF44D}"/>
+                <a16:creationId xmlns:a16="http://schemas.microsoft.com/office/drawing/2014/main" id="{54BDBDF5-6639-4A54-8041-C7BDB68BF736}"/>
               </a:ext>
             </a:extLst>
           </p:cNvPr>
@@ -10328,7 +10257,7 @@
           <p:cNvPr id="24" name="">
             <a:extLst xmlns:a="http://schemas.openxmlformats.org/drawingml/2006/main">
               <a:ext uri="{FF2B5EF4-FFF2-40B4-BE49-F238E27FC236}">
-                <a16:creationId xmlns:a16="http://schemas.microsoft.com/office/drawing/2014/main" id="{DC9BEC51-909B-4FAE-B6A4-7CF32FDDD272}"/>
+                <a16:creationId xmlns:a16="http://schemas.microsoft.com/office/drawing/2014/main" id="{A1B901F2-EBDC-4C6B-A282-D3E871301C55}"/>
               </a:ext>
             </a:extLst>
           </p:cNvPr>
@@ -10385,7 +10314,7 @@
           <p:cNvPr id="25" name="">
             <a:extLst xmlns:a="http://schemas.openxmlformats.org/drawingml/2006/main">
               <a:ext uri="{FF2B5EF4-FFF2-40B4-BE49-F238E27FC236}">
-                <a16:creationId xmlns:a16="http://schemas.microsoft.com/office/drawing/2014/main" id="{7B9CC6B4-7B45-4968-8695-F750CFCBDA39}"/>
+                <a16:creationId xmlns:a16="http://schemas.microsoft.com/office/drawing/2014/main" id="{89E7503D-F705-45B9-9849-09BCE2479513}"/>
               </a:ext>
             </a:extLst>
           </p:cNvPr>
@@ -10442,7 +10371,7 @@
           <p:cNvPr id="26" name="">
             <a:extLst xmlns:a="http://schemas.openxmlformats.org/drawingml/2006/main">
               <a:ext uri="{FF2B5EF4-FFF2-40B4-BE49-F238E27FC236}">
-                <a16:creationId xmlns:a16="http://schemas.microsoft.com/office/drawing/2014/main" id="{23F87112-AADF-49AD-84C4-96777859F9FF}"/>
+                <a16:creationId xmlns:a16="http://schemas.microsoft.com/office/drawing/2014/main" id="{A18204A7-B7D2-4C7D-8821-23FF02907CEE}"/>
               </a:ext>
             </a:extLst>
           </p:cNvPr>
@@ -10499,7 +10428,7 @@
           <p:cNvPr id="27" name="">
             <a:extLst xmlns:a="http://schemas.openxmlformats.org/drawingml/2006/main">
               <a:ext uri="{FF2B5EF4-FFF2-40B4-BE49-F238E27FC236}">
-                <a16:creationId xmlns:a16="http://schemas.microsoft.com/office/drawing/2014/main" id="{8739A1D3-68BE-49BF-917C-2B6F7F0AE8B6}"/>
+                <a16:creationId xmlns:a16="http://schemas.microsoft.com/office/drawing/2014/main" id="{708573C1-348B-449A-9770-FC157A229CBC}"/>
               </a:ext>
             </a:extLst>
           </p:cNvPr>
@@ -10532,7 +10461,7 @@
           <p:cNvPr id="28" name="">
             <a:extLst xmlns:a="http://schemas.openxmlformats.org/drawingml/2006/main">
               <a:ext uri="{FF2B5EF4-FFF2-40B4-BE49-F238E27FC236}">
-                <a16:creationId xmlns:a16="http://schemas.microsoft.com/office/drawing/2014/main" id="{B7624F36-C4FB-4F61-9FE9-3624A3039678}"/>
+                <a16:creationId xmlns:a16="http://schemas.microsoft.com/office/drawing/2014/main" id="{E9231457-8B4A-4552-B449-926499A63A26}"/>
               </a:ext>
             </a:extLst>
           </p:cNvPr>
@@ -10589,7 +10518,7 @@
           <p:cNvPr id="29" name="">
             <a:extLst xmlns:a="http://schemas.openxmlformats.org/drawingml/2006/main">
               <a:ext uri="{FF2B5EF4-FFF2-40B4-BE49-F238E27FC236}">
-                <a16:creationId xmlns:a16="http://schemas.microsoft.com/office/drawing/2014/main" id="{1E6414BD-F5DB-48D0-8602-8935189A14DB}"/>
+                <a16:creationId xmlns:a16="http://schemas.microsoft.com/office/drawing/2014/main" id="{C5FCE46F-291F-4886-96FC-5FDBD977D119}"/>
               </a:ext>
             </a:extLst>
           </p:cNvPr>
@@ -10702,7 +10631,7 @@
           <p:cNvPr id="30" name="">
             <a:extLst xmlns:a="http://schemas.openxmlformats.org/drawingml/2006/main">
               <a:ext uri="{FF2B5EF4-FFF2-40B4-BE49-F238E27FC236}">
-                <a16:creationId xmlns:a16="http://schemas.microsoft.com/office/drawing/2014/main" id="{95E99CCE-85F0-4E0F-BC08-5B2D1E608C48}"/>
+                <a16:creationId xmlns:a16="http://schemas.microsoft.com/office/drawing/2014/main" id="{1DD6C46B-C9FF-4030-AC83-82FF0670F78F}"/>
               </a:ext>
             </a:extLst>
           </p:cNvPr>
@@ -10757,1666 +10686,7 @@
     </p:spTree>
     <p:extLst>
       <p:ext uri="{BB962C8B-B14F-4D97-AF65-F5344CB8AC3E}">
-        <p14:creationId xmlns:p14="http://schemas.microsoft.com/office/powerpoint/2010/main" val="1770690633"/>
-      </p:ext>
-    </p:extLst>
-  </p:cSld>
-</p:sld>
-</file>
-
-<file path=ppt/slides/slide9.xml><?xml version="1.0" encoding="utf-8"?>
-<p:sld xmlns:p="http://schemas.openxmlformats.org/presentationml/2006/main">
-  <p:cSld>
-    <p:bg>
-      <p:bgPr>
-        <a:solidFill xmlns:a="http://schemas.openxmlformats.org/drawingml/2006/main">
-          <a:srgbClr val="F7F9FC"/>
-        </a:solidFill>
-      </p:bgPr>
-    </p:bg>
-    <p:spTree>
-      <p:nvGrpSpPr>
-        <p:cNvPr id="1" name=""/>
-        <p:cNvGrpSpPr/>
-        <p:nvPr/>
-      </p:nvGrpSpPr>
-      <p:grpSpPr>
-        <a:xfrm xmlns:a="http://schemas.openxmlformats.org/drawingml/2006/main"/>
-      </p:grpSpPr>
-      <p:sp>
-        <p:nvSpPr>
-          <p:cNvPr id="33" name="">
-            <a:extLst xmlns:a="http://schemas.openxmlformats.org/drawingml/2006/main">
-              <a:ext uri="{FF2B5EF4-FFF2-40B4-BE49-F238E27FC236}">
-                <a16:creationId xmlns:a16="http://schemas.microsoft.com/office/drawing/2014/main" id="{CB7A3720-1A8D-45F5-BA69-D6F2E0AB82D0}"/>
-              </a:ext>
-            </a:extLst>
-          </p:cNvPr>
-          <p:cNvSpPr>
-            <a:spLocks xmlns:a="http://schemas.openxmlformats.org/drawingml/2006/main" noGrp="1"/>
-          </p:cNvSpPr>
-          <p:nvPr/>
-        </p:nvSpPr>
-        <p:spPr>
-          <a:xfrm xmlns:a="http://schemas.openxmlformats.org/drawingml/2006/main">
-            <a:off x="609600" y="323850"/>
-            <a:ext cx="7239000" cy="266700"/>
-          </a:xfrm>
-          <a:prstGeom xmlns:a="http://schemas.openxmlformats.org/drawingml/2006/main" prst="rect">
-            <a:avLst/>
-          </a:prstGeom>
-          <a:noFill xmlns:a="http://schemas.openxmlformats.org/drawingml/2006/main"/>
-          <a:ln xmlns:a="http://schemas.openxmlformats.org/drawingml/2006/main" w="0">
-            <a:noFill/>
-          </a:ln>
-        </p:spPr>
-        <p:txBody>
-          <a:bodyPr xmlns:a="http://schemas.openxmlformats.org/drawingml/2006/main" anchor="ctr">
-            <a:normAutofit fontScale="100000"/>
-          </a:bodyPr>
-          <a:lstStyle xmlns:a="http://schemas.openxmlformats.org/drawingml/2006/main"/>
-          <a:p xmlns:a="http://schemas.openxmlformats.org/drawingml/2006/main">
-            <a:pPr algn="l">
-              <a:defRPr sz="1050" b="1">
-                <a:solidFill>
-                  <a:srgbClr val="F0642B"/>
-                </a:solidFill>
-                <a:latin typeface="Helvetica Neue"/>
-                <a:ea typeface="Helvetica Neue"/>
-                <a:cs typeface="Helvetica Neue"/>
-              </a:defRPr>
-            </a:pPr>
-            <a:r>
-              <a:rPr sz="1050" b="1">
-                <a:solidFill>
-                  <a:srgbClr val="F0642B"/>
-                </a:solidFill>
-                <a:latin typeface="Helvetica Neue"/>
-                <a:ea typeface="Helvetica Neue"/>
-                <a:cs typeface="Helvetica Neue"/>
-              </a:rPr>
-              <a:t>SUBMISSION MAP · 10 POINTS</a:t>
-            </a:r>
-          </a:p>
-        </p:txBody>
-      </p:sp>
-      <p:sp>
-        <p:nvSpPr>
-          <p:cNvPr id="2" name="">
-            <a:extLst xmlns:a="http://schemas.openxmlformats.org/drawingml/2006/main">
-              <a:ext uri="{FF2B5EF4-FFF2-40B4-BE49-F238E27FC236}">
-                <a16:creationId xmlns:a16="http://schemas.microsoft.com/office/drawing/2014/main" id="{22154C9A-10FB-45F2-9F96-AE2876A7D9A4}"/>
-              </a:ext>
-            </a:extLst>
-          </p:cNvPr>
-          <p:cNvSpPr>
-            <a:spLocks xmlns:a="http://schemas.openxmlformats.org/drawingml/2006/main" noGrp="1"/>
-          </p:cNvSpPr>
-          <p:nvPr/>
-        </p:nvSpPr>
-        <p:spPr>
-          <a:xfrm xmlns:a="http://schemas.openxmlformats.org/drawingml/2006/main">
-            <a:off x="609600" y="619125"/>
-            <a:ext cx="10972800" cy="590550"/>
-          </a:xfrm>
-          <a:prstGeom xmlns:a="http://schemas.openxmlformats.org/drawingml/2006/main" prst="rect">
-            <a:avLst/>
-          </a:prstGeom>
-          <a:noFill xmlns:a="http://schemas.openxmlformats.org/drawingml/2006/main"/>
-          <a:ln xmlns:a="http://schemas.openxmlformats.org/drawingml/2006/main" w="0">
-            <a:noFill/>
-          </a:ln>
-        </p:spPr>
-        <p:txBody>
-          <a:bodyPr xmlns:a="http://schemas.openxmlformats.org/drawingml/2006/main" anchor="ctr">
-            <a:normAutofit fontScale="100000"/>
-          </a:bodyPr>
-          <a:lstStyle xmlns:a="http://schemas.openxmlformats.org/drawingml/2006/main"/>
-          <a:p xmlns:a="http://schemas.openxmlformats.org/drawingml/2006/main">
-            <a:pPr algn="l">
-              <a:defRPr sz="2850" b="1">
-                <a:solidFill>
-                  <a:srgbClr val="102A43"/>
-                </a:solidFill>
-                <a:latin typeface="Helvetica Neue"/>
-                <a:ea typeface="Helvetica Neue"/>
-                <a:cs typeface="Helvetica Neue"/>
-              </a:defRPr>
-            </a:pPr>
-            <a:r>
-              <a:rPr sz="2850" b="1">
-                <a:solidFill>
-                  <a:srgbClr val="102A43"/>
-                </a:solidFill>
-                <a:latin typeface="Helvetica Neue"/>
-                <a:ea typeface="Helvetica Neue"/>
-                <a:cs typeface="Helvetica Neue"/>
-              </a:rPr>
-              <a:t>Where every rubric point is evidenced</a:t>
-            </a:r>
-          </a:p>
-        </p:txBody>
-      </p:sp>
-      <p:sp>
-        <p:nvSpPr>
-          <p:cNvPr id="3" name="">
-            <a:extLst xmlns:a="http://schemas.openxmlformats.org/drawingml/2006/main">
-              <a:ext uri="{FF2B5EF4-FFF2-40B4-BE49-F238E27FC236}">
-                <a16:creationId xmlns:a16="http://schemas.microsoft.com/office/drawing/2014/main" id="{9D47DCE7-5945-4DF8-974D-ADF408BB971C}"/>
-              </a:ext>
-            </a:extLst>
-          </p:cNvPr>
-          <p:cNvSpPr>
-            <a:spLocks xmlns:a="http://schemas.openxmlformats.org/drawingml/2006/main" noGrp="1"/>
-          </p:cNvSpPr>
-          <p:nvPr/>
-        </p:nvSpPr>
-        <p:spPr>
-          <a:xfrm xmlns:a="http://schemas.openxmlformats.org/drawingml/2006/main">
-            <a:off x="609600" y="1295400"/>
-            <a:ext cx="10972800" cy="0"/>
-          </a:xfrm>
-          <a:prstGeom xmlns:a="http://schemas.openxmlformats.org/drawingml/2006/main" prst="line">
-            <a:avLst/>
-          </a:prstGeom>
-          <a:noFill xmlns:a="http://schemas.openxmlformats.org/drawingml/2006/main"/>
-          <a:ln xmlns:a="http://schemas.openxmlformats.org/drawingml/2006/main" w="9525">
-            <a:solidFill>
-              <a:srgbClr val="CFD9E6"/>
-            </a:solidFill>
-            <a:prstDash val="solid"/>
-          </a:ln>
-        </p:spPr>
-      </p:sp>
-      <p:sp>
-        <p:nvSpPr>
-          <p:cNvPr id="4" name="">
-            <a:extLst xmlns:a="http://schemas.openxmlformats.org/drawingml/2006/main">
-              <a:ext uri="{FF2B5EF4-FFF2-40B4-BE49-F238E27FC236}">
-                <a16:creationId xmlns:a16="http://schemas.microsoft.com/office/drawing/2014/main" id="{7BBF77BC-D374-40FA-9A0F-B245F80420E4}"/>
-              </a:ext>
-            </a:extLst>
-          </p:cNvPr>
-          <p:cNvSpPr>
-            <a:spLocks xmlns:a="http://schemas.openxmlformats.org/drawingml/2006/main" noGrp="1"/>
-          </p:cNvSpPr>
-          <p:nvPr/>
-        </p:nvSpPr>
-        <p:spPr>
-          <a:xfrm xmlns:a="http://schemas.openxmlformats.org/drawingml/2006/main">
-            <a:off x="762000" y="1628775"/>
-            <a:ext cx="2667000" cy="285750"/>
-          </a:xfrm>
-          <a:prstGeom xmlns:a="http://schemas.openxmlformats.org/drawingml/2006/main" prst="rect">
-            <a:avLst/>
-          </a:prstGeom>
-          <a:noFill xmlns:a="http://schemas.openxmlformats.org/drawingml/2006/main"/>
-          <a:ln xmlns:a="http://schemas.openxmlformats.org/drawingml/2006/main" w="0">
-            <a:noFill/>
-          </a:ln>
-        </p:spPr>
-        <p:txBody>
-          <a:bodyPr xmlns:a="http://schemas.openxmlformats.org/drawingml/2006/main" anchor="ctr">
-            <a:normAutofit fontScale="100000"/>
-          </a:bodyPr>
-          <a:lstStyle xmlns:a="http://schemas.openxmlformats.org/drawingml/2006/main"/>
-          <a:p xmlns:a="http://schemas.openxmlformats.org/drawingml/2006/main">
-            <a:pPr algn="l">
-              <a:defRPr sz="1275" b="1">
-                <a:solidFill>
-                  <a:srgbClr val="63788E"/>
-                </a:solidFill>
-                <a:latin typeface="Helvetica Neue"/>
-                <a:ea typeface="Helvetica Neue"/>
-                <a:cs typeface="Helvetica Neue"/>
-              </a:defRPr>
-            </a:pPr>
-            <a:r>
-              <a:rPr sz="1275" b="1">
-                <a:solidFill>
-                  <a:srgbClr val="63788E"/>
-                </a:solidFill>
-                <a:latin typeface="Helvetica Neue"/>
-                <a:ea typeface="Helvetica Neue"/>
-                <a:cs typeface="Helvetica Neue"/>
-              </a:rPr>
-              <a:t>Criterion</a:t>
-            </a:r>
-          </a:p>
-        </p:txBody>
-      </p:sp>
-      <p:sp>
-        <p:nvSpPr>
-          <p:cNvPr id="5" name="">
-            <a:extLst xmlns:a="http://schemas.openxmlformats.org/drawingml/2006/main">
-              <a:ext uri="{FF2B5EF4-FFF2-40B4-BE49-F238E27FC236}">
-                <a16:creationId xmlns:a16="http://schemas.microsoft.com/office/drawing/2014/main" id="{3122ED93-ADC1-479C-A17A-7A7C4501FD4B}"/>
-              </a:ext>
-            </a:extLst>
-          </p:cNvPr>
-          <p:cNvSpPr>
-            <a:spLocks xmlns:a="http://schemas.openxmlformats.org/drawingml/2006/main" noGrp="1"/>
-          </p:cNvSpPr>
-          <p:nvPr/>
-        </p:nvSpPr>
-        <p:spPr>
-          <a:xfrm xmlns:a="http://schemas.openxmlformats.org/drawingml/2006/main">
-            <a:off x="3638550" y="1628775"/>
-            <a:ext cx="666750" cy="285750"/>
-          </a:xfrm>
-          <a:prstGeom xmlns:a="http://schemas.openxmlformats.org/drawingml/2006/main" prst="rect">
-            <a:avLst/>
-          </a:prstGeom>
-          <a:noFill xmlns:a="http://schemas.openxmlformats.org/drawingml/2006/main"/>
-          <a:ln xmlns:a="http://schemas.openxmlformats.org/drawingml/2006/main" w="0">
-            <a:noFill/>
-          </a:ln>
-        </p:spPr>
-        <p:txBody>
-          <a:bodyPr xmlns:a="http://schemas.openxmlformats.org/drawingml/2006/main" anchor="ctr">
-            <a:normAutofit fontScale="100000"/>
-          </a:bodyPr>
-          <a:lstStyle xmlns:a="http://schemas.openxmlformats.org/drawingml/2006/main"/>
-          <a:p xmlns:a="http://schemas.openxmlformats.org/drawingml/2006/main">
-            <a:pPr algn="ctr">
-              <a:defRPr sz="1275" b="1">
-                <a:solidFill>
-                  <a:srgbClr val="63788E"/>
-                </a:solidFill>
-                <a:latin typeface="Helvetica Neue"/>
-                <a:ea typeface="Helvetica Neue"/>
-                <a:cs typeface="Helvetica Neue"/>
-              </a:defRPr>
-            </a:pPr>
-            <a:r>
-              <a:rPr sz="1275" b="1">
-                <a:solidFill>
-                  <a:srgbClr val="63788E"/>
-                </a:solidFill>
-                <a:latin typeface="Helvetica Neue"/>
-                <a:ea typeface="Helvetica Neue"/>
-                <a:cs typeface="Helvetica Neue"/>
-              </a:rPr>
-              <a:t>Pts</a:t>
-            </a:r>
-          </a:p>
-        </p:txBody>
-      </p:sp>
-      <p:sp>
-        <p:nvSpPr>
-          <p:cNvPr id="6" name="">
-            <a:extLst xmlns:a="http://schemas.openxmlformats.org/drawingml/2006/main">
-              <a:ext uri="{FF2B5EF4-FFF2-40B4-BE49-F238E27FC236}">
-                <a16:creationId xmlns:a16="http://schemas.microsoft.com/office/drawing/2014/main" id="{7A48271D-0D39-4901-9D21-DA31B7A646DD}"/>
-              </a:ext>
-            </a:extLst>
-          </p:cNvPr>
-          <p:cNvSpPr>
-            <a:spLocks xmlns:a="http://schemas.openxmlformats.org/drawingml/2006/main" noGrp="1"/>
-          </p:cNvSpPr>
-          <p:nvPr/>
-        </p:nvSpPr>
-        <p:spPr>
-          <a:xfrm xmlns:a="http://schemas.openxmlformats.org/drawingml/2006/main">
-            <a:off x="4552950" y="1628775"/>
-            <a:ext cx="6381750" cy="285750"/>
-          </a:xfrm>
-          <a:prstGeom xmlns:a="http://schemas.openxmlformats.org/drawingml/2006/main" prst="rect">
-            <a:avLst/>
-          </a:prstGeom>
-          <a:noFill xmlns:a="http://schemas.openxmlformats.org/drawingml/2006/main"/>
-          <a:ln xmlns:a="http://schemas.openxmlformats.org/drawingml/2006/main" w="0">
-            <a:noFill/>
-          </a:ln>
-        </p:spPr>
-        <p:txBody>
-          <a:bodyPr xmlns:a="http://schemas.openxmlformats.org/drawingml/2006/main" anchor="ctr">
-            <a:normAutofit fontScale="100000"/>
-          </a:bodyPr>
-          <a:lstStyle xmlns:a="http://schemas.openxmlformats.org/drawingml/2006/main"/>
-          <a:p xmlns:a="http://schemas.openxmlformats.org/drawingml/2006/main">
-            <a:pPr algn="l">
-              <a:defRPr sz="1275" b="1">
-                <a:solidFill>
-                  <a:srgbClr val="63788E"/>
-                </a:solidFill>
-                <a:latin typeface="Helvetica Neue"/>
-                <a:ea typeface="Helvetica Neue"/>
-                <a:cs typeface="Helvetica Neue"/>
-              </a:defRPr>
-            </a:pPr>
-            <a:r>
-              <a:rPr sz="1275" b="1">
-                <a:solidFill>
-                  <a:srgbClr val="63788E"/>
-                </a:solidFill>
-                <a:latin typeface="Helvetica Neue"/>
-                <a:ea typeface="Helvetica Neue"/>
-                <a:cs typeface="Helvetica Neue"/>
-              </a:rPr>
-              <a:t>Evidence in this submission</a:t>
-            </a:r>
-          </a:p>
-        </p:txBody>
-      </p:sp>
-      <p:sp>
-        <p:nvSpPr>
-          <p:cNvPr id="7" name="">
-            <a:extLst xmlns:a="http://schemas.openxmlformats.org/drawingml/2006/main">
-              <a:ext uri="{FF2B5EF4-FFF2-40B4-BE49-F238E27FC236}">
-                <a16:creationId xmlns:a16="http://schemas.microsoft.com/office/drawing/2014/main" id="{6D96DCCA-AF6E-4D31-84B9-7C3C1F6EE5B2}"/>
-              </a:ext>
-            </a:extLst>
-          </p:cNvPr>
-          <p:cNvSpPr>
-            <a:spLocks xmlns:a="http://schemas.openxmlformats.org/drawingml/2006/main" noGrp="1"/>
-          </p:cNvSpPr>
-          <p:nvPr/>
-        </p:nvSpPr>
-        <p:spPr>
-          <a:xfrm xmlns:a="http://schemas.openxmlformats.org/drawingml/2006/main">
-            <a:off x="609600" y="2009775"/>
-            <a:ext cx="10648950" cy="495300"/>
-          </a:xfrm>
-          <a:prstGeom xmlns:a="http://schemas.openxmlformats.org/drawingml/2006/main" prst="roundRect">
-            <a:avLst>
-              <a:gd name="adj" fmla="val 15385"/>
-            </a:avLst>
-          </a:prstGeom>
-          <a:solidFill xmlns:a="http://schemas.openxmlformats.org/drawingml/2006/main">
-            <a:srgbClr val="FFFFFF"/>
-          </a:solidFill>
-          <a:ln xmlns:a="http://schemas.openxmlformats.org/drawingml/2006/main" w="0">
-            <a:noFill/>
-            <a:prstDash val="solid"/>
-          </a:ln>
-        </p:spPr>
-      </p:sp>
-      <p:sp>
-        <p:nvSpPr>
-          <p:cNvPr id="8" name="">
-            <a:extLst xmlns:a="http://schemas.openxmlformats.org/drawingml/2006/main">
-              <a:ext uri="{FF2B5EF4-FFF2-40B4-BE49-F238E27FC236}">
-                <a16:creationId xmlns:a16="http://schemas.microsoft.com/office/drawing/2014/main" id="{3637E9E3-0529-49DE-9EBF-81ABDB004590}"/>
-              </a:ext>
-            </a:extLst>
-          </p:cNvPr>
-          <p:cNvSpPr>
-            <a:spLocks xmlns:a="http://schemas.openxmlformats.org/drawingml/2006/main" noGrp="1"/>
-          </p:cNvSpPr>
-          <p:nvPr/>
-        </p:nvSpPr>
-        <p:spPr>
-          <a:xfrm xmlns:a="http://schemas.openxmlformats.org/drawingml/2006/main">
-            <a:off x="762000" y="2085975"/>
-            <a:ext cx="2667000" cy="342900"/>
-          </a:xfrm>
-          <a:prstGeom xmlns:a="http://schemas.openxmlformats.org/drawingml/2006/main" prst="rect">
-            <a:avLst/>
-          </a:prstGeom>
-          <a:noFill xmlns:a="http://schemas.openxmlformats.org/drawingml/2006/main"/>
-          <a:ln xmlns:a="http://schemas.openxmlformats.org/drawingml/2006/main" w="0">
-            <a:noFill/>
-          </a:ln>
-        </p:spPr>
-        <p:txBody>
-          <a:bodyPr xmlns:a="http://schemas.openxmlformats.org/drawingml/2006/main" anchor="ctr">
-            <a:normAutofit fontScale="100000"/>
-          </a:bodyPr>
-          <a:lstStyle xmlns:a="http://schemas.openxmlformats.org/drawingml/2006/main"/>
-          <a:p xmlns:a="http://schemas.openxmlformats.org/drawingml/2006/main">
-            <a:pPr algn="l">
-              <a:defRPr sz="1500" b="1">
-                <a:solidFill>
-                  <a:srgbClr val="102A43"/>
-                </a:solidFill>
-                <a:latin typeface="Helvetica Neue"/>
-                <a:ea typeface="Helvetica Neue"/>
-                <a:cs typeface="Helvetica Neue"/>
-              </a:defRPr>
-            </a:pPr>
-            <a:r>
-              <a:rPr sz="1500" b="1">
-                <a:solidFill>
-                  <a:srgbClr val="102A43"/>
-                </a:solidFill>
-                <a:latin typeface="Helvetica Neue"/>
-                <a:ea typeface="Helvetica Neue"/>
-                <a:cs typeface="Helvetica Neue"/>
-              </a:rPr>
-              <a:t>Problem definition</a:t>
-            </a:r>
-          </a:p>
-        </p:txBody>
-      </p:sp>
-      <p:sp>
-        <p:nvSpPr>
-          <p:cNvPr id="9" name="">
-            <a:extLst xmlns:a="http://schemas.openxmlformats.org/drawingml/2006/main">
-              <a:ext uri="{FF2B5EF4-FFF2-40B4-BE49-F238E27FC236}">
-                <a16:creationId xmlns:a16="http://schemas.microsoft.com/office/drawing/2014/main" id="{9ECA2E3B-0EE8-448A-A8CB-4A0C1CF373D0}"/>
-              </a:ext>
-            </a:extLst>
-          </p:cNvPr>
-          <p:cNvSpPr>
-            <a:spLocks xmlns:a="http://schemas.openxmlformats.org/drawingml/2006/main" noGrp="1"/>
-          </p:cNvSpPr>
-          <p:nvPr/>
-        </p:nvSpPr>
-        <p:spPr>
-          <a:xfrm xmlns:a="http://schemas.openxmlformats.org/drawingml/2006/main">
-            <a:off x="3638550" y="2085975"/>
-            <a:ext cx="666750" cy="342900"/>
-          </a:xfrm>
-          <a:prstGeom xmlns:a="http://schemas.openxmlformats.org/drawingml/2006/main" prst="rect">
-            <a:avLst/>
-          </a:prstGeom>
-          <a:noFill xmlns:a="http://schemas.openxmlformats.org/drawingml/2006/main"/>
-          <a:ln xmlns:a="http://schemas.openxmlformats.org/drawingml/2006/main" w="0">
-            <a:noFill/>
-          </a:ln>
-        </p:spPr>
-        <p:txBody>
-          <a:bodyPr xmlns:a="http://schemas.openxmlformats.org/drawingml/2006/main" anchor="ctr">
-            <a:normAutofit fontScale="100000"/>
-          </a:bodyPr>
-          <a:lstStyle xmlns:a="http://schemas.openxmlformats.org/drawingml/2006/main"/>
-          <a:p xmlns:a="http://schemas.openxmlformats.org/drawingml/2006/main">
-            <a:pPr algn="ctr">
-              <a:defRPr sz="1500" b="1">
-                <a:solidFill>
-                  <a:srgbClr val="1769D2"/>
-                </a:solidFill>
-                <a:latin typeface="Helvetica Neue"/>
-                <a:ea typeface="Helvetica Neue"/>
-                <a:cs typeface="Helvetica Neue"/>
-              </a:defRPr>
-            </a:pPr>
-            <a:r>
-              <a:rPr sz="1500" b="1">
-                <a:solidFill>
-                  <a:srgbClr val="1769D2"/>
-                </a:solidFill>
-                <a:latin typeface="Helvetica Neue"/>
-                <a:ea typeface="Helvetica Neue"/>
-                <a:cs typeface="Helvetica Neue"/>
-              </a:rPr>
-              <a:t>2</a:t>
-            </a:r>
-          </a:p>
-        </p:txBody>
-      </p:sp>
-      <p:sp>
-        <p:nvSpPr>
-          <p:cNvPr id="10" name="">
-            <a:extLst xmlns:a="http://schemas.openxmlformats.org/drawingml/2006/main">
-              <a:ext uri="{FF2B5EF4-FFF2-40B4-BE49-F238E27FC236}">
-                <a16:creationId xmlns:a16="http://schemas.microsoft.com/office/drawing/2014/main" id="{CD5C9337-CF6C-4A53-BC37-123EAAE70916}"/>
-              </a:ext>
-            </a:extLst>
-          </p:cNvPr>
-          <p:cNvSpPr>
-            <a:spLocks xmlns:a="http://schemas.openxmlformats.org/drawingml/2006/main" noGrp="1"/>
-          </p:cNvSpPr>
-          <p:nvPr/>
-        </p:nvSpPr>
-        <p:spPr>
-          <a:xfrm xmlns:a="http://schemas.openxmlformats.org/drawingml/2006/main">
-            <a:off x="4552950" y="2085975"/>
-            <a:ext cx="6438900" cy="342900"/>
-          </a:xfrm>
-          <a:prstGeom xmlns:a="http://schemas.openxmlformats.org/drawingml/2006/main" prst="rect">
-            <a:avLst/>
-          </a:prstGeom>
-          <a:noFill xmlns:a="http://schemas.openxmlformats.org/drawingml/2006/main"/>
-          <a:ln xmlns:a="http://schemas.openxmlformats.org/drawingml/2006/main" w="0">
-            <a:noFill/>
-          </a:ln>
-        </p:spPr>
-        <p:txBody>
-          <a:bodyPr xmlns:a="http://schemas.openxmlformats.org/drawingml/2006/main" anchor="ctr">
-            <a:normAutofit fontScale="100000"/>
-          </a:bodyPr>
-          <a:lstStyle xmlns:a="http://schemas.openxmlformats.org/drawingml/2006/main"/>
-          <a:p xmlns:a="http://schemas.openxmlformats.org/drawingml/2006/main">
-            <a:pPr algn="l">
-              <a:defRPr sz="1350" b="0">
-                <a:solidFill>
-                  <a:srgbClr val="17324D"/>
-                </a:solidFill>
-                <a:latin typeface="Helvetica Neue"/>
-                <a:ea typeface="Helvetica Neue"/>
-                <a:cs typeface="Helvetica Neue"/>
-              </a:defRPr>
-            </a:pPr>
-            <a:r>
-              <a:rPr sz="1350" b="0">
-                <a:solidFill>
-                  <a:srgbClr val="17324D"/>
-                </a:solidFill>
-                <a:latin typeface="Helvetica Neue"/>
-                <a:ea typeface="Helvetica Neue"/>
-                <a:cs typeface="Helvetica Neue"/>
-              </a:rPr>
-              <a:t>Numbers, source-backed inequality and SDG 10 link</a:t>
-            </a:r>
-          </a:p>
-        </p:txBody>
-      </p:sp>
-      <p:sp>
-        <p:nvSpPr>
-          <p:cNvPr id="11" name="">
-            <a:extLst xmlns:a="http://schemas.openxmlformats.org/drawingml/2006/main">
-              <a:ext uri="{FF2B5EF4-FFF2-40B4-BE49-F238E27FC236}">
-                <a16:creationId xmlns:a16="http://schemas.microsoft.com/office/drawing/2014/main" id="{49F31B01-1671-4FA1-8AFA-2A62AA15EA8E}"/>
-              </a:ext>
-            </a:extLst>
-          </p:cNvPr>
-          <p:cNvSpPr>
-            <a:spLocks xmlns:a="http://schemas.openxmlformats.org/drawingml/2006/main" noGrp="1"/>
-          </p:cNvSpPr>
-          <p:nvPr/>
-        </p:nvSpPr>
-        <p:spPr>
-          <a:xfrm xmlns:a="http://schemas.openxmlformats.org/drawingml/2006/main">
-            <a:off x="609600" y="2609850"/>
-            <a:ext cx="10648950" cy="495300"/>
-          </a:xfrm>
-          <a:prstGeom xmlns:a="http://schemas.openxmlformats.org/drawingml/2006/main" prst="roundRect">
-            <a:avLst>
-              <a:gd name="adj" fmla="val 15385"/>
-            </a:avLst>
-          </a:prstGeom>
-          <a:solidFill xmlns:a="http://schemas.openxmlformats.org/drawingml/2006/main">
-            <a:srgbClr val="F0F4F8"/>
-          </a:solidFill>
-          <a:ln xmlns:a="http://schemas.openxmlformats.org/drawingml/2006/main" w="0">
-            <a:noFill/>
-            <a:prstDash val="solid"/>
-          </a:ln>
-        </p:spPr>
-      </p:sp>
-      <p:sp>
-        <p:nvSpPr>
-          <p:cNvPr id="12" name="">
-            <a:extLst xmlns:a="http://schemas.openxmlformats.org/drawingml/2006/main">
-              <a:ext uri="{FF2B5EF4-FFF2-40B4-BE49-F238E27FC236}">
-                <a16:creationId xmlns:a16="http://schemas.microsoft.com/office/drawing/2014/main" id="{36034205-63BF-4165-B1B4-250C8CF18E4E}"/>
-              </a:ext>
-            </a:extLst>
-          </p:cNvPr>
-          <p:cNvSpPr>
-            <a:spLocks xmlns:a="http://schemas.openxmlformats.org/drawingml/2006/main" noGrp="1"/>
-          </p:cNvSpPr>
-          <p:nvPr/>
-        </p:nvSpPr>
-        <p:spPr>
-          <a:xfrm xmlns:a="http://schemas.openxmlformats.org/drawingml/2006/main">
-            <a:off x="762000" y="2686050"/>
-            <a:ext cx="2667000" cy="342900"/>
-          </a:xfrm>
-          <a:prstGeom xmlns:a="http://schemas.openxmlformats.org/drawingml/2006/main" prst="rect">
-            <a:avLst/>
-          </a:prstGeom>
-          <a:noFill xmlns:a="http://schemas.openxmlformats.org/drawingml/2006/main"/>
-          <a:ln xmlns:a="http://schemas.openxmlformats.org/drawingml/2006/main" w="0">
-            <a:noFill/>
-          </a:ln>
-        </p:spPr>
-        <p:txBody>
-          <a:bodyPr xmlns:a="http://schemas.openxmlformats.org/drawingml/2006/main" anchor="ctr">
-            <a:normAutofit fontScale="100000"/>
-          </a:bodyPr>
-          <a:lstStyle xmlns:a="http://schemas.openxmlformats.org/drawingml/2006/main"/>
-          <a:p xmlns:a="http://schemas.openxmlformats.org/drawingml/2006/main">
-            <a:pPr algn="l">
-              <a:defRPr sz="1500" b="1">
-                <a:solidFill>
-                  <a:srgbClr val="102A43"/>
-                </a:solidFill>
-                <a:latin typeface="Helvetica Neue"/>
-                <a:ea typeface="Helvetica Neue"/>
-                <a:cs typeface="Helvetica Neue"/>
-              </a:defRPr>
-            </a:pPr>
-            <a:r>
-              <a:rPr sz="1500" b="1">
-                <a:solidFill>
-                  <a:srgbClr val="102A43"/>
-                </a:solidFill>
-                <a:latin typeface="Helvetica Neue"/>
-                <a:ea typeface="Helvetica Neue"/>
-                <a:cs typeface="Helvetica Neue"/>
-              </a:rPr>
-              <a:t>User group</a:t>
-            </a:r>
-          </a:p>
-        </p:txBody>
-      </p:sp>
-      <p:sp>
-        <p:nvSpPr>
-          <p:cNvPr id="13" name="">
-            <a:extLst xmlns:a="http://schemas.openxmlformats.org/drawingml/2006/main">
-              <a:ext uri="{FF2B5EF4-FFF2-40B4-BE49-F238E27FC236}">
-                <a16:creationId xmlns:a16="http://schemas.microsoft.com/office/drawing/2014/main" id="{ECC2673F-3887-4C2A-A260-92B7E801A1F9}"/>
-              </a:ext>
-            </a:extLst>
-          </p:cNvPr>
-          <p:cNvSpPr>
-            <a:spLocks xmlns:a="http://schemas.openxmlformats.org/drawingml/2006/main" noGrp="1"/>
-          </p:cNvSpPr>
-          <p:nvPr/>
-        </p:nvSpPr>
-        <p:spPr>
-          <a:xfrm xmlns:a="http://schemas.openxmlformats.org/drawingml/2006/main">
-            <a:off x="3638550" y="2686050"/>
-            <a:ext cx="666750" cy="342900"/>
-          </a:xfrm>
-          <a:prstGeom xmlns:a="http://schemas.openxmlformats.org/drawingml/2006/main" prst="rect">
-            <a:avLst/>
-          </a:prstGeom>
-          <a:noFill xmlns:a="http://schemas.openxmlformats.org/drawingml/2006/main"/>
-          <a:ln xmlns:a="http://schemas.openxmlformats.org/drawingml/2006/main" w="0">
-            <a:noFill/>
-          </a:ln>
-        </p:spPr>
-        <p:txBody>
-          <a:bodyPr xmlns:a="http://schemas.openxmlformats.org/drawingml/2006/main" anchor="ctr">
-            <a:normAutofit fontScale="100000"/>
-          </a:bodyPr>
-          <a:lstStyle xmlns:a="http://schemas.openxmlformats.org/drawingml/2006/main"/>
-          <a:p xmlns:a="http://schemas.openxmlformats.org/drawingml/2006/main">
-            <a:pPr algn="ctr">
-              <a:defRPr sz="1500" b="1">
-                <a:solidFill>
-                  <a:srgbClr val="1769D2"/>
-                </a:solidFill>
-                <a:latin typeface="Helvetica Neue"/>
-                <a:ea typeface="Helvetica Neue"/>
-                <a:cs typeface="Helvetica Neue"/>
-              </a:defRPr>
-            </a:pPr>
-            <a:r>
-              <a:rPr sz="1500" b="1">
-                <a:solidFill>
-                  <a:srgbClr val="1769D2"/>
-                </a:solidFill>
-                <a:latin typeface="Helvetica Neue"/>
-                <a:ea typeface="Helvetica Neue"/>
-                <a:cs typeface="Helvetica Neue"/>
-              </a:rPr>
-              <a:t>2</a:t>
-            </a:r>
-          </a:p>
-        </p:txBody>
-      </p:sp>
-      <p:sp>
-        <p:nvSpPr>
-          <p:cNvPr id="14" name="">
-            <a:extLst xmlns:a="http://schemas.openxmlformats.org/drawingml/2006/main">
-              <a:ext uri="{FF2B5EF4-FFF2-40B4-BE49-F238E27FC236}">
-                <a16:creationId xmlns:a16="http://schemas.microsoft.com/office/drawing/2014/main" id="{7ADAFBEC-328A-458C-8FC5-9DAD1D072CF1}"/>
-              </a:ext>
-            </a:extLst>
-          </p:cNvPr>
-          <p:cNvSpPr>
-            <a:spLocks xmlns:a="http://schemas.openxmlformats.org/drawingml/2006/main" noGrp="1"/>
-          </p:cNvSpPr>
-          <p:nvPr/>
-        </p:nvSpPr>
-        <p:spPr>
-          <a:xfrm xmlns:a="http://schemas.openxmlformats.org/drawingml/2006/main">
-            <a:off x="4552950" y="2686050"/>
-            <a:ext cx="6438900" cy="342900"/>
-          </a:xfrm>
-          <a:prstGeom xmlns:a="http://schemas.openxmlformats.org/drawingml/2006/main" prst="rect">
-            <a:avLst/>
-          </a:prstGeom>
-          <a:noFill xmlns:a="http://schemas.openxmlformats.org/drawingml/2006/main"/>
-          <a:ln xmlns:a="http://schemas.openxmlformats.org/drawingml/2006/main" w="0">
-            <a:noFill/>
-          </a:ln>
-        </p:spPr>
-        <p:txBody>
-          <a:bodyPr xmlns:a="http://schemas.openxmlformats.org/drawingml/2006/main" anchor="ctr">
-            <a:normAutofit fontScale="100000"/>
-          </a:bodyPr>
-          <a:lstStyle xmlns:a="http://schemas.openxmlformats.org/drawingml/2006/main"/>
-          <a:p xmlns:a="http://schemas.openxmlformats.org/drawingml/2006/main">
-            <a:pPr algn="l">
-              <a:defRPr sz="1350" b="0">
-                <a:solidFill>
-                  <a:srgbClr val="17324D"/>
-                </a:solidFill>
-                <a:latin typeface="Helvetica Neue"/>
-                <a:ea typeface="Helvetica Neue"/>
-                <a:cs typeface="Helvetica Neue"/>
-              </a:defRPr>
-            </a:pPr>
-            <a:r>
-              <a:rPr sz="1350" b="0">
-                <a:solidFill>
-                  <a:srgbClr val="17324D"/>
-                </a:solidFill>
-                <a:latin typeface="Helvetica Neue"/>
-                <a:ea typeface="Helvetica Neue"/>
-                <a:cs typeface="Helvetica Neue"/>
-              </a:rPr>
-              <a:t>Recent arrivals with limited Dutch, plus explicit exclusions</a:t>
-            </a:r>
-          </a:p>
-        </p:txBody>
-      </p:sp>
-      <p:sp>
-        <p:nvSpPr>
-          <p:cNvPr id="15" name="">
-            <a:extLst xmlns:a="http://schemas.openxmlformats.org/drawingml/2006/main">
-              <a:ext uri="{FF2B5EF4-FFF2-40B4-BE49-F238E27FC236}">
-                <a16:creationId xmlns:a16="http://schemas.microsoft.com/office/drawing/2014/main" id="{F55BD754-952A-4163-9B47-B70654CADD1F}"/>
-              </a:ext>
-            </a:extLst>
-          </p:cNvPr>
-          <p:cNvSpPr>
-            <a:spLocks xmlns:a="http://schemas.openxmlformats.org/drawingml/2006/main" noGrp="1"/>
-          </p:cNvSpPr>
-          <p:nvPr/>
-        </p:nvSpPr>
-        <p:spPr>
-          <a:xfrm xmlns:a="http://schemas.openxmlformats.org/drawingml/2006/main">
-            <a:off x="609600" y="3209925"/>
-            <a:ext cx="10648950" cy="495300"/>
-          </a:xfrm>
-          <a:prstGeom xmlns:a="http://schemas.openxmlformats.org/drawingml/2006/main" prst="roundRect">
-            <a:avLst>
-              <a:gd name="adj" fmla="val 15385"/>
-            </a:avLst>
-          </a:prstGeom>
-          <a:solidFill xmlns:a="http://schemas.openxmlformats.org/drawingml/2006/main">
-            <a:srgbClr val="FFFFFF"/>
-          </a:solidFill>
-          <a:ln xmlns:a="http://schemas.openxmlformats.org/drawingml/2006/main" w="0">
-            <a:noFill/>
-            <a:prstDash val="solid"/>
-          </a:ln>
-        </p:spPr>
-      </p:sp>
-      <p:sp>
-        <p:nvSpPr>
-          <p:cNvPr id="16" name="">
-            <a:extLst xmlns:a="http://schemas.openxmlformats.org/drawingml/2006/main">
-              <a:ext uri="{FF2B5EF4-FFF2-40B4-BE49-F238E27FC236}">
-                <a16:creationId xmlns:a16="http://schemas.microsoft.com/office/drawing/2014/main" id="{F68815ED-46FE-43CF-AFFF-EB8AECA8D0FB}"/>
-              </a:ext>
-            </a:extLst>
-          </p:cNvPr>
-          <p:cNvSpPr>
-            <a:spLocks xmlns:a="http://schemas.openxmlformats.org/drawingml/2006/main" noGrp="1"/>
-          </p:cNvSpPr>
-          <p:nvPr/>
-        </p:nvSpPr>
-        <p:spPr>
-          <a:xfrm xmlns:a="http://schemas.openxmlformats.org/drawingml/2006/main">
-            <a:off x="762000" y="3286125"/>
-            <a:ext cx="2667000" cy="342900"/>
-          </a:xfrm>
-          <a:prstGeom xmlns:a="http://schemas.openxmlformats.org/drawingml/2006/main" prst="rect">
-            <a:avLst/>
-          </a:prstGeom>
-          <a:noFill xmlns:a="http://schemas.openxmlformats.org/drawingml/2006/main"/>
-          <a:ln xmlns:a="http://schemas.openxmlformats.org/drawingml/2006/main" w="0">
-            <a:noFill/>
-          </a:ln>
-        </p:spPr>
-        <p:txBody>
-          <a:bodyPr xmlns:a="http://schemas.openxmlformats.org/drawingml/2006/main" anchor="ctr">
-            <a:normAutofit fontScale="100000"/>
-          </a:bodyPr>
-          <a:lstStyle xmlns:a="http://schemas.openxmlformats.org/drawingml/2006/main"/>
-          <a:p xmlns:a="http://schemas.openxmlformats.org/drawingml/2006/main">
-            <a:pPr algn="l">
-              <a:defRPr sz="1500" b="1">
-                <a:solidFill>
-                  <a:srgbClr val="102A43"/>
-                </a:solidFill>
-                <a:latin typeface="Helvetica Neue"/>
-                <a:ea typeface="Helvetica Neue"/>
-                <a:cs typeface="Helvetica Neue"/>
-              </a:defRPr>
-            </a:pPr>
-            <a:r>
-              <a:rPr sz="1500" b="1">
-                <a:solidFill>
-                  <a:srgbClr val="102A43"/>
-                </a:solidFill>
-                <a:latin typeface="Helvetica Neue"/>
-                <a:ea typeface="Helvetica Neue"/>
-                <a:cs typeface="Helvetica Neue"/>
-              </a:rPr>
-              <a:t>Solution description</a:t>
-            </a:r>
-          </a:p>
-        </p:txBody>
-      </p:sp>
-      <p:sp>
-        <p:nvSpPr>
-          <p:cNvPr id="17" name="">
-            <a:extLst xmlns:a="http://schemas.openxmlformats.org/drawingml/2006/main">
-              <a:ext uri="{FF2B5EF4-FFF2-40B4-BE49-F238E27FC236}">
-                <a16:creationId xmlns:a16="http://schemas.microsoft.com/office/drawing/2014/main" id="{F335C99A-1D79-4C95-BE4F-AF4D6D073625}"/>
-              </a:ext>
-            </a:extLst>
-          </p:cNvPr>
-          <p:cNvSpPr>
-            <a:spLocks xmlns:a="http://schemas.openxmlformats.org/drawingml/2006/main" noGrp="1"/>
-          </p:cNvSpPr>
-          <p:nvPr/>
-        </p:nvSpPr>
-        <p:spPr>
-          <a:xfrm xmlns:a="http://schemas.openxmlformats.org/drawingml/2006/main">
-            <a:off x="3638550" y="3286125"/>
-            <a:ext cx="666750" cy="342900"/>
-          </a:xfrm>
-          <a:prstGeom xmlns:a="http://schemas.openxmlformats.org/drawingml/2006/main" prst="rect">
-            <a:avLst/>
-          </a:prstGeom>
-          <a:noFill xmlns:a="http://schemas.openxmlformats.org/drawingml/2006/main"/>
-          <a:ln xmlns:a="http://schemas.openxmlformats.org/drawingml/2006/main" w="0">
-            <a:noFill/>
-          </a:ln>
-        </p:spPr>
-        <p:txBody>
-          <a:bodyPr xmlns:a="http://schemas.openxmlformats.org/drawingml/2006/main" anchor="ctr">
-            <a:normAutofit fontScale="100000"/>
-          </a:bodyPr>
-          <a:lstStyle xmlns:a="http://schemas.openxmlformats.org/drawingml/2006/main"/>
-          <a:p xmlns:a="http://schemas.openxmlformats.org/drawingml/2006/main">
-            <a:pPr algn="ctr">
-              <a:defRPr sz="1500" b="1">
-                <a:solidFill>
-                  <a:srgbClr val="1769D2"/>
-                </a:solidFill>
-                <a:latin typeface="Helvetica Neue"/>
-                <a:ea typeface="Helvetica Neue"/>
-                <a:cs typeface="Helvetica Neue"/>
-              </a:defRPr>
-            </a:pPr>
-            <a:r>
-              <a:rPr sz="1500" b="1">
-                <a:solidFill>
-                  <a:srgbClr val="1769D2"/>
-                </a:solidFill>
-                <a:latin typeface="Helvetica Neue"/>
-                <a:ea typeface="Helvetica Neue"/>
-                <a:cs typeface="Helvetica Neue"/>
-              </a:rPr>
-              <a:t>2</a:t>
-            </a:r>
-          </a:p>
-        </p:txBody>
-      </p:sp>
-      <p:sp>
-        <p:nvSpPr>
-          <p:cNvPr id="18" name="">
-            <a:extLst xmlns:a="http://schemas.openxmlformats.org/drawingml/2006/main">
-              <a:ext uri="{FF2B5EF4-FFF2-40B4-BE49-F238E27FC236}">
-                <a16:creationId xmlns:a16="http://schemas.microsoft.com/office/drawing/2014/main" id="{116E0788-AC77-4C7F-ADFA-7AF91066F6DD}"/>
-              </a:ext>
-            </a:extLst>
-          </p:cNvPr>
-          <p:cNvSpPr>
-            <a:spLocks xmlns:a="http://schemas.openxmlformats.org/drawingml/2006/main" noGrp="1"/>
-          </p:cNvSpPr>
-          <p:nvPr/>
-        </p:nvSpPr>
-        <p:spPr>
-          <a:xfrm xmlns:a="http://schemas.openxmlformats.org/drawingml/2006/main">
-            <a:off x="4552950" y="3286125"/>
-            <a:ext cx="6438900" cy="342900"/>
-          </a:xfrm>
-          <a:prstGeom xmlns:a="http://schemas.openxmlformats.org/drawingml/2006/main" prst="rect">
-            <a:avLst/>
-          </a:prstGeom>
-          <a:noFill xmlns:a="http://schemas.openxmlformats.org/drawingml/2006/main"/>
-          <a:ln xmlns:a="http://schemas.openxmlformats.org/drawingml/2006/main" w="0">
-            <a:noFill/>
-          </a:ln>
-        </p:spPr>
-        <p:txBody>
-          <a:bodyPr xmlns:a="http://schemas.openxmlformats.org/drawingml/2006/main" anchor="ctr">
-            <a:normAutofit fontScale="100000"/>
-          </a:bodyPr>
-          <a:lstStyle xmlns:a="http://schemas.openxmlformats.org/drawingml/2006/main"/>
-          <a:p xmlns:a="http://schemas.openxmlformats.org/drawingml/2006/main">
-            <a:pPr algn="l">
-              <a:defRPr sz="1350" b="0">
-                <a:solidFill>
-                  <a:srgbClr val="17324D"/>
-                </a:solidFill>
-                <a:latin typeface="Helvetica Neue"/>
-                <a:ea typeface="Helvetica Neue"/>
-                <a:cs typeface="Helvetica Neue"/>
-              </a:defRPr>
-            </a:pPr>
-            <a:r>
-              <a:rPr sz="1350" b="0">
-                <a:solidFill>
-                  <a:srgbClr val="17324D"/>
-                </a:solidFill>
-                <a:latin typeface="Helvetica Neue"/>
-                <a:ea typeface="Helvetica Neue"/>
-                <a:cs typeface="Helvetica Neue"/>
-              </a:rPr>
-              <a:t>Working Streamlit flow and simple Python/API explanation</a:t>
-            </a:r>
-          </a:p>
-        </p:txBody>
-      </p:sp>
-      <p:sp>
-        <p:nvSpPr>
-          <p:cNvPr id="19" name="">
-            <a:extLst xmlns:a="http://schemas.openxmlformats.org/drawingml/2006/main">
-              <a:ext uri="{FF2B5EF4-FFF2-40B4-BE49-F238E27FC236}">
-                <a16:creationId xmlns:a16="http://schemas.microsoft.com/office/drawing/2014/main" id="{63422B10-DC3F-4767-8EAA-A0447E0F9871}"/>
-              </a:ext>
-            </a:extLst>
-          </p:cNvPr>
-          <p:cNvSpPr>
-            <a:spLocks xmlns:a="http://schemas.openxmlformats.org/drawingml/2006/main" noGrp="1"/>
-          </p:cNvSpPr>
-          <p:nvPr/>
-        </p:nvSpPr>
-        <p:spPr>
-          <a:xfrm xmlns:a="http://schemas.openxmlformats.org/drawingml/2006/main">
-            <a:off x="609600" y="3810000"/>
-            <a:ext cx="10648950" cy="495300"/>
-          </a:xfrm>
-          <a:prstGeom xmlns:a="http://schemas.openxmlformats.org/drawingml/2006/main" prst="roundRect">
-            <a:avLst>
-              <a:gd name="adj" fmla="val 15385"/>
-            </a:avLst>
-          </a:prstGeom>
-          <a:solidFill xmlns:a="http://schemas.openxmlformats.org/drawingml/2006/main">
-            <a:srgbClr val="F0F4F8"/>
-          </a:solidFill>
-          <a:ln xmlns:a="http://schemas.openxmlformats.org/drawingml/2006/main" w="0">
-            <a:noFill/>
-            <a:prstDash val="solid"/>
-          </a:ln>
-        </p:spPr>
-      </p:sp>
-      <p:sp>
-        <p:nvSpPr>
-          <p:cNvPr id="20" name="">
-            <a:extLst xmlns:a="http://schemas.openxmlformats.org/drawingml/2006/main">
-              <a:ext uri="{FF2B5EF4-FFF2-40B4-BE49-F238E27FC236}">
-                <a16:creationId xmlns:a16="http://schemas.microsoft.com/office/drawing/2014/main" id="{DAC90AD2-11F9-44FD-AEAE-E2D12E855F79}"/>
-              </a:ext>
-            </a:extLst>
-          </p:cNvPr>
-          <p:cNvSpPr>
-            <a:spLocks xmlns:a="http://schemas.openxmlformats.org/drawingml/2006/main" noGrp="1"/>
-          </p:cNvSpPr>
-          <p:nvPr/>
-        </p:nvSpPr>
-        <p:spPr>
-          <a:xfrm xmlns:a="http://schemas.openxmlformats.org/drawingml/2006/main">
-            <a:off x="762000" y="3886200"/>
-            <a:ext cx="2667000" cy="342900"/>
-          </a:xfrm>
-          <a:prstGeom xmlns:a="http://schemas.openxmlformats.org/drawingml/2006/main" prst="rect">
-            <a:avLst/>
-          </a:prstGeom>
-          <a:noFill xmlns:a="http://schemas.openxmlformats.org/drawingml/2006/main"/>
-          <a:ln xmlns:a="http://schemas.openxmlformats.org/drawingml/2006/main" w="0">
-            <a:noFill/>
-          </a:ln>
-        </p:spPr>
-        <p:txBody>
-          <a:bodyPr xmlns:a="http://schemas.openxmlformats.org/drawingml/2006/main" anchor="ctr">
-            <a:normAutofit fontScale="100000"/>
-          </a:bodyPr>
-          <a:lstStyle xmlns:a="http://schemas.openxmlformats.org/drawingml/2006/main"/>
-          <a:p xmlns:a="http://schemas.openxmlformats.org/drawingml/2006/main">
-            <a:pPr algn="l">
-              <a:defRPr sz="1500" b="1">
-                <a:solidFill>
-                  <a:srgbClr val="102A43"/>
-                </a:solidFill>
-                <a:latin typeface="Helvetica Neue"/>
-                <a:ea typeface="Helvetica Neue"/>
-                <a:cs typeface="Helvetica Neue"/>
-              </a:defRPr>
-            </a:pPr>
-            <a:r>
-              <a:rPr sz="1500" b="1">
-                <a:solidFill>
-                  <a:srgbClr val="102A43"/>
-                </a:solidFill>
-                <a:latin typeface="Helvetica Neue"/>
-                <a:ea typeface="Helvetica Neue"/>
-                <a:cs typeface="Helvetica Neue"/>
-              </a:rPr>
-              <a:t>Problem–solution fit</a:t>
-            </a:r>
-          </a:p>
-        </p:txBody>
-      </p:sp>
-      <p:sp>
-        <p:nvSpPr>
-          <p:cNvPr id="21" name="">
-            <a:extLst xmlns:a="http://schemas.openxmlformats.org/drawingml/2006/main">
-              <a:ext uri="{FF2B5EF4-FFF2-40B4-BE49-F238E27FC236}">
-                <a16:creationId xmlns:a16="http://schemas.microsoft.com/office/drawing/2014/main" id="{FD724091-70A2-405A-A33F-0794AE3D8993}"/>
-              </a:ext>
-            </a:extLst>
-          </p:cNvPr>
-          <p:cNvSpPr>
-            <a:spLocks xmlns:a="http://schemas.openxmlformats.org/drawingml/2006/main" noGrp="1"/>
-          </p:cNvSpPr>
-          <p:nvPr/>
-        </p:nvSpPr>
-        <p:spPr>
-          <a:xfrm xmlns:a="http://schemas.openxmlformats.org/drawingml/2006/main">
-            <a:off x="3638550" y="3886200"/>
-            <a:ext cx="666750" cy="342900"/>
-          </a:xfrm>
-          <a:prstGeom xmlns:a="http://schemas.openxmlformats.org/drawingml/2006/main" prst="rect">
-            <a:avLst/>
-          </a:prstGeom>
-          <a:noFill xmlns:a="http://schemas.openxmlformats.org/drawingml/2006/main"/>
-          <a:ln xmlns:a="http://schemas.openxmlformats.org/drawingml/2006/main" w="0">
-            <a:noFill/>
-          </a:ln>
-        </p:spPr>
-        <p:txBody>
-          <a:bodyPr xmlns:a="http://schemas.openxmlformats.org/drawingml/2006/main" anchor="ctr">
-            <a:normAutofit fontScale="100000"/>
-          </a:bodyPr>
-          <a:lstStyle xmlns:a="http://schemas.openxmlformats.org/drawingml/2006/main"/>
-          <a:p xmlns:a="http://schemas.openxmlformats.org/drawingml/2006/main">
-            <a:pPr algn="ctr">
-              <a:defRPr sz="1500" b="1">
-                <a:solidFill>
-                  <a:srgbClr val="1769D2"/>
-                </a:solidFill>
-                <a:latin typeface="Helvetica Neue"/>
-                <a:ea typeface="Helvetica Neue"/>
-                <a:cs typeface="Helvetica Neue"/>
-              </a:defRPr>
-            </a:pPr>
-            <a:r>
-              <a:rPr sz="1500" b="1">
-                <a:solidFill>
-                  <a:srgbClr val="1769D2"/>
-                </a:solidFill>
-                <a:latin typeface="Helvetica Neue"/>
-                <a:ea typeface="Helvetica Neue"/>
-                <a:cs typeface="Helvetica Neue"/>
-              </a:rPr>
-              <a:t>1</a:t>
-            </a:r>
-          </a:p>
-        </p:txBody>
-      </p:sp>
-      <p:sp>
-        <p:nvSpPr>
-          <p:cNvPr id="22" name="">
-            <a:extLst xmlns:a="http://schemas.openxmlformats.org/drawingml/2006/main">
-              <a:ext uri="{FF2B5EF4-FFF2-40B4-BE49-F238E27FC236}">
-                <a16:creationId xmlns:a16="http://schemas.microsoft.com/office/drawing/2014/main" id="{F4EA79E3-4BBD-42F0-B433-E2CE361AFF58}"/>
-              </a:ext>
-            </a:extLst>
-          </p:cNvPr>
-          <p:cNvSpPr>
-            <a:spLocks xmlns:a="http://schemas.openxmlformats.org/drawingml/2006/main" noGrp="1"/>
-          </p:cNvSpPr>
-          <p:nvPr/>
-        </p:nvSpPr>
-        <p:spPr>
-          <a:xfrm xmlns:a="http://schemas.openxmlformats.org/drawingml/2006/main">
-            <a:off x="4552950" y="3886200"/>
-            <a:ext cx="6438900" cy="342900"/>
-          </a:xfrm>
-          <a:prstGeom xmlns:a="http://schemas.openxmlformats.org/drawingml/2006/main" prst="rect">
-            <a:avLst/>
-          </a:prstGeom>
-          <a:noFill xmlns:a="http://schemas.openxmlformats.org/drawingml/2006/main"/>
-          <a:ln xmlns:a="http://schemas.openxmlformats.org/drawingml/2006/main" w="0">
-            <a:noFill/>
-          </a:ln>
-        </p:spPr>
-        <p:txBody>
-          <a:bodyPr xmlns:a="http://schemas.openxmlformats.org/drawingml/2006/main" anchor="ctr">
-            <a:normAutofit fontScale="100000"/>
-          </a:bodyPr>
-          <a:lstStyle xmlns:a="http://schemas.openxmlformats.org/drawingml/2006/main"/>
-          <a:p xmlns:a="http://schemas.openxmlformats.org/drawingml/2006/main">
-            <a:pPr algn="l">
-              <a:defRPr sz="1350" b="0">
-                <a:solidFill>
-                  <a:srgbClr val="17324D"/>
-                </a:solidFill>
-                <a:latin typeface="Helvetica Neue"/>
-                <a:ea typeface="Helvetica Neue"/>
-                <a:cs typeface="Helvetica Neue"/>
-              </a:defRPr>
-            </a:pPr>
-            <a:r>
-              <a:rPr sz="1350" b="0">
-                <a:solidFill>
-                  <a:srgbClr val="17324D"/>
-                </a:solidFill>
-                <a:latin typeface="Helvetica Neue"/>
-                <a:ea typeface="Helvetica Neue"/>
-                <a:cs typeface="Helvetica Neue"/>
-              </a:rPr>
-              <a:t>Personalised route replaces a fragmented link hunt</a:t>
-            </a:r>
-          </a:p>
-        </p:txBody>
-      </p:sp>
-      <p:sp>
-        <p:nvSpPr>
-          <p:cNvPr id="23" name="">
-            <a:extLst xmlns:a="http://schemas.openxmlformats.org/drawingml/2006/main">
-              <a:ext uri="{FF2B5EF4-FFF2-40B4-BE49-F238E27FC236}">
-                <a16:creationId xmlns:a16="http://schemas.microsoft.com/office/drawing/2014/main" id="{A45A3DB0-D0C7-47DD-A9EC-FEA55DE9EEEC}"/>
-              </a:ext>
-            </a:extLst>
-          </p:cNvPr>
-          <p:cNvSpPr>
-            <a:spLocks xmlns:a="http://schemas.openxmlformats.org/drawingml/2006/main" noGrp="1"/>
-          </p:cNvSpPr>
-          <p:nvPr/>
-        </p:nvSpPr>
-        <p:spPr>
-          <a:xfrm xmlns:a="http://schemas.openxmlformats.org/drawingml/2006/main">
-            <a:off x="609600" y="4410075"/>
-            <a:ext cx="10648950" cy="495300"/>
-          </a:xfrm>
-          <a:prstGeom xmlns:a="http://schemas.openxmlformats.org/drawingml/2006/main" prst="roundRect">
-            <a:avLst>
-              <a:gd name="adj" fmla="val 15385"/>
-            </a:avLst>
-          </a:prstGeom>
-          <a:solidFill xmlns:a="http://schemas.openxmlformats.org/drawingml/2006/main">
-            <a:srgbClr val="FFFFFF"/>
-          </a:solidFill>
-          <a:ln xmlns:a="http://schemas.openxmlformats.org/drawingml/2006/main" w="0">
-            <a:noFill/>
-            <a:prstDash val="solid"/>
-          </a:ln>
-        </p:spPr>
-      </p:sp>
-      <p:sp>
-        <p:nvSpPr>
-          <p:cNvPr id="24" name="">
-            <a:extLst xmlns:a="http://schemas.openxmlformats.org/drawingml/2006/main">
-              <a:ext uri="{FF2B5EF4-FFF2-40B4-BE49-F238E27FC236}">
-                <a16:creationId xmlns:a16="http://schemas.microsoft.com/office/drawing/2014/main" id="{14A7F993-344B-4EED-BAE9-D1E57B7E2A10}"/>
-              </a:ext>
-            </a:extLst>
-          </p:cNvPr>
-          <p:cNvSpPr>
-            <a:spLocks xmlns:a="http://schemas.openxmlformats.org/drawingml/2006/main" noGrp="1"/>
-          </p:cNvSpPr>
-          <p:nvPr/>
-        </p:nvSpPr>
-        <p:spPr>
-          <a:xfrm xmlns:a="http://schemas.openxmlformats.org/drawingml/2006/main">
-            <a:off x="762000" y="4486275"/>
-            <a:ext cx="2667000" cy="342900"/>
-          </a:xfrm>
-          <a:prstGeom xmlns:a="http://schemas.openxmlformats.org/drawingml/2006/main" prst="rect">
-            <a:avLst/>
-          </a:prstGeom>
-          <a:noFill xmlns:a="http://schemas.openxmlformats.org/drawingml/2006/main"/>
-          <a:ln xmlns:a="http://schemas.openxmlformats.org/drawingml/2006/main" w="0">
-            <a:noFill/>
-          </a:ln>
-        </p:spPr>
-        <p:txBody>
-          <a:bodyPr xmlns:a="http://schemas.openxmlformats.org/drawingml/2006/main" anchor="ctr">
-            <a:normAutofit fontScale="100000"/>
-          </a:bodyPr>
-          <a:lstStyle xmlns:a="http://schemas.openxmlformats.org/drawingml/2006/main"/>
-          <a:p xmlns:a="http://schemas.openxmlformats.org/drawingml/2006/main">
-            <a:pPr algn="l">
-              <a:defRPr sz="1500" b="1">
-                <a:solidFill>
-                  <a:srgbClr val="102A43"/>
-                </a:solidFill>
-                <a:latin typeface="Helvetica Neue"/>
-                <a:ea typeface="Helvetica Neue"/>
-                <a:cs typeface="Helvetica Neue"/>
-              </a:defRPr>
-            </a:pPr>
-            <a:r>
-              <a:rPr sz="1500" b="1">
-                <a:solidFill>
-                  <a:srgbClr val="102A43"/>
-                </a:solidFill>
-                <a:latin typeface="Helvetica Neue"/>
-                <a:ea typeface="Helvetica Neue"/>
-                <a:cs typeface="Helvetica Neue"/>
-              </a:rPr>
-              <a:t>Working prototype</a:t>
-            </a:r>
-          </a:p>
-        </p:txBody>
-      </p:sp>
-      <p:sp>
-        <p:nvSpPr>
-          <p:cNvPr id="25" name="">
-            <a:extLst xmlns:a="http://schemas.openxmlformats.org/drawingml/2006/main">
-              <a:ext uri="{FF2B5EF4-FFF2-40B4-BE49-F238E27FC236}">
-                <a16:creationId xmlns:a16="http://schemas.microsoft.com/office/drawing/2014/main" id="{C8EF062B-D265-4382-9CAB-D57BBC9F8441}"/>
-              </a:ext>
-            </a:extLst>
-          </p:cNvPr>
-          <p:cNvSpPr>
-            <a:spLocks xmlns:a="http://schemas.openxmlformats.org/drawingml/2006/main" noGrp="1"/>
-          </p:cNvSpPr>
-          <p:nvPr/>
-        </p:nvSpPr>
-        <p:spPr>
-          <a:xfrm xmlns:a="http://schemas.openxmlformats.org/drawingml/2006/main">
-            <a:off x="3638550" y="4486275"/>
-            <a:ext cx="666750" cy="342900"/>
-          </a:xfrm>
-          <a:prstGeom xmlns:a="http://schemas.openxmlformats.org/drawingml/2006/main" prst="rect">
-            <a:avLst/>
-          </a:prstGeom>
-          <a:noFill xmlns:a="http://schemas.openxmlformats.org/drawingml/2006/main"/>
-          <a:ln xmlns:a="http://schemas.openxmlformats.org/drawingml/2006/main" w="0">
-            <a:noFill/>
-          </a:ln>
-        </p:spPr>
-        <p:txBody>
-          <a:bodyPr xmlns:a="http://schemas.openxmlformats.org/drawingml/2006/main" anchor="ctr">
-            <a:normAutofit fontScale="100000"/>
-          </a:bodyPr>
-          <a:lstStyle xmlns:a="http://schemas.openxmlformats.org/drawingml/2006/main"/>
-          <a:p xmlns:a="http://schemas.openxmlformats.org/drawingml/2006/main">
-            <a:pPr algn="ctr">
-              <a:defRPr sz="1500" b="1">
-                <a:solidFill>
-                  <a:srgbClr val="1769D2"/>
-                </a:solidFill>
-                <a:latin typeface="Helvetica Neue"/>
-                <a:ea typeface="Helvetica Neue"/>
-                <a:cs typeface="Helvetica Neue"/>
-              </a:defRPr>
-            </a:pPr>
-            <a:r>
-              <a:rPr sz="1500" b="1">
-                <a:solidFill>
-                  <a:srgbClr val="1769D2"/>
-                </a:solidFill>
-                <a:latin typeface="Helvetica Neue"/>
-                <a:ea typeface="Helvetica Neue"/>
-                <a:cs typeface="Helvetica Neue"/>
-              </a:rPr>
-              <a:t>1</a:t>
-            </a:r>
-          </a:p>
-        </p:txBody>
-      </p:sp>
-      <p:sp>
-        <p:nvSpPr>
-          <p:cNvPr id="26" name="">
-            <a:extLst xmlns:a="http://schemas.openxmlformats.org/drawingml/2006/main">
-              <a:ext uri="{FF2B5EF4-FFF2-40B4-BE49-F238E27FC236}">
-                <a16:creationId xmlns:a16="http://schemas.microsoft.com/office/drawing/2014/main" id="{4CBE9E32-9F3D-4F96-B0AB-714D80996614}"/>
-              </a:ext>
-            </a:extLst>
-          </p:cNvPr>
-          <p:cNvSpPr>
-            <a:spLocks xmlns:a="http://schemas.openxmlformats.org/drawingml/2006/main" noGrp="1"/>
-          </p:cNvSpPr>
-          <p:nvPr/>
-        </p:nvSpPr>
-        <p:spPr>
-          <a:xfrm xmlns:a="http://schemas.openxmlformats.org/drawingml/2006/main">
-            <a:off x="4552950" y="4486275"/>
-            <a:ext cx="6438900" cy="342900"/>
-          </a:xfrm>
-          <a:prstGeom xmlns:a="http://schemas.openxmlformats.org/drawingml/2006/main" prst="rect">
-            <a:avLst/>
-          </a:prstGeom>
-          <a:noFill xmlns:a="http://schemas.openxmlformats.org/drawingml/2006/main"/>
-          <a:ln xmlns:a="http://schemas.openxmlformats.org/drawingml/2006/main" w="0">
-            <a:noFill/>
-          </a:ln>
-        </p:spPr>
-        <p:txBody>
-          <a:bodyPr xmlns:a="http://schemas.openxmlformats.org/drawingml/2006/main" anchor="ctr">
-            <a:normAutofit fontScale="100000"/>
-          </a:bodyPr>
-          <a:lstStyle xmlns:a="http://schemas.openxmlformats.org/drawingml/2006/main"/>
-          <a:p xmlns:a="http://schemas.openxmlformats.org/drawingml/2006/main">
-            <a:pPr algn="l">
-              <a:defRPr sz="1350" b="0">
-                <a:solidFill>
-                  <a:srgbClr val="17324D"/>
-                </a:solidFill>
-                <a:latin typeface="Helvetica Neue"/>
-                <a:ea typeface="Helvetica Neue"/>
-                <a:cs typeface="Helvetica Neue"/>
-              </a:defRPr>
-            </a:pPr>
-            <a:r>
-              <a:rPr sz="1350" b="0">
-                <a:solidFill>
-                  <a:srgbClr val="17324D"/>
-                </a:solidFill>
-                <a:latin typeface="Helvetica Neue"/>
-                <a:ea typeface="Helvetica Neue"/>
-                <a:cs typeface="Helvetica Neue"/>
-              </a:rPr>
-              <a:t>Live Gemini call, 9 tests and recorded browser demo</a:t>
-            </a:r>
-          </a:p>
-        </p:txBody>
-      </p:sp>
-      <p:sp>
-        <p:nvSpPr>
-          <p:cNvPr id="27" name="">
-            <a:extLst xmlns:a="http://schemas.openxmlformats.org/drawingml/2006/main">
-              <a:ext uri="{FF2B5EF4-FFF2-40B4-BE49-F238E27FC236}">
-                <a16:creationId xmlns:a16="http://schemas.microsoft.com/office/drawing/2014/main" id="{C6EC9A10-CC50-4951-B831-100E378949E4}"/>
-              </a:ext>
-            </a:extLst>
-          </p:cNvPr>
-          <p:cNvSpPr>
-            <a:spLocks xmlns:a="http://schemas.openxmlformats.org/drawingml/2006/main" noGrp="1"/>
-          </p:cNvSpPr>
-          <p:nvPr/>
-        </p:nvSpPr>
-        <p:spPr>
-          <a:xfrm xmlns:a="http://schemas.openxmlformats.org/drawingml/2006/main">
-            <a:off x="609600" y="5010150"/>
-            <a:ext cx="10648950" cy="495300"/>
-          </a:xfrm>
-          <a:prstGeom xmlns:a="http://schemas.openxmlformats.org/drawingml/2006/main" prst="roundRect">
-            <a:avLst>
-              <a:gd name="adj" fmla="val 15385"/>
-            </a:avLst>
-          </a:prstGeom>
-          <a:solidFill xmlns:a="http://schemas.openxmlformats.org/drawingml/2006/main">
-            <a:srgbClr val="F0F4F8"/>
-          </a:solidFill>
-          <a:ln xmlns:a="http://schemas.openxmlformats.org/drawingml/2006/main" w="0">
-            <a:noFill/>
-            <a:prstDash val="solid"/>
-          </a:ln>
-        </p:spPr>
-      </p:sp>
-      <p:sp>
-        <p:nvSpPr>
-          <p:cNvPr id="28" name="">
-            <a:extLst xmlns:a="http://schemas.openxmlformats.org/drawingml/2006/main">
-              <a:ext uri="{FF2B5EF4-FFF2-40B4-BE49-F238E27FC236}">
-                <a16:creationId xmlns:a16="http://schemas.microsoft.com/office/drawing/2014/main" id="{1AFEF28A-7687-4DD1-8AEE-D5C11C5C0465}"/>
-              </a:ext>
-            </a:extLst>
-          </p:cNvPr>
-          <p:cNvSpPr>
-            <a:spLocks xmlns:a="http://schemas.openxmlformats.org/drawingml/2006/main" noGrp="1"/>
-          </p:cNvSpPr>
-          <p:nvPr/>
-        </p:nvSpPr>
-        <p:spPr>
-          <a:xfrm xmlns:a="http://schemas.openxmlformats.org/drawingml/2006/main">
-            <a:off x="762000" y="5086350"/>
-            <a:ext cx="2667000" cy="342900"/>
-          </a:xfrm>
-          <a:prstGeom xmlns:a="http://schemas.openxmlformats.org/drawingml/2006/main" prst="rect">
-            <a:avLst/>
-          </a:prstGeom>
-          <a:noFill xmlns:a="http://schemas.openxmlformats.org/drawingml/2006/main"/>
-          <a:ln xmlns:a="http://schemas.openxmlformats.org/drawingml/2006/main" w="0">
-            <a:noFill/>
-          </a:ln>
-        </p:spPr>
-        <p:txBody>
-          <a:bodyPr xmlns:a="http://schemas.openxmlformats.org/drawingml/2006/main" anchor="ctr">
-            <a:normAutofit fontScale="100000"/>
-          </a:bodyPr>
-          <a:lstStyle xmlns:a="http://schemas.openxmlformats.org/drawingml/2006/main"/>
-          <a:p xmlns:a="http://schemas.openxmlformats.org/drawingml/2006/main">
-            <a:pPr algn="l">
-              <a:defRPr sz="1500" b="1">
-                <a:solidFill>
-                  <a:srgbClr val="102A43"/>
-                </a:solidFill>
-                <a:latin typeface="Helvetica Neue"/>
-                <a:ea typeface="Helvetica Neue"/>
-                <a:cs typeface="Helvetica Neue"/>
-              </a:defRPr>
-            </a:pPr>
-            <a:r>
-              <a:rPr sz="1500" b="1">
-                <a:solidFill>
-                  <a:srgbClr val="102A43"/>
-                </a:solidFill>
-                <a:latin typeface="Helvetica Neue"/>
-                <a:ea typeface="Helvetica Neue"/>
-                <a:cs typeface="Helvetica Neue"/>
-              </a:rPr>
-              <a:t>Ethical reasoning</a:t>
-            </a:r>
-          </a:p>
-        </p:txBody>
-      </p:sp>
-      <p:sp>
-        <p:nvSpPr>
-          <p:cNvPr id="29" name="">
-            <a:extLst xmlns:a="http://schemas.openxmlformats.org/drawingml/2006/main">
-              <a:ext uri="{FF2B5EF4-FFF2-40B4-BE49-F238E27FC236}">
-                <a16:creationId xmlns:a16="http://schemas.microsoft.com/office/drawing/2014/main" id="{929438D8-6A79-4245-B95C-2B11C1E93786}"/>
-              </a:ext>
-            </a:extLst>
-          </p:cNvPr>
-          <p:cNvSpPr>
-            <a:spLocks xmlns:a="http://schemas.openxmlformats.org/drawingml/2006/main" noGrp="1"/>
-          </p:cNvSpPr>
-          <p:nvPr/>
-        </p:nvSpPr>
-        <p:spPr>
-          <a:xfrm xmlns:a="http://schemas.openxmlformats.org/drawingml/2006/main">
-            <a:off x="3638550" y="5086350"/>
-            <a:ext cx="666750" cy="342900"/>
-          </a:xfrm>
-          <a:prstGeom xmlns:a="http://schemas.openxmlformats.org/drawingml/2006/main" prst="rect">
-            <a:avLst/>
-          </a:prstGeom>
-          <a:noFill xmlns:a="http://schemas.openxmlformats.org/drawingml/2006/main"/>
-          <a:ln xmlns:a="http://schemas.openxmlformats.org/drawingml/2006/main" w="0">
-            <a:noFill/>
-          </a:ln>
-        </p:spPr>
-        <p:txBody>
-          <a:bodyPr xmlns:a="http://schemas.openxmlformats.org/drawingml/2006/main" anchor="ctr">
-            <a:normAutofit fontScale="100000"/>
-          </a:bodyPr>
-          <a:lstStyle xmlns:a="http://schemas.openxmlformats.org/drawingml/2006/main"/>
-          <a:p xmlns:a="http://schemas.openxmlformats.org/drawingml/2006/main">
-            <a:pPr algn="ctr">
-              <a:defRPr sz="1500" b="1">
-                <a:solidFill>
-                  <a:srgbClr val="1769D2"/>
-                </a:solidFill>
-                <a:latin typeface="Helvetica Neue"/>
-                <a:ea typeface="Helvetica Neue"/>
-                <a:cs typeface="Helvetica Neue"/>
-              </a:defRPr>
-            </a:pPr>
-            <a:r>
-              <a:rPr sz="1500" b="1">
-                <a:solidFill>
-                  <a:srgbClr val="1769D2"/>
-                </a:solidFill>
-                <a:latin typeface="Helvetica Neue"/>
-                <a:ea typeface="Helvetica Neue"/>
-                <a:cs typeface="Helvetica Neue"/>
-              </a:rPr>
-              <a:t>2</a:t>
-            </a:r>
-          </a:p>
-        </p:txBody>
-      </p:sp>
-      <p:sp>
-        <p:nvSpPr>
-          <p:cNvPr id="30" name="">
-            <a:extLst xmlns:a="http://schemas.openxmlformats.org/drawingml/2006/main">
-              <a:ext uri="{FF2B5EF4-FFF2-40B4-BE49-F238E27FC236}">
-                <a16:creationId xmlns:a16="http://schemas.microsoft.com/office/drawing/2014/main" id="{7AC1044A-245A-4E9D-AAD3-F2EC78D92B8A}"/>
-              </a:ext>
-            </a:extLst>
-          </p:cNvPr>
-          <p:cNvSpPr>
-            <a:spLocks xmlns:a="http://schemas.openxmlformats.org/drawingml/2006/main" noGrp="1"/>
-          </p:cNvSpPr>
-          <p:nvPr/>
-        </p:nvSpPr>
-        <p:spPr>
-          <a:xfrm xmlns:a="http://schemas.openxmlformats.org/drawingml/2006/main">
-            <a:off x="4552950" y="5086350"/>
-            <a:ext cx="6438900" cy="342900"/>
-          </a:xfrm>
-          <a:prstGeom xmlns:a="http://schemas.openxmlformats.org/drawingml/2006/main" prst="rect">
-            <a:avLst/>
-          </a:prstGeom>
-          <a:noFill xmlns:a="http://schemas.openxmlformats.org/drawingml/2006/main"/>
-          <a:ln xmlns:a="http://schemas.openxmlformats.org/drawingml/2006/main" w="0">
-            <a:noFill/>
-          </a:ln>
-        </p:spPr>
-        <p:txBody>
-          <a:bodyPr xmlns:a="http://schemas.openxmlformats.org/drawingml/2006/main" anchor="ctr">
-            <a:normAutofit fontScale="100000"/>
-          </a:bodyPr>
-          <a:lstStyle xmlns:a="http://schemas.openxmlformats.org/drawingml/2006/main"/>
-          <a:p xmlns:a="http://schemas.openxmlformats.org/drawingml/2006/main">
-            <a:pPr algn="l">
-              <a:defRPr sz="1350" b="0">
-                <a:solidFill>
-                  <a:srgbClr val="17324D"/>
-                </a:solidFill>
-                <a:latin typeface="Helvetica Neue"/>
-                <a:ea typeface="Helvetica Neue"/>
-                <a:cs typeface="Helvetica Neue"/>
-              </a:defRPr>
-            </a:pPr>
-            <a:r>
-              <a:rPr sz="1350" b="0">
-                <a:solidFill>
-                  <a:srgbClr val="17324D"/>
-                </a:solidFill>
-                <a:latin typeface="Helvetica Neue"/>
-                <a:ea typeface="Helvetica Neue"/>
-                <a:cs typeface="Helvetica Neue"/>
-              </a:rPr>
-              <a:t>Specific harm, mitigations and residual limitations</a:t>
-            </a:r>
-          </a:p>
-        </p:txBody>
-      </p:sp>
-      <p:sp>
-        <p:nvSpPr>
-          <p:cNvPr id="31" name="">
-            <a:extLst xmlns:a="http://schemas.openxmlformats.org/drawingml/2006/main">
-              <a:ext uri="{FF2B5EF4-FFF2-40B4-BE49-F238E27FC236}">
-                <a16:creationId xmlns:a16="http://schemas.microsoft.com/office/drawing/2014/main" id="{67B21ACB-5D52-457C-8131-4BC8CC01725B}"/>
-              </a:ext>
-            </a:extLst>
-          </p:cNvPr>
-          <p:cNvSpPr>
-            <a:spLocks xmlns:a="http://schemas.openxmlformats.org/drawingml/2006/main" noGrp="1"/>
-          </p:cNvSpPr>
-          <p:nvPr/>
-        </p:nvSpPr>
-        <p:spPr>
-          <a:xfrm xmlns:a="http://schemas.openxmlformats.org/drawingml/2006/main">
-            <a:off x="609600" y="5848350"/>
-            <a:ext cx="10648950" cy="495300"/>
-          </a:xfrm>
-          <a:prstGeom xmlns:a="http://schemas.openxmlformats.org/drawingml/2006/main" prst="roundRect">
-            <a:avLst>
-              <a:gd name="adj" fmla="val 15385"/>
-            </a:avLst>
-          </a:prstGeom>
-          <a:solidFill xmlns:a="http://schemas.openxmlformats.org/drawingml/2006/main">
-            <a:srgbClr val="102A43"/>
-          </a:solidFill>
-          <a:ln xmlns:a="http://schemas.openxmlformats.org/drawingml/2006/main" w="0">
-            <a:noFill/>
-            <a:prstDash val="solid"/>
-          </a:ln>
-        </p:spPr>
-      </p:sp>
-      <p:sp>
-        <p:nvSpPr>
-          <p:cNvPr id="32" name="">
-            <a:extLst xmlns:a="http://schemas.openxmlformats.org/drawingml/2006/main">
-              <a:ext uri="{FF2B5EF4-FFF2-40B4-BE49-F238E27FC236}">
-                <a16:creationId xmlns:a16="http://schemas.microsoft.com/office/drawing/2014/main" id="{590CD550-CA7C-41B0-9D0E-74EF3C988A31}"/>
-              </a:ext>
-            </a:extLst>
-          </p:cNvPr>
-          <p:cNvSpPr>
-            <a:spLocks xmlns:a="http://schemas.openxmlformats.org/drawingml/2006/main" noGrp="1"/>
-          </p:cNvSpPr>
-          <p:nvPr/>
-        </p:nvSpPr>
-        <p:spPr>
-          <a:xfrm xmlns:a="http://schemas.openxmlformats.org/drawingml/2006/main">
-            <a:off x="819150" y="5924550"/>
-            <a:ext cx="10229850" cy="323850"/>
-          </a:xfrm>
-          <a:prstGeom xmlns:a="http://schemas.openxmlformats.org/drawingml/2006/main" prst="rect">
-            <a:avLst/>
-          </a:prstGeom>
-          <a:noFill xmlns:a="http://schemas.openxmlformats.org/drawingml/2006/main"/>
-          <a:ln xmlns:a="http://schemas.openxmlformats.org/drawingml/2006/main" w="0">
-            <a:noFill/>
-          </a:ln>
-        </p:spPr>
-        <p:txBody>
-          <a:bodyPr xmlns:a="http://schemas.openxmlformats.org/drawingml/2006/main" anchor="ctr">
-            <a:normAutofit fontScale="100000"/>
-          </a:bodyPr>
-          <a:lstStyle xmlns:a="http://schemas.openxmlformats.org/drawingml/2006/main"/>
-          <a:p xmlns:a="http://schemas.openxmlformats.org/drawingml/2006/main">
-            <a:pPr algn="ctr">
-              <a:defRPr sz="1500" b="1">
-                <a:solidFill>
-                  <a:srgbClr val="FFFFFF"/>
-                </a:solidFill>
-                <a:latin typeface="Helvetica Neue"/>
-                <a:ea typeface="Helvetica Neue"/>
-                <a:cs typeface="Helvetica Neue"/>
-              </a:defRPr>
-            </a:pPr>
-            <a:r>
-              <a:rPr sz="1500" b="1">
-                <a:solidFill>
-                  <a:srgbClr val="FFFFFF"/>
-                </a:solidFill>
-                <a:latin typeface="Helvetica Neue"/>
-                <a:ea typeface="Helvetica Neue"/>
-                <a:cs typeface="Helvetica Neue"/>
-              </a:rPr>
-              <a:t>Knockouts covered: meaningful AI integration, concrete SDG 10 issue, non-trivial user value</a:t>
-            </a:r>
-          </a:p>
-        </p:txBody>
-      </p:sp>
-    </p:spTree>
-    <p:extLst>
-      <p:ext uri="{BB962C8B-B14F-4D97-AF65-F5344CB8AC3E}">
-        <p14:creationId xmlns:p14="http://schemas.microsoft.com/office/powerpoint/2010/main" val="231617852"/>
+        <p14:creationId xmlns:p14="http://schemas.microsoft.com/office/powerpoint/2010/main" val="1302293718"/>
       </p:ext>
     </p:extLst>
   </p:cSld>

</xml_diff>

<commit_message>
Clean presentation labels and highlight SDG 10
</commit_message>
<xml_diff>
--- a/Term 1/Week 3/hackathon/presentation/MigrationHelp-Hackathon-3-final.pptx
+++ b/Term 1/Week 3/hackathon/presentation/MigrationHelp-Hackathon-3-final.pptx
@@ -2,20 +2,20 @@
 <file path=ppt/presentation.xml><?xml version="1.0" encoding="utf-8"?>
 <p:presentation xmlns:p="http://schemas.openxmlformats.org/presentationml/2006/main">
   <p:sldMasterIdLst>
-    <p:sldMasterId xmlns:r="http://schemas.openxmlformats.org/officeDocument/2006/relationships" id="2147483648" r:id="Rd6848b1a3418485b"/>
+    <p:sldMasterId xmlns:r="http://schemas.openxmlformats.org/officeDocument/2006/relationships" id="2147483648" r:id="R5b4910fa175e425b"/>
   </p:sldMasterIdLst>
   <p:notesMasterIdLst>
-    <p:notesMasterId xmlns:r="http://schemas.openxmlformats.org/officeDocument/2006/relationships" r:id="R95ed1b50bd95472a"/>
+    <p:notesMasterId xmlns:r="http://schemas.openxmlformats.org/officeDocument/2006/relationships" r:id="Rfcac769390b24caf"/>
   </p:notesMasterIdLst>
   <p:sldIdLst>
-    <p:sldId xmlns:r="http://schemas.openxmlformats.org/officeDocument/2006/relationships" id="256" r:id="Ra32f40b606d54857"/>
-    <p:sldId xmlns:r="http://schemas.openxmlformats.org/officeDocument/2006/relationships" id="257" r:id="R0f4feb8aa8c74e97"/>
-    <p:sldId xmlns:r="http://schemas.openxmlformats.org/officeDocument/2006/relationships" id="258" r:id="R21f5e465f5e943fb"/>
-    <p:sldId xmlns:r="http://schemas.openxmlformats.org/officeDocument/2006/relationships" id="259" r:id="Re84314ce320c4ef2"/>
-    <p:sldId xmlns:r="http://schemas.openxmlformats.org/officeDocument/2006/relationships" id="260" r:id="R9dd879062f344adf"/>
-    <p:sldId xmlns:r="http://schemas.openxmlformats.org/officeDocument/2006/relationships" id="261" r:id="R6fbbb28cad1f4aea"/>
-    <p:sldId xmlns:r="http://schemas.openxmlformats.org/officeDocument/2006/relationships" id="262" r:id="R3181eb4a4be84430"/>
-    <p:sldId xmlns:r="http://schemas.openxmlformats.org/officeDocument/2006/relationships" id="263" r:id="R05a27f34af3c4eed"/>
+    <p:sldId xmlns:r="http://schemas.openxmlformats.org/officeDocument/2006/relationships" id="256" r:id="R97ce46221c754915"/>
+    <p:sldId xmlns:r="http://schemas.openxmlformats.org/officeDocument/2006/relationships" id="257" r:id="R60d46a29038b49f4"/>
+    <p:sldId xmlns:r="http://schemas.openxmlformats.org/officeDocument/2006/relationships" id="258" r:id="R52c6ff8faa1f4a48"/>
+    <p:sldId xmlns:r="http://schemas.openxmlformats.org/officeDocument/2006/relationships" id="259" r:id="R811b49cb12d441d2"/>
+    <p:sldId xmlns:r="http://schemas.openxmlformats.org/officeDocument/2006/relationships" id="260" r:id="Ra2a01198c5c84cc8"/>
+    <p:sldId xmlns:r="http://schemas.openxmlformats.org/officeDocument/2006/relationships" id="261" r:id="R886da169c5314419"/>
+    <p:sldId xmlns:r="http://schemas.openxmlformats.org/officeDocument/2006/relationships" id="262" r:id="R37207dc41fed4f6e"/>
+    <p:sldId xmlns:r="http://schemas.openxmlformats.org/officeDocument/2006/relationships" id="263" r:id="R04a2393335c54454"/>
   </p:sldIdLst>
   <p:sldSz cx="12192000" cy="6858000"/>
   <p:notesSz cx="6858000" cy="9144000"/>
@@ -1022,7 +1022,7 @@
   </p:cSld>
   <p:clrMap bg1="lt1" tx1="dk1" bg2="lt2" tx2="dk2" accent1="accent1" accent2="accent2" accent3="accent3" accent4="accent4" accent5="accent5" accent6="accent6" hlink="hlink" folHlink="folHlink"/>
   <p:sldLayoutIdLst>
-    <p:sldLayoutId xmlns:r="http://schemas.openxmlformats.org/officeDocument/2006/relationships" id="2147483649" r:id="Rca1a56def80546e4"/>
+    <p:sldLayoutId xmlns:r="http://schemas.openxmlformats.org/officeDocument/2006/relationships" id="2147483649" r:id="R295da67c51364314"/>
   </p:sldLayoutIdLst>
   <p:txStyles>
     <p:titleStyle>
@@ -1573,7 +1573,7 @@
           <p:cNvPr id="9" name="">
             <a:extLst xmlns:a="http://schemas.openxmlformats.org/drawingml/2006/main">
               <a:ext uri="{FF2B5EF4-FFF2-40B4-BE49-F238E27FC236}">
-                <a16:creationId xmlns:a16="http://schemas.microsoft.com/office/drawing/2014/main" id="{E6932B2F-10BB-42D0-A1E5-8BBB2A4193C1}"/>
+                <a16:creationId xmlns:a16="http://schemas.microsoft.com/office/drawing/2014/main" id="{FF285ED0-620F-43AB-9902-96C2AE7DE4CF}"/>
               </a:ext>
             </a:extLst>
           </p:cNvPr>
@@ -1630,7 +1630,7 @@
           <p:cNvPr id="2" name="">
             <a:extLst xmlns:a="http://schemas.openxmlformats.org/drawingml/2006/main">
               <a:ext uri="{FF2B5EF4-FFF2-40B4-BE49-F238E27FC236}">
-                <a16:creationId xmlns:a16="http://schemas.microsoft.com/office/drawing/2014/main" id="{601A4D6F-4D73-42BC-96F2-E2039EE9C4F3}"/>
+                <a16:creationId xmlns:a16="http://schemas.microsoft.com/office/drawing/2014/main" id="{90C0681E-C235-4B90-A3CB-A762B224F887}"/>
               </a:ext>
             </a:extLst>
           </p:cNvPr>
@@ -1687,7 +1687,7 @@
           <p:cNvPr id="3" name="">
             <a:extLst xmlns:a="http://schemas.openxmlformats.org/drawingml/2006/main">
               <a:ext uri="{FF2B5EF4-FFF2-40B4-BE49-F238E27FC236}">
-                <a16:creationId xmlns:a16="http://schemas.microsoft.com/office/drawing/2014/main" id="{F3A65757-2425-41EE-BFCE-C90B4DA81C97}"/>
+                <a16:creationId xmlns:a16="http://schemas.microsoft.com/office/drawing/2014/main" id="{F450EAE2-72D8-483B-9982-44B4A71C6DBA}"/>
               </a:ext>
             </a:extLst>
           </p:cNvPr>
@@ -1744,7 +1744,7 @@
           <p:cNvPr id="4" name="">
             <a:extLst xmlns:a="http://schemas.openxmlformats.org/drawingml/2006/main">
               <a:ext uri="{FF2B5EF4-FFF2-40B4-BE49-F238E27FC236}">
-                <a16:creationId xmlns:a16="http://schemas.microsoft.com/office/drawing/2014/main" id="{8A9B0FEB-271A-4891-B195-671335AFDB01}"/>
+                <a16:creationId xmlns:a16="http://schemas.microsoft.com/office/drawing/2014/main" id="{7A4432D0-695C-40E8-9623-CE959AD80649}"/>
               </a:ext>
             </a:extLst>
           </p:cNvPr>
@@ -1775,7 +1775,7 @@
           <p:cNvPr id="5" name="">
             <a:extLst xmlns:a="http://schemas.openxmlformats.org/drawingml/2006/main">
               <a:ext uri="{FF2B5EF4-FFF2-40B4-BE49-F238E27FC236}">
-                <a16:creationId xmlns:a16="http://schemas.microsoft.com/office/drawing/2014/main" id="{334EBB9D-A7FF-426A-A8A5-0F5AAD575C49}"/>
+                <a16:creationId xmlns:a16="http://schemas.microsoft.com/office/drawing/2014/main" id="{D52E88B6-6819-48E6-ACEC-3CB373C54229}"/>
               </a:ext>
             </a:extLst>
           </p:cNvPr>
@@ -1832,7 +1832,7 @@
           <p:cNvPr id="6" name="">
             <a:extLst xmlns:a="http://schemas.openxmlformats.org/drawingml/2006/main">
               <a:ext uri="{FF2B5EF4-FFF2-40B4-BE49-F238E27FC236}">
-                <a16:creationId xmlns:a16="http://schemas.microsoft.com/office/drawing/2014/main" id="{0A3A41BC-7A5F-41B3-BB0D-C30AFECE714C}"/>
+                <a16:creationId xmlns:a16="http://schemas.microsoft.com/office/drawing/2014/main" id="{C4618012-7A1E-4A87-8A58-4FE0B365CEF8}"/>
               </a:ext>
             </a:extLst>
           </p:cNvPr>
@@ -1889,7 +1889,7 @@
           <p:cNvPr id="7" name="">
             <a:extLst xmlns:a="http://schemas.openxmlformats.org/drawingml/2006/main">
               <a:ext uri="{FF2B5EF4-FFF2-40B4-BE49-F238E27FC236}">
-                <a16:creationId xmlns:a16="http://schemas.microsoft.com/office/drawing/2014/main" id="{06E1C19B-230F-4043-8DD8-39133E8272E4}"/>
+                <a16:creationId xmlns:a16="http://schemas.microsoft.com/office/drawing/2014/main" id="{9C09A176-B736-47C8-B879-C2095C7EF8D8}"/>
               </a:ext>
             </a:extLst>
           </p:cNvPr>
@@ -1946,7 +1946,7 @@
           <p:cNvPr id="8" name="">
             <a:extLst xmlns:a="http://schemas.openxmlformats.org/drawingml/2006/main">
               <a:ext uri="{FF2B5EF4-FFF2-40B4-BE49-F238E27FC236}">
-                <a16:creationId xmlns:a16="http://schemas.microsoft.com/office/drawing/2014/main" id="{2DC3D7B4-D744-45B8-A1B3-514D625A428B}"/>
+                <a16:creationId xmlns:a16="http://schemas.microsoft.com/office/drawing/2014/main" id="{A9ED9950-D560-4CAB-BCB8-34FB849DF672}"/>
               </a:ext>
             </a:extLst>
           </p:cNvPr>
@@ -2001,7 +2001,7 @@
     </p:spTree>
     <p:extLst>
       <p:ext uri="{BB962C8B-B14F-4D97-AF65-F5344CB8AC3E}">
-        <p14:creationId xmlns:p14="http://schemas.microsoft.com/office/powerpoint/2010/main" val="699486017"/>
+        <p14:creationId xmlns:p14="http://schemas.microsoft.com/office/powerpoint/2010/main" val="1664594711"/>
       </p:ext>
     </p:extLst>
   </p:cSld>
@@ -2032,7 +2032,7 @@
           <p:cNvPr id="17" name="">
             <a:extLst xmlns:a="http://schemas.openxmlformats.org/drawingml/2006/main">
               <a:ext uri="{FF2B5EF4-FFF2-40B4-BE49-F238E27FC236}">
-                <a16:creationId xmlns:a16="http://schemas.microsoft.com/office/drawing/2014/main" id="{388A7767-7E8E-4D37-8B54-26AB0BDAD600}"/>
+                <a16:creationId xmlns:a16="http://schemas.microsoft.com/office/drawing/2014/main" id="{B7EF37B6-C797-4A85-99E3-7B2325D12358}"/>
               </a:ext>
             </a:extLst>
           </p:cNvPr>
@@ -2079,7 +2079,7 @@
                 <a:ea typeface="Helvetica Neue"/>
                 <a:cs typeface="Helvetica Neue"/>
               </a:rPr>
-              <a:t>PROBLEM DEFINITION · 2 POINTS</a:t>
+              <a:t>SDG 10 · REDUCED INEQUALITIES</a:t>
             </a:r>
           </a:p>
         </p:txBody>
@@ -2089,7 +2089,7 @@
           <p:cNvPr id="2" name="">
             <a:extLst xmlns:a="http://schemas.openxmlformats.org/drawingml/2006/main">
               <a:ext uri="{FF2B5EF4-FFF2-40B4-BE49-F238E27FC236}">
-                <a16:creationId xmlns:a16="http://schemas.microsoft.com/office/drawing/2014/main" id="{80ABF021-009F-4A96-8C64-8AA7EF89E768}"/>
+                <a16:creationId xmlns:a16="http://schemas.microsoft.com/office/drawing/2014/main" id="{31215633-685B-444F-B72F-971D23FEF096}"/>
               </a:ext>
             </a:extLst>
           </p:cNvPr>
@@ -2146,7 +2146,7 @@
           <p:cNvPr id="3" name="">
             <a:extLst xmlns:a="http://schemas.openxmlformats.org/drawingml/2006/main">
               <a:ext uri="{FF2B5EF4-FFF2-40B4-BE49-F238E27FC236}">
-                <a16:creationId xmlns:a16="http://schemas.microsoft.com/office/drawing/2014/main" id="{782EBF28-2BBF-4487-AC10-7309545C7C28}"/>
+                <a16:creationId xmlns:a16="http://schemas.microsoft.com/office/drawing/2014/main" id="{7EA0D946-6BDC-447E-8138-FA1C7980A013}"/>
               </a:ext>
             </a:extLst>
           </p:cNvPr>
@@ -2177,7 +2177,7 @@
           <p:cNvPr id="4" name="">
             <a:extLst xmlns:a="http://schemas.openxmlformats.org/drawingml/2006/main">
               <a:ext uri="{FF2B5EF4-FFF2-40B4-BE49-F238E27FC236}">
-                <a16:creationId xmlns:a16="http://schemas.microsoft.com/office/drawing/2014/main" id="{C49D3473-103A-4087-AF75-6DDC3E9A6D05}"/>
+                <a16:creationId xmlns:a16="http://schemas.microsoft.com/office/drawing/2014/main" id="{E70765F0-DC4B-49B1-AA69-1A335ECD7564}"/>
               </a:ext>
             </a:extLst>
           </p:cNvPr>
@@ -2234,7 +2234,7 @@
           <p:cNvPr id="5" name="">
             <a:extLst xmlns:a="http://schemas.openxmlformats.org/drawingml/2006/main">
               <a:ext uri="{FF2B5EF4-FFF2-40B4-BE49-F238E27FC236}">
-                <a16:creationId xmlns:a16="http://schemas.microsoft.com/office/drawing/2014/main" id="{BEF7C4E5-22EA-4AEA-B6AB-E399BC2B5130}"/>
+                <a16:creationId xmlns:a16="http://schemas.microsoft.com/office/drawing/2014/main" id="{186CCA56-CCC2-4BF0-B104-295F82246C62}"/>
               </a:ext>
             </a:extLst>
           </p:cNvPr>
@@ -2267,7 +2267,7 @@
           <p:cNvPr id="6" name="">
             <a:extLst xmlns:a="http://schemas.openxmlformats.org/drawingml/2006/main">
               <a:ext uri="{FF2B5EF4-FFF2-40B4-BE49-F238E27FC236}">
-                <a16:creationId xmlns:a16="http://schemas.microsoft.com/office/drawing/2014/main" id="{58FFA5E2-D5AA-4645-8ED3-EC3856F54C61}"/>
+                <a16:creationId xmlns:a16="http://schemas.microsoft.com/office/drawing/2014/main" id="{D6A80721-E007-4A22-BB83-EC3BBB6E0BDE}"/>
               </a:ext>
             </a:extLst>
           </p:cNvPr>
@@ -2324,7 +2324,7 @@
           <p:cNvPr id="7" name="">
             <a:extLst xmlns:a="http://schemas.openxmlformats.org/drawingml/2006/main">
               <a:ext uri="{FF2B5EF4-FFF2-40B4-BE49-F238E27FC236}">
-                <a16:creationId xmlns:a16="http://schemas.microsoft.com/office/drawing/2014/main" id="{7CBC8801-6F7B-4C59-9BA9-CA6CB04141EF}"/>
+                <a16:creationId xmlns:a16="http://schemas.microsoft.com/office/drawing/2014/main" id="{106EB31F-6E8C-45EC-A281-FD0948B367ED}"/>
               </a:ext>
             </a:extLst>
           </p:cNvPr>
@@ -2381,7 +2381,7 @@
           <p:cNvPr id="8" name="">
             <a:extLst xmlns:a="http://schemas.openxmlformats.org/drawingml/2006/main">
               <a:ext uri="{FF2B5EF4-FFF2-40B4-BE49-F238E27FC236}">
-                <a16:creationId xmlns:a16="http://schemas.microsoft.com/office/drawing/2014/main" id="{C7157606-92C9-42E0-8589-DCEE1B6ADC2D}"/>
+                <a16:creationId xmlns:a16="http://schemas.microsoft.com/office/drawing/2014/main" id="{8BC9B026-325F-44EB-B97C-EBA011644041}"/>
               </a:ext>
             </a:extLst>
           </p:cNvPr>
@@ -2414,7 +2414,7 @@
           <p:cNvPr id="9" name="">
             <a:extLst xmlns:a="http://schemas.openxmlformats.org/drawingml/2006/main">
               <a:ext uri="{FF2B5EF4-FFF2-40B4-BE49-F238E27FC236}">
-                <a16:creationId xmlns:a16="http://schemas.microsoft.com/office/drawing/2014/main" id="{18807E81-4CB1-4720-87DA-FBE8AEC4FA49}"/>
+                <a16:creationId xmlns:a16="http://schemas.microsoft.com/office/drawing/2014/main" id="{E8E58A56-4168-4F88-B821-81C4077F0D1C}"/>
               </a:ext>
             </a:extLst>
           </p:cNvPr>
@@ -2471,7 +2471,7 @@
           <p:cNvPr id="10" name="">
             <a:extLst xmlns:a="http://schemas.openxmlformats.org/drawingml/2006/main">
               <a:ext uri="{FF2B5EF4-FFF2-40B4-BE49-F238E27FC236}">
-                <a16:creationId xmlns:a16="http://schemas.microsoft.com/office/drawing/2014/main" id="{33F832BA-F90C-466D-9C94-0085641A40BD}"/>
+                <a16:creationId xmlns:a16="http://schemas.microsoft.com/office/drawing/2014/main" id="{2CC19E83-9C54-41EA-B7EF-173E9AF785D5}"/>
               </a:ext>
             </a:extLst>
           </p:cNvPr>
@@ -2528,7 +2528,7 @@
           <p:cNvPr id="11" name="">
             <a:extLst xmlns:a="http://schemas.openxmlformats.org/drawingml/2006/main">
               <a:ext uri="{FF2B5EF4-FFF2-40B4-BE49-F238E27FC236}">
-                <a16:creationId xmlns:a16="http://schemas.microsoft.com/office/drawing/2014/main" id="{67908D5A-19A3-429C-85F3-996BB409960F}"/>
+                <a16:creationId xmlns:a16="http://schemas.microsoft.com/office/drawing/2014/main" id="{CAF2977F-2653-41C5-974F-7CD2667AD0EA}"/>
               </a:ext>
             </a:extLst>
           </p:cNvPr>
@@ -2561,7 +2561,7 @@
           <p:cNvPr id="12" name="">
             <a:extLst xmlns:a="http://schemas.openxmlformats.org/drawingml/2006/main">
               <a:ext uri="{FF2B5EF4-FFF2-40B4-BE49-F238E27FC236}">
-                <a16:creationId xmlns:a16="http://schemas.microsoft.com/office/drawing/2014/main" id="{901413CB-A44C-47A1-BE00-FE30E2526E2E}"/>
+                <a16:creationId xmlns:a16="http://schemas.microsoft.com/office/drawing/2014/main" id="{604807D0-FBD0-4196-96F5-FCEE0071AB9A}"/>
               </a:ext>
             </a:extLst>
           </p:cNvPr>
@@ -2618,7 +2618,7 @@
           <p:cNvPr id="13" name="">
             <a:extLst xmlns:a="http://schemas.openxmlformats.org/drawingml/2006/main">
               <a:ext uri="{FF2B5EF4-FFF2-40B4-BE49-F238E27FC236}">
-                <a16:creationId xmlns:a16="http://schemas.microsoft.com/office/drawing/2014/main" id="{CA0FD724-07C5-4A1D-B9CD-FB26533D060C}"/>
+                <a16:creationId xmlns:a16="http://schemas.microsoft.com/office/drawing/2014/main" id="{5EC8ECEA-5BEE-4D6D-8643-6A0812E54F72}"/>
               </a:ext>
             </a:extLst>
           </p:cNvPr>
@@ -2665,7 +2665,7 @@
                 <a:ea typeface="Helvetica Neue"/>
                 <a:cs typeface="Helvetica Neue"/>
               </a:rPr>
-              <a:t>of migrants reported little or no Dutch in 2023</a:t>
+              <a:t>of migrants reported little or no Dutch in 2021</a:t>
             </a:r>
           </a:p>
         </p:txBody>
@@ -2675,7 +2675,7 @@
           <p:cNvPr id="14" name="">
             <a:extLst xmlns:a="http://schemas.openxmlformats.org/drawingml/2006/main">
               <a:ext uri="{FF2B5EF4-FFF2-40B4-BE49-F238E27FC236}">
-                <a16:creationId xmlns:a16="http://schemas.microsoft.com/office/drawing/2014/main" id="{33679F9D-5974-4028-88FF-7CF3D08571A0}"/>
+                <a16:creationId xmlns:a16="http://schemas.microsoft.com/office/drawing/2014/main" id="{43744CAC-F5C1-48D9-B3AF-421337F9D64C}"/>
               </a:ext>
             </a:extLst>
           </p:cNvPr>
@@ -2710,7 +2710,7 @@
           <p:cNvPr id="15" name="">
             <a:extLst xmlns:a="http://schemas.openxmlformats.org/drawingml/2006/main">
               <a:ext uri="{FF2B5EF4-FFF2-40B4-BE49-F238E27FC236}">
-                <a16:creationId xmlns:a16="http://schemas.microsoft.com/office/drawing/2014/main" id="{90F80482-A5AD-4DCC-ACBA-FE1ECB40AEB9}"/>
+                <a16:creationId xmlns:a16="http://schemas.microsoft.com/office/drawing/2014/main" id="{F0DFDF15-DCF0-4311-A886-F2F33309BEEC}"/>
               </a:ext>
             </a:extLst>
           </p:cNvPr>
@@ -2767,7 +2767,7 @@
           <p:cNvPr id="16" name="">
             <a:extLst xmlns:a="http://schemas.openxmlformats.org/drawingml/2006/main">
               <a:ext uri="{FF2B5EF4-FFF2-40B4-BE49-F238E27FC236}">
-                <a16:creationId xmlns:a16="http://schemas.microsoft.com/office/drawing/2014/main" id="{9BD1162F-68D6-4088-B27D-678ADD4D55F6}"/>
+                <a16:creationId xmlns:a16="http://schemas.microsoft.com/office/drawing/2014/main" id="{6B8843BC-521D-4AB9-B03E-5B845D66DB37}"/>
               </a:ext>
             </a:extLst>
           </p:cNvPr>
@@ -2822,7 +2822,7 @@
     </p:spTree>
     <p:extLst>
       <p:ext uri="{BB962C8B-B14F-4D97-AF65-F5344CB8AC3E}">
-        <p14:creationId xmlns:p14="http://schemas.microsoft.com/office/powerpoint/2010/main" val="1245200976"/>
+        <p14:creationId xmlns:p14="http://schemas.microsoft.com/office/powerpoint/2010/main" val="103103781"/>
       </p:ext>
     </p:extLst>
   </p:cSld>
@@ -2853,7 +2853,7 @@
           <p:cNvPr id="15" name="">
             <a:extLst xmlns:a="http://schemas.openxmlformats.org/drawingml/2006/main">
               <a:ext uri="{FF2B5EF4-FFF2-40B4-BE49-F238E27FC236}">
-                <a16:creationId xmlns:a16="http://schemas.microsoft.com/office/drawing/2014/main" id="{308FB85B-3AC2-477D-A666-D9765096E600}"/>
+                <a16:creationId xmlns:a16="http://schemas.microsoft.com/office/drawing/2014/main" id="{D8969D2B-5F3E-471B-832E-3BB5CAA59F2E}"/>
               </a:ext>
             </a:extLst>
           </p:cNvPr>
@@ -2900,7 +2900,7 @@
                 <a:ea typeface="Helvetica Neue"/>
                 <a:cs typeface="Helvetica Neue"/>
               </a:rPr>
-              <a:t>USER GROUP · 2 POINTS</a:t>
+              <a:t>INTENDED USERS</a:t>
             </a:r>
           </a:p>
         </p:txBody>
@@ -2910,7 +2910,7 @@
           <p:cNvPr id="2" name="">
             <a:extLst xmlns:a="http://schemas.openxmlformats.org/drawingml/2006/main">
               <a:ext uri="{FF2B5EF4-FFF2-40B4-BE49-F238E27FC236}">
-                <a16:creationId xmlns:a16="http://schemas.microsoft.com/office/drawing/2014/main" id="{5415736E-716A-443C-8F9C-86209C174D52}"/>
+                <a16:creationId xmlns:a16="http://schemas.microsoft.com/office/drawing/2014/main" id="{9EB98F19-8192-4EA7-8E94-1A418B7FC320}"/>
               </a:ext>
             </a:extLst>
           </p:cNvPr>
@@ -2967,7 +2967,7 @@
           <p:cNvPr id="3" name="">
             <a:extLst xmlns:a="http://schemas.openxmlformats.org/drawingml/2006/main">
               <a:ext uri="{FF2B5EF4-FFF2-40B4-BE49-F238E27FC236}">
-                <a16:creationId xmlns:a16="http://schemas.microsoft.com/office/drawing/2014/main" id="{8CBAAB1D-294C-42D0-9522-CDC20AAE96DF}"/>
+                <a16:creationId xmlns:a16="http://schemas.microsoft.com/office/drawing/2014/main" id="{188E9716-0C40-4BF1-B04F-70E35EF1D3F7}"/>
               </a:ext>
             </a:extLst>
           </p:cNvPr>
@@ -2998,7 +2998,7 @@
           <p:cNvPr id="4" name="">
             <a:extLst xmlns:a="http://schemas.openxmlformats.org/drawingml/2006/main">
               <a:ext uri="{FF2B5EF4-FFF2-40B4-BE49-F238E27FC236}">
-                <a16:creationId xmlns:a16="http://schemas.microsoft.com/office/drawing/2014/main" id="{A94220A4-6EAD-4D8C-BEFA-8EC928F2F0CB}"/>
+                <a16:creationId xmlns:a16="http://schemas.microsoft.com/office/drawing/2014/main" id="{38681B24-31C6-4AEA-B2C0-F635DEAFC1ED}"/>
               </a:ext>
             </a:extLst>
           </p:cNvPr>
@@ -3033,7 +3033,7 @@
           <p:cNvPr id="5" name="">
             <a:extLst xmlns:a="http://schemas.openxmlformats.org/drawingml/2006/main">
               <a:ext uri="{FF2B5EF4-FFF2-40B4-BE49-F238E27FC236}">
-                <a16:creationId xmlns:a16="http://schemas.microsoft.com/office/drawing/2014/main" id="{0EF8700E-ABBA-4298-BDA0-55A2219F1D82}"/>
+                <a16:creationId xmlns:a16="http://schemas.microsoft.com/office/drawing/2014/main" id="{BCA161DC-91D2-4D35-9195-1EC9E79384A6}"/>
               </a:ext>
             </a:extLst>
           </p:cNvPr>
@@ -3090,7 +3090,7 @@
           <p:cNvPr id="6" name="">
             <a:extLst xmlns:a="http://schemas.openxmlformats.org/drawingml/2006/main">
               <a:ext uri="{FF2B5EF4-FFF2-40B4-BE49-F238E27FC236}">
-                <a16:creationId xmlns:a16="http://schemas.microsoft.com/office/drawing/2014/main" id="{C24AC537-7BB4-44F6-B988-CB7EFA3A21B7}"/>
+                <a16:creationId xmlns:a16="http://schemas.microsoft.com/office/drawing/2014/main" id="{417D74B8-7209-47D1-B781-520CE8A48F06}"/>
               </a:ext>
             </a:extLst>
           </p:cNvPr>
@@ -3147,7 +3147,7 @@
           <p:cNvPr id="7" name="">
             <a:extLst xmlns:a="http://schemas.openxmlformats.org/drawingml/2006/main">
               <a:ext uri="{FF2B5EF4-FFF2-40B4-BE49-F238E27FC236}">
-                <a16:creationId xmlns:a16="http://schemas.microsoft.com/office/drawing/2014/main" id="{1CB0F1B8-8643-456F-95A5-24D07C6F385A}"/>
+                <a16:creationId xmlns:a16="http://schemas.microsoft.com/office/drawing/2014/main" id="{B1C6FF5A-4DB8-4731-8A23-238B4A232A61}"/>
               </a:ext>
             </a:extLst>
           </p:cNvPr>
@@ -3204,7 +3204,7 @@
           <p:cNvPr id="8" name="">
             <a:extLst xmlns:a="http://schemas.openxmlformats.org/drawingml/2006/main">
               <a:ext uri="{FF2B5EF4-FFF2-40B4-BE49-F238E27FC236}">
-                <a16:creationId xmlns:a16="http://schemas.microsoft.com/office/drawing/2014/main" id="{E925E9CA-BD1B-4B8F-B8D1-A8D241E6B6CB}"/>
+                <a16:creationId xmlns:a16="http://schemas.microsoft.com/office/drawing/2014/main" id="{9238A167-E03C-4727-9F2E-34128637C87D}"/>
               </a:ext>
             </a:extLst>
           </p:cNvPr>
@@ -3307,7 +3307,7 @@
           <p:cNvPr id="9" name="">
             <a:extLst xmlns:a="http://schemas.openxmlformats.org/drawingml/2006/main">
               <a:ext uri="{FF2B5EF4-FFF2-40B4-BE49-F238E27FC236}">
-                <a16:creationId xmlns:a16="http://schemas.microsoft.com/office/drawing/2014/main" id="{955A5482-77F2-43D6-9C9D-043D2EB1301E}"/>
+                <a16:creationId xmlns:a16="http://schemas.microsoft.com/office/drawing/2014/main" id="{05F2F26D-FD0E-459F-98F2-5198EFD7C15A}"/>
               </a:ext>
             </a:extLst>
           </p:cNvPr>
@@ -3364,7 +3364,7 @@
           <p:cNvPr id="10" name="">
             <a:extLst xmlns:a="http://schemas.openxmlformats.org/drawingml/2006/main">
               <a:ext uri="{FF2B5EF4-FFF2-40B4-BE49-F238E27FC236}">
-                <a16:creationId xmlns:a16="http://schemas.microsoft.com/office/drawing/2014/main" id="{CBFE61D0-44FB-40E8-8F78-9AA13C8F659A}"/>
+                <a16:creationId xmlns:a16="http://schemas.microsoft.com/office/drawing/2014/main" id="{58A6A2F1-9F35-4FB9-9643-68046B760878}"/>
               </a:ext>
             </a:extLst>
           </p:cNvPr>
@@ -3399,7 +3399,7 @@
           <p:cNvPr id="11" name="">
             <a:extLst xmlns:a="http://schemas.openxmlformats.org/drawingml/2006/main">
               <a:ext uri="{FF2B5EF4-FFF2-40B4-BE49-F238E27FC236}">
-                <a16:creationId xmlns:a16="http://schemas.microsoft.com/office/drawing/2014/main" id="{F04A770B-82C8-409B-9BBF-DCDAB3101567}"/>
+                <a16:creationId xmlns:a16="http://schemas.microsoft.com/office/drawing/2014/main" id="{DDA2CB58-A5B0-4162-90CA-1EBA7037E61B}"/>
               </a:ext>
             </a:extLst>
           </p:cNvPr>
@@ -3456,7 +3456,7 @@
           <p:cNvPr id="12" name="">
             <a:extLst xmlns:a="http://schemas.openxmlformats.org/drawingml/2006/main">
               <a:ext uri="{FF2B5EF4-FFF2-40B4-BE49-F238E27FC236}">
-                <a16:creationId xmlns:a16="http://schemas.microsoft.com/office/drawing/2014/main" id="{A8E44AE9-ACF3-456C-8C0B-044993AAB536}"/>
+                <a16:creationId xmlns:a16="http://schemas.microsoft.com/office/drawing/2014/main" id="{B121BBA8-1B68-40E5-BEEC-B0F2D12732FC}"/>
               </a:ext>
             </a:extLst>
           </p:cNvPr>
@@ -3605,7 +3605,7 @@
           <p:cNvPr id="13" name="">
             <a:extLst xmlns:a="http://schemas.openxmlformats.org/drawingml/2006/main">
               <a:ext uri="{FF2B5EF4-FFF2-40B4-BE49-F238E27FC236}">
-                <a16:creationId xmlns:a16="http://schemas.microsoft.com/office/drawing/2014/main" id="{922841B1-DFFE-42BF-A10F-B920E46906A3}"/>
+                <a16:creationId xmlns:a16="http://schemas.microsoft.com/office/drawing/2014/main" id="{2F2D229E-E0EF-4876-84AD-A9021F7814FE}"/>
               </a:ext>
             </a:extLst>
           </p:cNvPr>
@@ -3662,7 +3662,7 @@
           <p:cNvPr id="14" name="">
             <a:extLst xmlns:a="http://schemas.openxmlformats.org/drawingml/2006/main">
               <a:ext uri="{FF2B5EF4-FFF2-40B4-BE49-F238E27FC236}">
-                <a16:creationId xmlns:a16="http://schemas.microsoft.com/office/drawing/2014/main" id="{21219C4D-9143-404E-8363-7CA409315C24}"/>
+                <a16:creationId xmlns:a16="http://schemas.microsoft.com/office/drawing/2014/main" id="{A729EC77-3D62-4A15-BB9C-5423DCB4B07B}"/>
               </a:ext>
             </a:extLst>
           </p:cNvPr>
@@ -3717,7 +3717,7 @@
     </p:spTree>
     <p:extLst>
       <p:ext uri="{BB962C8B-B14F-4D97-AF65-F5344CB8AC3E}">
-        <p14:creationId xmlns:p14="http://schemas.microsoft.com/office/powerpoint/2010/main" val="679383959"/>
+        <p14:creationId xmlns:p14="http://schemas.microsoft.com/office/powerpoint/2010/main" val="1789542174"/>
       </p:ext>
     </p:extLst>
   </p:cSld>
@@ -3748,7 +3748,7 @@
           <p:cNvPr id="16" name="">
             <a:extLst xmlns:a="http://schemas.openxmlformats.org/drawingml/2006/main">
               <a:ext uri="{FF2B5EF4-FFF2-40B4-BE49-F238E27FC236}">
-                <a16:creationId xmlns:a16="http://schemas.microsoft.com/office/drawing/2014/main" id="{862C2C37-D85E-415D-B809-73CDAF045A6A}"/>
+                <a16:creationId xmlns:a16="http://schemas.microsoft.com/office/drawing/2014/main" id="{01CF6CC4-0B05-4762-A80B-03B8778B081F}"/>
               </a:ext>
             </a:extLst>
           </p:cNvPr>
@@ -3795,7 +3795,7 @@
                 <a:ea typeface="Helvetica Neue"/>
                 <a:cs typeface="Helvetica Neue"/>
               </a:rPr>
-              <a:t>SOLUTION DESCRIPTION · 2 POINTS</a:t>
+              <a:t>PRODUCT WALKTHROUGH</a:t>
             </a:r>
           </a:p>
         </p:txBody>
@@ -3805,7 +3805,7 @@
           <p:cNvPr id="2" name="">
             <a:extLst xmlns:a="http://schemas.openxmlformats.org/drawingml/2006/main">
               <a:ext uri="{FF2B5EF4-FFF2-40B4-BE49-F238E27FC236}">
-                <a16:creationId xmlns:a16="http://schemas.microsoft.com/office/drawing/2014/main" id="{6FE95FA4-E363-4BAC-883D-A1FD528DE832}"/>
+                <a16:creationId xmlns:a16="http://schemas.microsoft.com/office/drawing/2014/main" id="{74F312F9-521B-4AE9-A070-A631229ADDEF}"/>
               </a:ext>
             </a:extLst>
           </p:cNvPr>
@@ -3862,7 +3862,7 @@
           <p:cNvPr id="3" name="">
             <a:extLst xmlns:a="http://schemas.openxmlformats.org/drawingml/2006/main">
               <a:ext uri="{FF2B5EF4-FFF2-40B4-BE49-F238E27FC236}">
-                <a16:creationId xmlns:a16="http://schemas.microsoft.com/office/drawing/2014/main" id="{CFCC4C29-0DCA-4688-8F1A-05BE1CED9242}"/>
+                <a16:creationId xmlns:a16="http://schemas.microsoft.com/office/drawing/2014/main" id="{7C0AC6F1-F241-483D-8C70-1D0D54DDE6B2}"/>
               </a:ext>
             </a:extLst>
           </p:cNvPr>
@@ -3897,7 +3897,7 @@
           <p:nvPr/>
         </p:nvPicPr>
         <p:blipFill>
-          <a:blip xmlns:r="http://schemas.openxmlformats.org/officeDocument/2006/relationships" xmlns:a="http://schemas.openxmlformats.org/drawingml/2006/main" r:embed="Rc8be199bca244eb7"/>
+          <a:blip xmlns:r="http://schemas.openxmlformats.org/officeDocument/2006/relationships" xmlns:a="http://schemas.openxmlformats.org/drawingml/2006/main" r:embed="Rd77a6a73f4d349bf"/>
           <a:srcRect xmlns:a="http://schemas.openxmlformats.org/drawingml/2006/main" l="0" t="3659" r="0" b="3659"/>
           <a:stretch xmlns:a="http://schemas.openxmlformats.org/drawingml/2006/main">
             <a:fillRect l="0" t="0" r="0" b="0"/>
@@ -3920,7 +3920,7 @@
           <p:cNvPr id="5" name="">
             <a:extLst xmlns:a="http://schemas.openxmlformats.org/drawingml/2006/main">
               <a:ext uri="{FF2B5EF4-FFF2-40B4-BE49-F238E27FC236}">
-                <a16:creationId xmlns:a16="http://schemas.microsoft.com/office/drawing/2014/main" id="{70A1CED1-4BC2-4825-8B26-411FD6A91C4B}"/>
+                <a16:creationId xmlns:a16="http://schemas.microsoft.com/office/drawing/2014/main" id="{F9BFC476-C7E8-4ED0-B824-07331DCAB8D1}"/>
               </a:ext>
             </a:extLst>
           </p:cNvPr>
@@ -3953,7 +3953,7 @@
           <p:cNvPr id="6" name="">
             <a:extLst xmlns:a="http://schemas.openxmlformats.org/drawingml/2006/main">
               <a:ext uri="{FF2B5EF4-FFF2-40B4-BE49-F238E27FC236}">
-                <a16:creationId xmlns:a16="http://schemas.microsoft.com/office/drawing/2014/main" id="{565A2CF0-88B5-4487-BE75-77E21227F1EA}"/>
+                <a16:creationId xmlns:a16="http://schemas.microsoft.com/office/drawing/2014/main" id="{62604CCC-6221-4F65-9695-2AE2F7C36720}"/>
               </a:ext>
             </a:extLst>
           </p:cNvPr>
@@ -4010,7 +4010,7 @@
           <p:cNvPr id="7" name="">
             <a:extLst xmlns:a="http://schemas.openxmlformats.org/drawingml/2006/main">
               <a:ext uri="{FF2B5EF4-FFF2-40B4-BE49-F238E27FC236}">
-                <a16:creationId xmlns:a16="http://schemas.microsoft.com/office/drawing/2014/main" id="{7B07A512-3D84-4617-982B-2BE8D81BCB39}"/>
+                <a16:creationId xmlns:a16="http://schemas.microsoft.com/office/drawing/2014/main" id="{32BB7C08-FFF9-4CCE-92EF-5A102D58521E}"/>
               </a:ext>
             </a:extLst>
           </p:cNvPr>
@@ -4067,7 +4067,7 @@
           <p:cNvPr id="8" name="">
             <a:extLst xmlns:a="http://schemas.openxmlformats.org/drawingml/2006/main">
               <a:ext uri="{FF2B5EF4-FFF2-40B4-BE49-F238E27FC236}">
-                <a16:creationId xmlns:a16="http://schemas.microsoft.com/office/drawing/2014/main" id="{E37E9349-A2DE-4E75-B2C5-6AF3954F99A8}"/>
+                <a16:creationId xmlns:a16="http://schemas.microsoft.com/office/drawing/2014/main" id="{F28C0EB6-451E-46DA-B078-E9926F301863}"/>
               </a:ext>
             </a:extLst>
           </p:cNvPr>
@@ -4124,7 +4124,7 @@
           <p:cNvPr id="9" name="">
             <a:extLst xmlns:a="http://schemas.openxmlformats.org/drawingml/2006/main">
               <a:ext uri="{FF2B5EF4-FFF2-40B4-BE49-F238E27FC236}">
-                <a16:creationId xmlns:a16="http://schemas.microsoft.com/office/drawing/2014/main" id="{E0DDE6DF-8930-4B6F-982E-6E270E7E842D}"/>
+                <a16:creationId xmlns:a16="http://schemas.microsoft.com/office/drawing/2014/main" id="{38F60EBB-D404-4CBF-A370-CB31FC0007EB}"/>
               </a:ext>
             </a:extLst>
           </p:cNvPr>
@@ -4181,7 +4181,7 @@
           <p:cNvPr id="10" name="">
             <a:extLst xmlns:a="http://schemas.openxmlformats.org/drawingml/2006/main">
               <a:ext uri="{FF2B5EF4-FFF2-40B4-BE49-F238E27FC236}">
-                <a16:creationId xmlns:a16="http://schemas.microsoft.com/office/drawing/2014/main" id="{88F7CC36-5D11-4400-BB51-CDAC6F3F8A11}"/>
+                <a16:creationId xmlns:a16="http://schemas.microsoft.com/office/drawing/2014/main" id="{978D741F-930B-4B72-B77E-730CF1DCA523}"/>
               </a:ext>
             </a:extLst>
           </p:cNvPr>
@@ -4238,7 +4238,7 @@
           <p:cNvPr id="11" name="">
             <a:extLst xmlns:a="http://schemas.openxmlformats.org/drawingml/2006/main">
               <a:ext uri="{FF2B5EF4-FFF2-40B4-BE49-F238E27FC236}">
-                <a16:creationId xmlns:a16="http://schemas.microsoft.com/office/drawing/2014/main" id="{046FB030-C132-438E-9339-CB24C119980C}"/>
+                <a16:creationId xmlns:a16="http://schemas.microsoft.com/office/drawing/2014/main" id="{49FFE74E-5617-4DAE-98D8-2A327F9108C2}"/>
               </a:ext>
             </a:extLst>
           </p:cNvPr>
@@ -4295,7 +4295,7 @@
           <p:cNvPr id="12" name="">
             <a:extLst xmlns:a="http://schemas.openxmlformats.org/drawingml/2006/main">
               <a:ext uri="{FF2B5EF4-FFF2-40B4-BE49-F238E27FC236}">
-                <a16:creationId xmlns:a16="http://schemas.microsoft.com/office/drawing/2014/main" id="{7210E6AE-9F60-4F03-A66A-5B8EAE7FDC8D}"/>
+                <a16:creationId xmlns:a16="http://schemas.microsoft.com/office/drawing/2014/main" id="{074270C5-B33D-4BA9-84EC-9498A055A3AB}"/>
               </a:ext>
             </a:extLst>
           </p:cNvPr>
@@ -4352,7 +4352,7 @@
           <p:cNvPr id="13" name="">
             <a:extLst xmlns:a="http://schemas.openxmlformats.org/drawingml/2006/main">
               <a:ext uri="{FF2B5EF4-FFF2-40B4-BE49-F238E27FC236}">
-                <a16:creationId xmlns:a16="http://schemas.microsoft.com/office/drawing/2014/main" id="{30B6256E-CB45-4D28-82EA-CF0D10DAF8DB}"/>
+                <a16:creationId xmlns:a16="http://schemas.microsoft.com/office/drawing/2014/main" id="{07C2B886-D0D9-48AF-9FC1-03DE30171E0C}"/>
               </a:ext>
             </a:extLst>
           </p:cNvPr>
@@ -4409,7 +4409,7 @@
           <p:cNvPr id="14" name="">
             <a:extLst xmlns:a="http://schemas.openxmlformats.org/drawingml/2006/main">
               <a:ext uri="{FF2B5EF4-FFF2-40B4-BE49-F238E27FC236}">
-                <a16:creationId xmlns:a16="http://schemas.microsoft.com/office/drawing/2014/main" id="{CC875E46-8597-48AF-9B92-AAE1714B5436}"/>
+                <a16:creationId xmlns:a16="http://schemas.microsoft.com/office/drawing/2014/main" id="{41A67BAD-8789-4C6C-9332-701E97CDFEC2}"/>
               </a:ext>
             </a:extLst>
           </p:cNvPr>
@@ -4466,7 +4466,7 @@
           <p:cNvPr id="15" name="">
             <a:extLst xmlns:a="http://schemas.openxmlformats.org/drawingml/2006/main">
               <a:ext uri="{FF2B5EF4-FFF2-40B4-BE49-F238E27FC236}">
-                <a16:creationId xmlns:a16="http://schemas.microsoft.com/office/drawing/2014/main" id="{239D052F-A5AF-41A8-83E1-F8653EF7F11D}"/>
+                <a16:creationId xmlns:a16="http://schemas.microsoft.com/office/drawing/2014/main" id="{1F9B9C67-0973-45C5-AF38-B654503B4404}"/>
               </a:ext>
             </a:extLst>
           </p:cNvPr>
@@ -4521,7 +4521,7 @@
     </p:spTree>
     <p:extLst>
       <p:ext uri="{BB962C8B-B14F-4D97-AF65-F5344CB8AC3E}">
-        <p14:creationId xmlns:p14="http://schemas.microsoft.com/office/powerpoint/2010/main" val="953533108"/>
+        <p14:creationId xmlns:p14="http://schemas.microsoft.com/office/powerpoint/2010/main" val="1066854821"/>
       </p:ext>
     </p:extLst>
   </p:cSld>
@@ -4552,7 +4552,7 @@
           <p:cNvPr id="19" name="">
             <a:extLst xmlns:a="http://schemas.openxmlformats.org/drawingml/2006/main">
               <a:ext uri="{FF2B5EF4-FFF2-40B4-BE49-F238E27FC236}">
-                <a16:creationId xmlns:a16="http://schemas.microsoft.com/office/drawing/2014/main" id="{6C4D806D-830B-4AAC-B8BD-E3EDFABA7FCA}"/>
+                <a16:creationId xmlns:a16="http://schemas.microsoft.com/office/drawing/2014/main" id="{4BB7660B-BF39-44E0-ADD6-A752121804F0}"/>
               </a:ext>
             </a:extLst>
           </p:cNvPr>
@@ -4599,7 +4599,7 @@
                 <a:ea typeface="Helvetica Neue"/>
                 <a:cs typeface="Helvetica Neue"/>
               </a:rPr>
-              <a:t>ACTUAL CODE FROM ASSISTANT.PY</a:t>
+              <a:t>GEMINI API</a:t>
             </a:r>
           </a:p>
         </p:txBody>
@@ -4609,7 +4609,7 @@
           <p:cNvPr id="2" name="">
             <a:extLst xmlns:a="http://schemas.openxmlformats.org/drawingml/2006/main">
               <a:ext uri="{FF2B5EF4-FFF2-40B4-BE49-F238E27FC236}">
-                <a16:creationId xmlns:a16="http://schemas.microsoft.com/office/drawing/2014/main" id="{8AF42746-832D-4FFB-B39D-F281AF47CD11}"/>
+                <a16:creationId xmlns:a16="http://schemas.microsoft.com/office/drawing/2014/main" id="{7C4DDD16-C4B5-4949-9DA9-F4151BEFA25A}"/>
               </a:ext>
             </a:extLst>
           </p:cNvPr>
@@ -4666,7 +4666,7 @@
           <p:cNvPr id="3" name="">
             <a:extLst xmlns:a="http://schemas.openxmlformats.org/drawingml/2006/main">
               <a:ext uri="{FF2B5EF4-FFF2-40B4-BE49-F238E27FC236}">
-                <a16:creationId xmlns:a16="http://schemas.microsoft.com/office/drawing/2014/main" id="{179491D9-37FB-4774-9C08-F9775E18B4CD}"/>
+                <a16:creationId xmlns:a16="http://schemas.microsoft.com/office/drawing/2014/main" id="{43E12B0E-7546-4C2D-94E4-BE3463322766}"/>
               </a:ext>
             </a:extLst>
           </p:cNvPr>
@@ -4697,7 +4697,7 @@
           <p:cNvPr id="4" name="">
             <a:extLst xmlns:a="http://schemas.openxmlformats.org/drawingml/2006/main">
               <a:ext uri="{FF2B5EF4-FFF2-40B4-BE49-F238E27FC236}">
-                <a16:creationId xmlns:a16="http://schemas.microsoft.com/office/drawing/2014/main" id="{F2E53206-FED6-42DA-AC5B-CD19DEDFA68A}"/>
+                <a16:creationId xmlns:a16="http://schemas.microsoft.com/office/drawing/2014/main" id="{BC9C7117-19A1-4401-92B2-B74625950A58}"/>
               </a:ext>
             </a:extLst>
           </p:cNvPr>
@@ -4754,7 +4754,7 @@
           <p:cNvPr id="5" name="">
             <a:extLst xmlns:a="http://schemas.openxmlformats.org/drawingml/2006/main">
               <a:ext uri="{FF2B5EF4-FFF2-40B4-BE49-F238E27FC236}">
-                <a16:creationId xmlns:a16="http://schemas.microsoft.com/office/drawing/2014/main" id="{02101BEF-9FC5-46DB-B753-ADE68C58B866}"/>
+                <a16:creationId xmlns:a16="http://schemas.microsoft.com/office/drawing/2014/main" id="{12A320C2-784D-4E58-A113-ED63B90C3AA4}"/>
               </a:ext>
             </a:extLst>
           </p:cNvPr>
@@ -4787,7 +4787,7 @@
           <p:cNvPr id="6" name="">
             <a:extLst xmlns:a="http://schemas.openxmlformats.org/drawingml/2006/main">
               <a:ext uri="{FF2B5EF4-FFF2-40B4-BE49-F238E27FC236}">
-                <a16:creationId xmlns:a16="http://schemas.microsoft.com/office/drawing/2014/main" id="{D6443EAE-218B-444C-BF16-AA30B73DF905}"/>
+                <a16:creationId xmlns:a16="http://schemas.microsoft.com/office/drawing/2014/main" id="{5CB834E5-0814-4CAE-8EFA-4D0412D89289}"/>
               </a:ext>
             </a:extLst>
           </p:cNvPr>
@@ -5199,7 +5199,7 @@
           <p:cNvPr id="7" name="">
             <a:extLst xmlns:a="http://schemas.openxmlformats.org/drawingml/2006/main">
               <a:ext uri="{FF2B5EF4-FFF2-40B4-BE49-F238E27FC236}">
-                <a16:creationId xmlns:a16="http://schemas.microsoft.com/office/drawing/2014/main" id="{28FA783C-8429-4F05-8620-A6818554404C}"/>
+                <a16:creationId xmlns:a16="http://schemas.microsoft.com/office/drawing/2014/main" id="{4C76D10E-6BE7-4400-8F4D-E8680479C936}"/>
               </a:ext>
             </a:extLst>
           </p:cNvPr>
@@ -5256,7 +5256,7 @@
           <p:cNvPr id="8" name="">
             <a:extLst xmlns:a="http://schemas.openxmlformats.org/drawingml/2006/main">
               <a:ext uri="{FF2B5EF4-FFF2-40B4-BE49-F238E27FC236}">
-                <a16:creationId xmlns:a16="http://schemas.microsoft.com/office/drawing/2014/main" id="{D0A2DD86-D6C9-492B-B73D-D0EC3FAE7D8B}"/>
+                <a16:creationId xmlns:a16="http://schemas.microsoft.com/office/drawing/2014/main" id="{E851EE41-E997-4BD3-A266-DB63E6529AE6}"/>
               </a:ext>
             </a:extLst>
           </p:cNvPr>
@@ -5313,7 +5313,7 @@
           <p:cNvPr id="9" name="">
             <a:extLst xmlns:a="http://schemas.openxmlformats.org/drawingml/2006/main">
               <a:ext uri="{FF2B5EF4-FFF2-40B4-BE49-F238E27FC236}">
-                <a16:creationId xmlns:a16="http://schemas.microsoft.com/office/drawing/2014/main" id="{81FB360C-6BE3-4F14-A60A-AB1B9C3C4142}"/>
+                <a16:creationId xmlns:a16="http://schemas.microsoft.com/office/drawing/2014/main" id="{87351FD7-4254-4413-8FAB-8A05C934C87C}"/>
               </a:ext>
             </a:extLst>
           </p:cNvPr>
@@ -5370,7 +5370,7 @@
           <p:cNvPr id="10" name="">
             <a:extLst xmlns:a="http://schemas.openxmlformats.org/drawingml/2006/main">
               <a:ext uri="{FF2B5EF4-FFF2-40B4-BE49-F238E27FC236}">
-                <a16:creationId xmlns:a16="http://schemas.microsoft.com/office/drawing/2014/main" id="{0BF1908A-A157-49C4-9D7B-0FA731BE1B87}"/>
+                <a16:creationId xmlns:a16="http://schemas.microsoft.com/office/drawing/2014/main" id="{8E0F5B26-24AF-43B5-977C-3E43048B359D}"/>
               </a:ext>
             </a:extLst>
           </p:cNvPr>
@@ -5427,7 +5427,7 @@
           <p:cNvPr id="11" name="">
             <a:extLst xmlns:a="http://schemas.openxmlformats.org/drawingml/2006/main">
               <a:ext uri="{FF2B5EF4-FFF2-40B4-BE49-F238E27FC236}">
-                <a16:creationId xmlns:a16="http://schemas.microsoft.com/office/drawing/2014/main" id="{917F36ED-3042-4E77-B577-6954362E1CE8}"/>
+                <a16:creationId xmlns:a16="http://schemas.microsoft.com/office/drawing/2014/main" id="{A5596535-99E7-4FF8-8D7D-C1187B271C84}"/>
               </a:ext>
             </a:extLst>
           </p:cNvPr>
@@ -5484,7 +5484,7 @@
           <p:cNvPr id="12" name="">
             <a:extLst xmlns:a="http://schemas.openxmlformats.org/drawingml/2006/main">
               <a:ext uri="{FF2B5EF4-FFF2-40B4-BE49-F238E27FC236}">
-                <a16:creationId xmlns:a16="http://schemas.microsoft.com/office/drawing/2014/main" id="{12D43BC2-C52F-47C2-B48C-113783E58996}"/>
+                <a16:creationId xmlns:a16="http://schemas.microsoft.com/office/drawing/2014/main" id="{B763E4FA-7607-433E-B8C0-0008F8B5F8FA}"/>
               </a:ext>
             </a:extLst>
           </p:cNvPr>
@@ -5541,7 +5541,7 @@
           <p:cNvPr id="13" name="">
             <a:extLst xmlns:a="http://schemas.openxmlformats.org/drawingml/2006/main">
               <a:ext uri="{FF2B5EF4-FFF2-40B4-BE49-F238E27FC236}">
-                <a16:creationId xmlns:a16="http://schemas.microsoft.com/office/drawing/2014/main" id="{CD42D825-7412-4F7F-A3D9-0797233E8D7E}"/>
+                <a16:creationId xmlns:a16="http://schemas.microsoft.com/office/drawing/2014/main" id="{8C68A667-16AD-4143-B3FD-0D26AF20B5B1}"/>
               </a:ext>
             </a:extLst>
           </p:cNvPr>
@@ -5598,7 +5598,7 @@
           <p:cNvPr id="14" name="">
             <a:extLst xmlns:a="http://schemas.openxmlformats.org/drawingml/2006/main">
               <a:ext uri="{FF2B5EF4-FFF2-40B4-BE49-F238E27FC236}">
-                <a16:creationId xmlns:a16="http://schemas.microsoft.com/office/drawing/2014/main" id="{E7A579EA-8719-4036-B27C-ADDFF83FF5FA}"/>
+                <a16:creationId xmlns:a16="http://schemas.microsoft.com/office/drawing/2014/main" id="{EDB3CD4D-0EC8-47EC-BFC2-E5A9F8DFA94B}"/>
               </a:ext>
             </a:extLst>
           </p:cNvPr>
@@ -5655,7 +5655,7 @@
           <p:cNvPr id="15" name="">
             <a:extLst xmlns:a="http://schemas.openxmlformats.org/drawingml/2006/main">
               <a:ext uri="{FF2B5EF4-FFF2-40B4-BE49-F238E27FC236}">
-                <a16:creationId xmlns:a16="http://schemas.microsoft.com/office/drawing/2014/main" id="{3356C2CB-E7D4-4193-8AD3-A694466B6C13}"/>
+                <a16:creationId xmlns:a16="http://schemas.microsoft.com/office/drawing/2014/main" id="{AAA16B37-CF0B-4B26-A5B7-8816E535151B}"/>
               </a:ext>
             </a:extLst>
           </p:cNvPr>
@@ -5712,7 +5712,7 @@
           <p:cNvPr id="16" name="">
             <a:extLst xmlns:a="http://schemas.openxmlformats.org/drawingml/2006/main">
               <a:ext uri="{FF2B5EF4-FFF2-40B4-BE49-F238E27FC236}">
-                <a16:creationId xmlns:a16="http://schemas.microsoft.com/office/drawing/2014/main" id="{AB0E49A4-4C26-4D50-9B17-CB76FFC21172}"/>
+                <a16:creationId xmlns:a16="http://schemas.microsoft.com/office/drawing/2014/main" id="{1701B334-E243-4A5D-A78F-04E7343D3F16}"/>
               </a:ext>
             </a:extLst>
           </p:cNvPr>
@@ -5769,7 +5769,7 @@
           <p:cNvPr id="17" name="">
             <a:extLst xmlns:a="http://schemas.openxmlformats.org/drawingml/2006/main">
               <a:ext uri="{FF2B5EF4-FFF2-40B4-BE49-F238E27FC236}">
-                <a16:creationId xmlns:a16="http://schemas.microsoft.com/office/drawing/2014/main" id="{CEF5BF50-041E-453F-81E7-5065D0D31E69}"/>
+                <a16:creationId xmlns:a16="http://schemas.microsoft.com/office/drawing/2014/main" id="{1239B10C-0651-4650-88CD-D057FF6803D5}"/>
               </a:ext>
             </a:extLst>
           </p:cNvPr>
@@ -5826,7 +5826,7 @@
           <p:cNvPr id="18" name="">
             <a:extLst xmlns:a="http://schemas.openxmlformats.org/drawingml/2006/main">
               <a:ext uri="{FF2B5EF4-FFF2-40B4-BE49-F238E27FC236}">
-                <a16:creationId xmlns:a16="http://schemas.microsoft.com/office/drawing/2014/main" id="{B08DF3CF-834C-43BF-AC85-6E0256B3857A}"/>
+                <a16:creationId xmlns:a16="http://schemas.microsoft.com/office/drawing/2014/main" id="{1046A87E-3857-4B88-B64A-C025A7E7FFB6}"/>
               </a:ext>
             </a:extLst>
           </p:cNvPr>
@@ -5881,7 +5881,7 @@
     </p:spTree>
     <p:extLst>
       <p:ext uri="{BB962C8B-B14F-4D97-AF65-F5344CB8AC3E}">
-        <p14:creationId xmlns:p14="http://schemas.microsoft.com/office/powerpoint/2010/main" val="680481391"/>
+        <p14:creationId xmlns:p14="http://schemas.microsoft.com/office/powerpoint/2010/main" val="1973138752"/>
       </p:ext>
     </p:extLst>
   </p:cSld>
@@ -5912,7 +5912,7 @@
           <p:cNvPr id="41" name="">
             <a:extLst xmlns:a="http://schemas.openxmlformats.org/drawingml/2006/main">
               <a:ext uri="{FF2B5EF4-FFF2-40B4-BE49-F238E27FC236}">
-                <a16:creationId xmlns:a16="http://schemas.microsoft.com/office/drawing/2014/main" id="{66CA8C7A-90A7-4B16-8639-93F4B6BA31C8}"/>
+                <a16:creationId xmlns:a16="http://schemas.microsoft.com/office/drawing/2014/main" id="{7B3A1452-8A3B-4F86-9F54-FC13784A94A3}"/>
               </a:ext>
             </a:extLst>
           </p:cNvPr>
@@ -5959,7 +5959,7 @@
                 <a:ea typeface="Helvetica Neue"/>
                 <a:cs typeface="Helvetica Neue"/>
               </a:rPr>
-              <a:t>API EXPLANATION</a:t>
+              <a:t>PYTHON WORKFLOW</a:t>
             </a:r>
           </a:p>
         </p:txBody>
@@ -5969,7 +5969,7 @@
           <p:cNvPr id="2" name="">
             <a:extLst xmlns:a="http://schemas.openxmlformats.org/drawingml/2006/main">
               <a:ext uri="{FF2B5EF4-FFF2-40B4-BE49-F238E27FC236}">
-                <a16:creationId xmlns:a16="http://schemas.microsoft.com/office/drawing/2014/main" id="{0A41649B-D144-4EB2-AA34-C71C86ECADBC}"/>
+                <a16:creationId xmlns:a16="http://schemas.microsoft.com/office/drawing/2014/main" id="{76E6C45C-7ACD-49A8-A4DD-DC26D603C174}"/>
               </a:ext>
             </a:extLst>
           </p:cNvPr>
@@ -6026,7 +6026,7 @@
           <p:cNvPr id="3" name="">
             <a:extLst xmlns:a="http://schemas.openxmlformats.org/drawingml/2006/main">
               <a:ext uri="{FF2B5EF4-FFF2-40B4-BE49-F238E27FC236}">
-                <a16:creationId xmlns:a16="http://schemas.microsoft.com/office/drawing/2014/main" id="{C6913901-C2A1-4EC6-BDA1-4E1F77597B88}"/>
+                <a16:creationId xmlns:a16="http://schemas.microsoft.com/office/drawing/2014/main" id="{2C22642B-A4FC-474D-B2A8-1845E365BF29}"/>
               </a:ext>
             </a:extLst>
           </p:cNvPr>
@@ -6057,7 +6057,7 @@
           <p:cNvPr id="4" name="">
             <a:extLst xmlns:a="http://schemas.openxmlformats.org/drawingml/2006/main">
               <a:ext uri="{FF2B5EF4-FFF2-40B4-BE49-F238E27FC236}">
-                <a16:creationId xmlns:a16="http://schemas.microsoft.com/office/drawing/2014/main" id="{77542FFF-30B9-45E8-9614-F0347F52D914}"/>
+                <a16:creationId xmlns:a16="http://schemas.microsoft.com/office/drawing/2014/main" id="{03535FB5-05CC-4676-8281-6ED37B424D1F}"/>
               </a:ext>
             </a:extLst>
           </p:cNvPr>
@@ -6114,7 +6114,7 @@
           <p:cNvPr id="5" name="">
             <a:extLst xmlns:a="http://schemas.openxmlformats.org/drawingml/2006/main">
               <a:ext uri="{FF2B5EF4-FFF2-40B4-BE49-F238E27FC236}">
-                <a16:creationId xmlns:a16="http://schemas.microsoft.com/office/drawing/2014/main" id="{6ED441BB-7A60-4078-B358-2DBB26235B60}"/>
+                <a16:creationId xmlns:a16="http://schemas.microsoft.com/office/drawing/2014/main" id="{FF7989AF-BC54-4E63-9E58-60BD6A6DFF1D}"/>
               </a:ext>
             </a:extLst>
           </p:cNvPr>
@@ -6149,7 +6149,7 @@
           <p:cNvPr id="6" name="">
             <a:extLst xmlns:a="http://schemas.openxmlformats.org/drawingml/2006/main">
               <a:ext uri="{FF2B5EF4-FFF2-40B4-BE49-F238E27FC236}">
-                <a16:creationId xmlns:a16="http://schemas.microsoft.com/office/drawing/2014/main" id="{2FD821F5-8729-4327-88E0-C97470725591}"/>
+                <a16:creationId xmlns:a16="http://schemas.microsoft.com/office/drawing/2014/main" id="{5DEE8F60-0A99-4B1B-A305-197F0D729619}"/>
               </a:ext>
             </a:extLst>
           </p:cNvPr>
@@ -6182,7 +6182,7 @@
           <p:cNvPr id="7" name="">
             <a:extLst xmlns:a="http://schemas.openxmlformats.org/drawingml/2006/main">
               <a:ext uri="{FF2B5EF4-FFF2-40B4-BE49-F238E27FC236}">
-                <a16:creationId xmlns:a16="http://schemas.microsoft.com/office/drawing/2014/main" id="{77C77DED-9FEC-4E5D-BC0E-2783E63C013F}"/>
+                <a16:creationId xmlns:a16="http://schemas.microsoft.com/office/drawing/2014/main" id="{4B55A024-1994-4E38-9522-508CA3011253}"/>
               </a:ext>
             </a:extLst>
           </p:cNvPr>
@@ -6239,7 +6239,7 @@
           <p:cNvPr id="8" name="">
             <a:extLst xmlns:a="http://schemas.openxmlformats.org/drawingml/2006/main">
               <a:ext uri="{FF2B5EF4-FFF2-40B4-BE49-F238E27FC236}">
-                <a16:creationId xmlns:a16="http://schemas.microsoft.com/office/drawing/2014/main" id="{4F63CB9E-E1CB-4C60-AC4A-FF98C31CD615}"/>
+                <a16:creationId xmlns:a16="http://schemas.microsoft.com/office/drawing/2014/main" id="{A6662E80-D93D-4F22-8E2C-40DD1D486CFC}"/>
               </a:ext>
             </a:extLst>
           </p:cNvPr>
@@ -6296,7 +6296,7 @@
           <p:cNvPr id="9" name="">
             <a:extLst xmlns:a="http://schemas.openxmlformats.org/drawingml/2006/main">
               <a:ext uri="{FF2B5EF4-FFF2-40B4-BE49-F238E27FC236}">
-                <a16:creationId xmlns:a16="http://schemas.microsoft.com/office/drawing/2014/main" id="{26BE3DC9-F675-4C0A-BE6C-EC65ADF7A6C6}"/>
+                <a16:creationId xmlns:a16="http://schemas.microsoft.com/office/drawing/2014/main" id="{2CB8A808-2AD5-459A-88A1-E752D9E15472}"/>
               </a:ext>
             </a:extLst>
           </p:cNvPr>
@@ -6353,7 +6353,7 @@
           <p:cNvPr id="10" name="">
             <a:extLst xmlns:a="http://schemas.openxmlformats.org/drawingml/2006/main">
               <a:ext uri="{FF2B5EF4-FFF2-40B4-BE49-F238E27FC236}">
-                <a16:creationId xmlns:a16="http://schemas.microsoft.com/office/drawing/2014/main" id="{12805413-53E6-4C1F-80B1-4782FB1CDFD4}"/>
+                <a16:creationId xmlns:a16="http://schemas.microsoft.com/office/drawing/2014/main" id="{7FD7FE72-723E-412E-867A-489A83EB8A23}"/>
               </a:ext>
             </a:extLst>
           </p:cNvPr>
@@ -6410,7 +6410,7 @@
           <p:cNvPr id="11" name="">
             <a:extLst xmlns:a="http://schemas.openxmlformats.org/drawingml/2006/main">
               <a:ext uri="{FF2B5EF4-FFF2-40B4-BE49-F238E27FC236}">
-                <a16:creationId xmlns:a16="http://schemas.microsoft.com/office/drawing/2014/main" id="{BC952135-02B3-4668-BD2D-FC8BC8C1FCF0}"/>
+                <a16:creationId xmlns:a16="http://schemas.microsoft.com/office/drawing/2014/main" id="{FB1F3141-3EC0-4B1A-852B-B78296F420ED}"/>
               </a:ext>
             </a:extLst>
           </p:cNvPr>
@@ -6445,7 +6445,7 @@
           <p:cNvPr id="12" name="">
             <a:extLst xmlns:a="http://schemas.openxmlformats.org/drawingml/2006/main">
               <a:ext uri="{FF2B5EF4-FFF2-40B4-BE49-F238E27FC236}">
-                <a16:creationId xmlns:a16="http://schemas.microsoft.com/office/drawing/2014/main" id="{FC89C0FF-34E4-4DD2-8EB1-55313FCE653E}"/>
+                <a16:creationId xmlns:a16="http://schemas.microsoft.com/office/drawing/2014/main" id="{3C83A292-831E-4D73-AB56-906FDA73F122}"/>
               </a:ext>
             </a:extLst>
           </p:cNvPr>
@@ -6478,7 +6478,7 @@
           <p:cNvPr id="13" name="">
             <a:extLst xmlns:a="http://schemas.openxmlformats.org/drawingml/2006/main">
               <a:ext uri="{FF2B5EF4-FFF2-40B4-BE49-F238E27FC236}">
-                <a16:creationId xmlns:a16="http://schemas.microsoft.com/office/drawing/2014/main" id="{9C96B7E8-4EA0-4012-AE72-2B9A635C0181}"/>
+                <a16:creationId xmlns:a16="http://schemas.microsoft.com/office/drawing/2014/main" id="{AED29C4C-0104-48BD-92F2-D2E7131DCC45}"/>
               </a:ext>
             </a:extLst>
           </p:cNvPr>
@@ -6535,7 +6535,7 @@
           <p:cNvPr id="14" name="">
             <a:extLst xmlns:a="http://schemas.openxmlformats.org/drawingml/2006/main">
               <a:ext uri="{FF2B5EF4-FFF2-40B4-BE49-F238E27FC236}">
-                <a16:creationId xmlns:a16="http://schemas.microsoft.com/office/drawing/2014/main" id="{2DC659B7-846F-4483-84AD-24435D38BF16}"/>
+                <a16:creationId xmlns:a16="http://schemas.microsoft.com/office/drawing/2014/main" id="{ED1C4A90-C730-48B9-BD5C-E55716EC6C62}"/>
               </a:ext>
             </a:extLst>
           </p:cNvPr>
@@ -6592,7 +6592,7 @@
           <p:cNvPr id="15" name="">
             <a:extLst xmlns:a="http://schemas.openxmlformats.org/drawingml/2006/main">
               <a:ext uri="{FF2B5EF4-FFF2-40B4-BE49-F238E27FC236}">
-                <a16:creationId xmlns:a16="http://schemas.microsoft.com/office/drawing/2014/main" id="{0DA0BE4B-DD35-47E8-891C-2B495808F5F1}"/>
+                <a16:creationId xmlns:a16="http://schemas.microsoft.com/office/drawing/2014/main" id="{32C5FBA5-DD49-4477-92B9-983ABAA883F1}"/>
               </a:ext>
             </a:extLst>
           </p:cNvPr>
@@ -6649,7 +6649,7 @@
           <p:cNvPr id="16" name="">
             <a:extLst xmlns:a="http://schemas.openxmlformats.org/drawingml/2006/main">
               <a:ext uri="{FF2B5EF4-FFF2-40B4-BE49-F238E27FC236}">
-                <a16:creationId xmlns:a16="http://schemas.microsoft.com/office/drawing/2014/main" id="{AB009BFF-1114-43EB-89BB-3FAA8C271ECB}"/>
+                <a16:creationId xmlns:a16="http://schemas.microsoft.com/office/drawing/2014/main" id="{EDE89534-B936-4C09-93E5-8530132B974B}"/>
               </a:ext>
             </a:extLst>
           </p:cNvPr>
@@ -6706,7 +6706,7 @@
           <p:cNvPr id="17" name="">
             <a:extLst xmlns:a="http://schemas.openxmlformats.org/drawingml/2006/main">
               <a:ext uri="{FF2B5EF4-FFF2-40B4-BE49-F238E27FC236}">
-                <a16:creationId xmlns:a16="http://schemas.microsoft.com/office/drawing/2014/main" id="{EAB0907D-5AFC-40D3-9106-6DBE523FAFF0}"/>
+                <a16:creationId xmlns:a16="http://schemas.microsoft.com/office/drawing/2014/main" id="{1ED65517-08C0-4819-B268-FAF71B966F6F}"/>
               </a:ext>
             </a:extLst>
           </p:cNvPr>
@@ -6741,7 +6741,7 @@
           <p:cNvPr id="18" name="">
             <a:extLst xmlns:a="http://schemas.openxmlformats.org/drawingml/2006/main">
               <a:ext uri="{FF2B5EF4-FFF2-40B4-BE49-F238E27FC236}">
-                <a16:creationId xmlns:a16="http://schemas.microsoft.com/office/drawing/2014/main" id="{554D6EDE-DAC5-40D4-929D-408BFFDE06A6}"/>
+                <a16:creationId xmlns:a16="http://schemas.microsoft.com/office/drawing/2014/main" id="{353CD04C-BC79-45EE-8154-85711D15B61C}"/>
               </a:ext>
             </a:extLst>
           </p:cNvPr>
@@ -6774,7 +6774,7 @@
           <p:cNvPr id="19" name="">
             <a:extLst xmlns:a="http://schemas.openxmlformats.org/drawingml/2006/main">
               <a:ext uri="{FF2B5EF4-FFF2-40B4-BE49-F238E27FC236}">
-                <a16:creationId xmlns:a16="http://schemas.microsoft.com/office/drawing/2014/main" id="{D3109C4F-652B-450F-B68F-7F9F36FBF3F1}"/>
+                <a16:creationId xmlns:a16="http://schemas.microsoft.com/office/drawing/2014/main" id="{BE050B4E-1CC4-4437-9F55-68773EC1EBC0}"/>
               </a:ext>
             </a:extLst>
           </p:cNvPr>
@@ -6831,7 +6831,7 @@
           <p:cNvPr id="20" name="">
             <a:extLst xmlns:a="http://schemas.openxmlformats.org/drawingml/2006/main">
               <a:ext uri="{FF2B5EF4-FFF2-40B4-BE49-F238E27FC236}">
-                <a16:creationId xmlns:a16="http://schemas.microsoft.com/office/drawing/2014/main" id="{2E61D152-2F55-49A7-A5C6-386AE8AB057A}"/>
+                <a16:creationId xmlns:a16="http://schemas.microsoft.com/office/drawing/2014/main" id="{A5CFDD60-C26A-430E-B359-E0670A44CE43}"/>
               </a:ext>
             </a:extLst>
           </p:cNvPr>
@@ -6888,7 +6888,7 @@
           <p:cNvPr id="21" name="">
             <a:extLst xmlns:a="http://schemas.openxmlformats.org/drawingml/2006/main">
               <a:ext uri="{FF2B5EF4-FFF2-40B4-BE49-F238E27FC236}">
-                <a16:creationId xmlns:a16="http://schemas.microsoft.com/office/drawing/2014/main" id="{4C796ACA-F5FB-4293-9C28-0BA5FDA936EF}"/>
+                <a16:creationId xmlns:a16="http://schemas.microsoft.com/office/drawing/2014/main" id="{196299B0-0E26-4F52-81A1-1ADF6FB72B8C}"/>
               </a:ext>
             </a:extLst>
           </p:cNvPr>
@@ -6945,7 +6945,7 @@
           <p:cNvPr id="22" name="">
             <a:extLst xmlns:a="http://schemas.openxmlformats.org/drawingml/2006/main">
               <a:ext uri="{FF2B5EF4-FFF2-40B4-BE49-F238E27FC236}">
-                <a16:creationId xmlns:a16="http://schemas.microsoft.com/office/drawing/2014/main" id="{43C0A266-9EA9-46D0-BDE2-AB1CC172AB95}"/>
+                <a16:creationId xmlns:a16="http://schemas.microsoft.com/office/drawing/2014/main" id="{0C6972D2-ED39-4B37-B7AD-15DAB8763F2B}"/>
               </a:ext>
             </a:extLst>
           </p:cNvPr>
@@ -7002,7 +7002,7 @@
           <p:cNvPr id="23" name="">
             <a:extLst xmlns:a="http://schemas.openxmlformats.org/drawingml/2006/main">
               <a:ext uri="{FF2B5EF4-FFF2-40B4-BE49-F238E27FC236}">
-                <a16:creationId xmlns:a16="http://schemas.microsoft.com/office/drawing/2014/main" id="{6C22765E-46DC-42F9-9266-11DFAC1FA83B}"/>
+                <a16:creationId xmlns:a16="http://schemas.microsoft.com/office/drawing/2014/main" id="{71F0E784-0FBB-41FF-B126-A469B8FBC7E4}"/>
               </a:ext>
             </a:extLst>
           </p:cNvPr>
@@ -7037,7 +7037,7 @@
           <p:cNvPr id="24" name="">
             <a:extLst xmlns:a="http://schemas.openxmlformats.org/drawingml/2006/main">
               <a:ext uri="{FF2B5EF4-FFF2-40B4-BE49-F238E27FC236}">
-                <a16:creationId xmlns:a16="http://schemas.microsoft.com/office/drawing/2014/main" id="{D8169FFD-E89A-434E-8C37-AE84583ED286}"/>
+                <a16:creationId xmlns:a16="http://schemas.microsoft.com/office/drawing/2014/main" id="{106A1BB0-996D-4C08-87E1-E8F423F0E50B}"/>
               </a:ext>
             </a:extLst>
           </p:cNvPr>
@@ -7070,7 +7070,7 @@
           <p:cNvPr id="25" name="">
             <a:extLst xmlns:a="http://schemas.openxmlformats.org/drawingml/2006/main">
               <a:ext uri="{FF2B5EF4-FFF2-40B4-BE49-F238E27FC236}">
-                <a16:creationId xmlns:a16="http://schemas.microsoft.com/office/drawing/2014/main" id="{FF205D92-9FC7-4B76-BD94-71E5C945EC97}"/>
+                <a16:creationId xmlns:a16="http://schemas.microsoft.com/office/drawing/2014/main" id="{0C663706-F218-48DE-9BA4-ED53C2EFE595}"/>
               </a:ext>
             </a:extLst>
           </p:cNvPr>
@@ -7127,7 +7127,7 @@
           <p:cNvPr id="26" name="">
             <a:extLst xmlns:a="http://schemas.openxmlformats.org/drawingml/2006/main">
               <a:ext uri="{FF2B5EF4-FFF2-40B4-BE49-F238E27FC236}">
-                <a16:creationId xmlns:a16="http://schemas.microsoft.com/office/drawing/2014/main" id="{09734781-2D3F-48A5-8AE9-0917308B7E16}"/>
+                <a16:creationId xmlns:a16="http://schemas.microsoft.com/office/drawing/2014/main" id="{443301DD-0537-4764-9E4C-F33827526987}"/>
               </a:ext>
             </a:extLst>
           </p:cNvPr>
@@ -7184,7 +7184,7 @@
           <p:cNvPr id="27" name="">
             <a:extLst xmlns:a="http://schemas.openxmlformats.org/drawingml/2006/main">
               <a:ext uri="{FF2B5EF4-FFF2-40B4-BE49-F238E27FC236}">
-                <a16:creationId xmlns:a16="http://schemas.microsoft.com/office/drawing/2014/main" id="{59EA4592-491C-4EF1-A5D2-51990BC1AF1F}"/>
+                <a16:creationId xmlns:a16="http://schemas.microsoft.com/office/drawing/2014/main" id="{1A4FEB52-4C59-4ABA-921B-004A57EA170C}"/>
               </a:ext>
             </a:extLst>
           </p:cNvPr>
@@ -7241,7 +7241,7 @@
           <p:cNvPr id="28" name="">
             <a:extLst xmlns:a="http://schemas.openxmlformats.org/drawingml/2006/main">
               <a:ext uri="{FF2B5EF4-FFF2-40B4-BE49-F238E27FC236}">
-                <a16:creationId xmlns:a16="http://schemas.microsoft.com/office/drawing/2014/main" id="{C29F15F7-8206-4041-92CA-39C13C0E102B}"/>
+                <a16:creationId xmlns:a16="http://schemas.microsoft.com/office/drawing/2014/main" id="{882EDFD9-5D59-4F34-A692-5022DF8C16AB}"/>
               </a:ext>
             </a:extLst>
           </p:cNvPr>
@@ -7298,7 +7298,7 @@
           <p:cNvPr id="29" name="">
             <a:extLst xmlns:a="http://schemas.openxmlformats.org/drawingml/2006/main">
               <a:ext uri="{FF2B5EF4-FFF2-40B4-BE49-F238E27FC236}">
-                <a16:creationId xmlns:a16="http://schemas.microsoft.com/office/drawing/2014/main" id="{735872E5-73ED-47F9-9F55-746DF41DC22B}"/>
+                <a16:creationId xmlns:a16="http://schemas.microsoft.com/office/drawing/2014/main" id="{F613D7E8-4895-4CCA-B93C-447BCEE04B0F}"/>
               </a:ext>
             </a:extLst>
           </p:cNvPr>
@@ -7333,7 +7333,7 @@
           <p:cNvPr id="30" name="">
             <a:extLst xmlns:a="http://schemas.openxmlformats.org/drawingml/2006/main">
               <a:ext uri="{FF2B5EF4-FFF2-40B4-BE49-F238E27FC236}">
-                <a16:creationId xmlns:a16="http://schemas.microsoft.com/office/drawing/2014/main" id="{5F448AF3-AC30-4C3B-A1AC-C765BEFD8176}"/>
+                <a16:creationId xmlns:a16="http://schemas.microsoft.com/office/drawing/2014/main" id="{92E959B7-A04F-439F-85B2-79FC61CFF56F}"/>
               </a:ext>
             </a:extLst>
           </p:cNvPr>
@@ -7366,7 +7366,7 @@
           <p:cNvPr id="31" name="">
             <a:extLst xmlns:a="http://schemas.openxmlformats.org/drawingml/2006/main">
               <a:ext uri="{FF2B5EF4-FFF2-40B4-BE49-F238E27FC236}">
-                <a16:creationId xmlns:a16="http://schemas.microsoft.com/office/drawing/2014/main" id="{F489DF83-D714-4B7D-BE91-3990B88B6BB7}"/>
+                <a16:creationId xmlns:a16="http://schemas.microsoft.com/office/drawing/2014/main" id="{88514B69-9DD7-465A-B3C0-3643AB56B263}"/>
               </a:ext>
             </a:extLst>
           </p:cNvPr>
@@ -7423,7 +7423,7 @@
           <p:cNvPr id="32" name="">
             <a:extLst xmlns:a="http://schemas.openxmlformats.org/drawingml/2006/main">
               <a:ext uri="{FF2B5EF4-FFF2-40B4-BE49-F238E27FC236}">
-                <a16:creationId xmlns:a16="http://schemas.microsoft.com/office/drawing/2014/main" id="{BABA81F2-4967-47DF-8985-593E50773A5A}"/>
+                <a16:creationId xmlns:a16="http://schemas.microsoft.com/office/drawing/2014/main" id="{9D52DA5F-1CCD-473C-93D7-E945F431DBAC}"/>
               </a:ext>
             </a:extLst>
           </p:cNvPr>
@@ -7480,7 +7480,7 @@
           <p:cNvPr id="33" name="">
             <a:extLst xmlns:a="http://schemas.openxmlformats.org/drawingml/2006/main">
               <a:ext uri="{FF2B5EF4-FFF2-40B4-BE49-F238E27FC236}">
-                <a16:creationId xmlns:a16="http://schemas.microsoft.com/office/drawing/2014/main" id="{1D74F838-B57B-4F3B-83F3-BE81059E665B}"/>
+                <a16:creationId xmlns:a16="http://schemas.microsoft.com/office/drawing/2014/main" id="{BAE1519E-1C4B-4132-A90F-5C73AD11FF3F}"/>
               </a:ext>
             </a:extLst>
           </p:cNvPr>
@@ -7537,7 +7537,7 @@
           <p:cNvPr id="34" name="">
             <a:extLst xmlns:a="http://schemas.openxmlformats.org/drawingml/2006/main">
               <a:ext uri="{FF2B5EF4-FFF2-40B4-BE49-F238E27FC236}">
-                <a16:creationId xmlns:a16="http://schemas.microsoft.com/office/drawing/2014/main" id="{670F60E1-75C6-4812-AEB7-E8147B5282D7}"/>
+                <a16:creationId xmlns:a16="http://schemas.microsoft.com/office/drawing/2014/main" id="{EA00AB6A-A94C-4F2E-ABCC-8FE7D47A738B}"/>
               </a:ext>
             </a:extLst>
           </p:cNvPr>
@@ -7694,7 +7694,7 @@
           <p:cNvPr id="39" name="">
             <a:extLst xmlns:a="http://schemas.openxmlformats.org/drawingml/2006/main">
               <a:ext uri="{FF2B5EF4-FFF2-40B4-BE49-F238E27FC236}">
-                <a16:creationId xmlns:a16="http://schemas.microsoft.com/office/drawing/2014/main" id="{69091303-CCB1-4A47-8BE7-495EEF3DF44E}"/>
+                <a16:creationId xmlns:a16="http://schemas.microsoft.com/office/drawing/2014/main" id="{88C13F6D-35AC-4CAF-8A38-772C2FA746BC}"/>
               </a:ext>
             </a:extLst>
           </p:cNvPr>
@@ -7729,7 +7729,7 @@
           <p:cNvPr id="40" name="">
             <a:extLst xmlns:a="http://schemas.openxmlformats.org/drawingml/2006/main">
               <a:ext uri="{FF2B5EF4-FFF2-40B4-BE49-F238E27FC236}">
-                <a16:creationId xmlns:a16="http://schemas.microsoft.com/office/drawing/2014/main" id="{773FD68F-85DA-40BB-AFC0-B24B4EE903EA}"/>
+                <a16:creationId xmlns:a16="http://schemas.microsoft.com/office/drawing/2014/main" id="{7548EDBB-77E6-4926-9F61-410E378E2A62}"/>
               </a:ext>
             </a:extLst>
           </p:cNvPr>
@@ -7784,7 +7784,7 @@
     </p:spTree>
     <p:extLst>
       <p:ext uri="{BB962C8B-B14F-4D97-AF65-F5344CB8AC3E}">
-        <p14:creationId xmlns:p14="http://schemas.microsoft.com/office/powerpoint/2010/main" val="793518973"/>
+        <p14:creationId xmlns:p14="http://schemas.microsoft.com/office/powerpoint/2010/main" val="546956500"/>
       </p:ext>
     </p:extLst>
   </p:cSld>
@@ -7815,7 +7815,7 @@
           <p:cNvPr id="25" name="">
             <a:extLst xmlns:a="http://schemas.openxmlformats.org/drawingml/2006/main">
               <a:ext uri="{FF2B5EF4-FFF2-40B4-BE49-F238E27FC236}">
-                <a16:creationId xmlns:a16="http://schemas.microsoft.com/office/drawing/2014/main" id="{74849934-21A0-421C-8200-88CB81E93CC0}"/>
+                <a16:creationId xmlns:a16="http://schemas.microsoft.com/office/drawing/2014/main" id="{61EB179B-F174-4DFF-B903-78E10A57F25D}"/>
               </a:ext>
             </a:extLst>
           </p:cNvPr>
@@ -7862,7 +7862,7 @@
                 <a:ea typeface="Helvetica Neue"/>
                 <a:cs typeface="Helvetica Neue"/>
               </a:rPr>
-              <a:t>WORKING PROTOTYPE · 1 POINT</a:t>
+              <a:t>PROTOTYPE EVIDENCE</a:t>
             </a:r>
           </a:p>
         </p:txBody>
@@ -7872,7 +7872,7 @@
           <p:cNvPr id="2" name="">
             <a:extLst xmlns:a="http://schemas.openxmlformats.org/drawingml/2006/main">
               <a:ext uri="{FF2B5EF4-FFF2-40B4-BE49-F238E27FC236}">
-                <a16:creationId xmlns:a16="http://schemas.microsoft.com/office/drawing/2014/main" id="{C88BDA1F-EF7C-4BF8-A8B3-02C5B6E1B213}"/>
+                <a16:creationId xmlns:a16="http://schemas.microsoft.com/office/drawing/2014/main" id="{BEB47F00-830D-4F4C-8C7E-3D11133E830B}"/>
               </a:ext>
             </a:extLst>
           </p:cNvPr>
@@ -7929,7 +7929,7 @@
           <p:cNvPr id="3" name="">
             <a:extLst xmlns:a="http://schemas.openxmlformats.org/drawingml/2006/main">
               <a:ext uri="{FF2B5EF4-FFF2-40B4-BE49-F238E27FC236}">
-                <a16:creationId xmlns:a16="http://schemas.microsoft.com/office/drawing/2014/main" id="{9A8396D4-D6B1-47AF-8A06-11F6503FCD8D}"/>
+                <a16:creationId xmlns:a16="http://schemas.microsoft.com/office/drawing/2014/main" id="{C3256E72-A56C-4620-89F1-04C5229C1F78}"/>
               </a:ext>
             </a:extLst>
           </p:cNvPr>
@@ -7960,7 +7960,7 @@
           <p:cNvPr id="4" name="">
             <a:extLst xmlns:a="http://schemas.openxmlformats.org/drawingml/2006/main">
               <a:ext uri="{FF2B5EF4-FFF2-40B4-BE49-F238E27FC236}">
-                <a16:creationId xmlns:a16="http://schemas.microsoft.com/office/drawing/2014/main" id="{E527150E-D030-4EC3-9001-D0650135A0F2}"/>
+                <a16:creationId xmlns:a16="http://schemas.microsoft.com/office/drawing/2014/main" id="{620D7998-CADE-4C9F-B865-29504B9479E7}"/>
               </a:ext>
             </a:extLst>
           </p:cNvPr>
@@ -7993,7 +7993,7 @@
           <p:cNvPr id="5" name="">
             <a:extLst xmlns:a="http://schemas.openxmlformats.org/drawingml/2006/main">
               <a:ext uri="{FF2B5EF4-FFF2-40B4-BE49-F238E27FC236}">
-                <a16:creationId xmlns:a16="http://schemas.microsoft.com/office/drawing/2014/main" id="{1F01F40A-1BD2-4FD2-8465-B8AF04403FFA}"/>
+                <a16:creationId xmlns:a16="http://schemas.microsoft.com/office/drawing/2014/main" id="{29BB5C70-62DE-49EF-A18A-57F53AF8C1D9}"/>
               </a:ext>
             </a:extLst>
           </p:cNvPr>
@@ -8050,7 +8050,7 @@
           <p:cNvPr id="6" name="">
             <a:extLst xmlns:a="http://schemas.openxmlformats.org/drawingml/2006/main">
               <a:ext uri="{FF2B5EF4-FFF2-40B4-BE49-F238E27FC236}">
-                <a16:creationId xmlns:a16="http://schemas.microsoft.com/office/drawing/2014/main" id="{BD1B00E6-864F-4B7F-A30A-6B9282AF17C5}"/>
+                <a16:creationId xmlns:a16="http://schemas.microsoft.com/office/drawing/2014/main" id="{2413CB41-E09F-4AA4-AB36-EBFDE4D8526A}"/>
               </a:ext>
             </a:extLst>
           </p:cNvPr>
@@ -8107,7 +8107,7 @@
           <p:cNvPr id="7" name="">
             <a:extLst xmlns:a="http://schemas.openxmlformats.org/drawingml/2006/main">
               <a:ext uri="{FF2B5EF4-FFF2-40B4-BE49-F238E27FC236}">
-                <a16:creationId xmlns:a16="http://schemas.microsoft.com/office/drawing/2014/main" id="{87297BAF-D20E-423C-B7D1-F2581C079C72}"/>
+                <a16:creationId xmlns:a16="http://schemas.microsoft.com/office/drawing/2014/main" id="{2760A4CD-D8AD-4AD2-A3C1-5B9F81D76C56}"/>
               </a:ext>
             </a:extLst>
           </p:cNvPr>
@@ -8164,7 +8164,7 @@
           <p:cNvPr id="8" name="">
             <a:extLst xmlns:a="http://schemas.openxmlformats.org/drawingml/2006/main">
               <a:ext uri="{FF2B5EF4-FFF2-40B4-BE49-F238E27FC236}">
-                <a16:creationId xmlns:a16="http://schemas.microsoft.com/office/drawing/2014/main" id="{DBEBF16B-8805-4714-8B08-2835DD557F92}"/>
+                <a16:creationId xmlns:a16="http://schemas.microsoft.com/office/drawing/2014/main" id="{9696D47B-83C7-459D-A0F2-82F994850593}"/>
               </a:ext>
             </a:extLst>
           </p:cNvPr>
@@ -8197,7 +8197,7 @@
           <p:cNvPr id="9" name="">
             <a:extLst xmlns:a="http://schemas.openxmlformats.org/drawingml/2006/main">
               <a:ext uri="{FF2B5EF4-FFF2-40B4-BE49-F238E27FC236}">
-                <a16:creationId xmlns:a16="http://schemas.microsoft.com/office/drawing/2014/main" id="{577DEED9-F979-4A46-80DE-4B4A1B3490F7}"/>
+                <a16:creationId xmlns:a16="http://schemas.microsoft.com/office/drawing/2014/main" id="{CC1AA301-9FD8-4A63-9320-4CE762E6BD9F}"/>
               </a:ext>
             </a:extLst>
           </p:cNvPr>
@@ -8254,7 +8254,7 @@
           <p:cNvPr id="10" name="">
             <a:extLst xmlns:a="http://schemas.openxmlformats.org/drawingml/2006/main">
               <a:ext uri="{FF2B5EF4-FFF2-40B4-BE49-F238E27FC236}">
-                <a16:creationId xmlns:a16="http://schemas.microsoft.com/office/drawing/2014/main" id="{5FC3D7E8-DF88-4A2D-A5CE-15AD329414EF}"/>
+                <a16:creationId xmlns:a16="http://schemas.microsoft.com/office/drawing/2014/main" id="{D350AB0B-A7BC-46E3-8473-5EE8007E2734}"/>
               </a:ext>
             </a:extLst>
           </p:cNvPr>
@@ -8311,7 +8311,7 @@
           <p:cNvPr id="11" name="">
             <a:extLst xmlns:a="http://schemas.openxmlformats.org/drawingml/2006/main">
               <a:ext uri="{FF2B5EF4-FFF2-40B4-BE49-F238E27FC236}">
-                <a16:creationId xmlns:a16="http://schemas.microsoft.com/office/drawing/2014/main" id="{70CA467D-01BB-4A0D-9533-AD884F4ED3D5}"/>
+                <a16:creationId xmlns:a16="http://schemas.microsoft.com/office/drawing/2014/main" id="{B6222395-7456-43FA-BD2E-F1627F983C05}"/>
               </a:ext>
             </a:extLst>
           </p:cNvPr>
@@ -8368,7 +8368,7 @@
           <p:cNvPr id="12" name="">
             <a:extLst xmlns:a="http://schemas.openxmlformats.org/drawingml/2006/main">
               <a:ext uri="{FF2B5EF4-FFF2-40B4-BE49-F238E27FC236}">
-                <a16:creationId xmlns:a16="http://schemas.microsoft.com/office/drawing/2014/main" id="{30952871-72BF-48E0-A652-5F6D26D16608}"/>
+                <a16:creationId xmlns:a16="http://schemas.microsoft.com/office/drawing/2014/main" id="{E5F90B8B-2247-4541-B3E4-1F94CBABB72D}"/>
               </a:ext>
             </a:extLst>
           </p:cNvPr>
@@ -8401,7 +8401,7 @@
           <p:cNvPr id="13" name="">
             <a:extLst xmlns:a="http://schemas.openxmlformats.org/drawingml/2006/main">
               <a:ext uri="{FF2B5EF4-FFF2-40B4-BE49-F238E27FC236}">
-                <a16:creationId xmlns:a16="http://schemas.microsoft.com/office/drawing/2014/main" id="{BA7EC254-7E5F-4326-B572-6A020E9AB300}"/>
+                <a16:creationId xmlns:a16="http://schemas.microsoft.com/office/drawing/2014/main" id="{CF207D00-8123-4B0C-BE04-F380617E8556}"/>
               </a:ext>
             </a:extLst>
           </p:cNvPr>
@@ -8458,7 +8458,7 @@
           <p:cNvPr id="14" name="">
             <a:extLst xmlns:a="http://schemas.openxmlformats.org/drawingml/2006/main">
               <a:ext uri="{FF2B5EF4-FFF2-40B4-BE49-F238E27FC236}">
-                <a16:creationId xmlns:a16="http://schemas.microsoft.com/office/drawing/2014/main" id="{CCE36222-7191-4C2A-A5AA-E0D64C2AAA14}"/>
+                <a16:creationId xmlns:a16="http://schemas.microsoft.com/office/drawing/2014/main" id="{DA28563B-DE31-40E5-8292-C3E6AABC0699}"/>
               </a:ext>
             </a:extLst>
           </p:cNvPr>
@@ -8515,7 +8515,7 @@
           <p:cNvPr id="15" name="">
             <a:extLst xmlns:a="http://schemas.openxmlformats.org/drawingml/2006/main">
               <a:ext uri="{FF2B5EF4-FFF2-40B4-BE49-F238E27FC236}">
-                <a16:creationId xmlns:a16="http://schemas.microsoft.com/office/drawing/2014/main" id="{BB8780DB-C7C6-4363-B43C-EBBDFF3229EA}"/>
+                <a16:creationId xmlns:a16="http://schemas.microsoft.com/office/drawing/2014/main" id="{C38B3AAB-3FD1-4756-93E3-518940EA37FB}"/>
               </a:ext>
             </a:extLst>
           </p:cNvPr>
@@ -8572,7 +8572,7 @@
           <p:cNvPr id="16" name="">
             <a:extLst xmlns:a="http://schemas.openxmlformats.org/drawingml/2006/main">
               <a:ext uri="{FF2B5EF4-FFF2-40B4-BE49-F238E27FC236}">
-                <a16:creationId xmlns:a16="http://schemas.microsoft.com/office/drawing/2014/main" id="{0A3DE1BE-547D-4894-826C-D95127182485}"/>
+                <a16:creationId xmlns:a16="http://schemas.microsoft.com/office/drawing/2014/main" id="{8F9F316F-2E52-4155-8D60-BFBE39AFA01A}"/>
               </a:ext>
             </a:extLst>
           </p:cNvPr>
@@ -8629,7 +8629,7 @@
           <p:cNvPr id="17" name="">
             <a:extLst xmlns:a="http://schemas.openxmlformats.org/drawingml/2006/main">
               <a:ext uri="{FF2B5EF4-FFF2-40B4-BE49-F238E27FC236}">
-                <a16:creationId xmlns:a16="http://schemas.microsoft.com/office/drawing/2014/main" id="{1EC3FB27-AB7F-49CD-BEF3-85E79BFC29EE}"/>
+                <a16:creationId xmlns:a16="http://schemas.microsoft.com/office/drawing/2014/main" id="{ECCAF6A6-C20B-4F42-9C5E-66B97BD17660}"/>
               </a:ext>
             </a:extLst>
           </p:cNvPr>
@@ -8686,7 +8686,7 @@
           <p:cNvPr id="18" name="">
             <a:extLst xmlns:a="http://schemas.openxmlformats.org/drawingml/2006/main">
               <a:ext uri="{FF2B5EF4-FFF2-40B4-BE49-F238E27FC236}">
-                <a16:creationId xmlns:a16="http://schemas.microsoft.com/office/drawing/2014/main" id="{3847BC2A-0E67-4C53-9D89-B55A95C21772}"/>
+                <a16:creationId xmlns:a16="http://schemas.microsoft.com/office/drawing/2014/main" id="{8CC63AF4-688D-4CC2-AB8A-A5AF00EA99CB}"/>
               </a:ext>
             </a:extLst>
           </p:cNvPr>
@@ -8743,7 +8743,7 @@
           <p:cNvPr id="19" name="">
             <a:extLst xmlns:a="http://schemas.openxmlformats.org/drawingml/2006/main">
               <a:ext uri="{FF2B5EF4-FFF2-40B4-BE49-F238E27FC236}">
-                <a16:creationId xmlns:a16="http://schemas.microsoft.com/office/drawing/2014/main" id="{ECC5BE46-B1AF-448B-8DB1-2AB6535A79C8}"/>
+                <a16:creationId xmlns:a16="http://schemas.microsoft.com/office/drawing/2014/main" id="{5B6DD9E8-6206-43DB-822C-082A0FC63EA9}"/>
               </a:ext>
             </a:extLst>
           </p:cNvPr>
@@ -8800,7 +8800,7 @@
           <p:cNvPr id="20" name="">
             <a:extLst xmlns:a="http://schemas.openxmlformats.org/drawingml/2006/main">
               <a:ext uri="{FF2B5EF4-FFF2-40B4-BE49-F238E27FC236}">
-                <a16:creationId xmlns:a16="http://schemas.microsoft.com/office/drawing/2014/main" id="{BB0B4184-B3FC-41A8-84EF-A3B089A31A8B}"/>
+                <a16:creationId xmlns:a16="http://schemas.microsoft.com/office/drawing/2014/main" id="{863AE71D-762C-4137-9ED8-70246157B39E}"/>
               </a:ext>
             </a:extLst>
           </p:cNvPr>
@@ -8857,7 +8857,7 @@
           <p:cNvPr id="21" name="">
             <a:extLst xmlns:a="http://schemas.openxmlformats.org/drawingml/2006/main">
               <a:ext uri="{FF2B5EF4-FFF2-40B4-BE49-F238E27FC236}">
-                <a16:creationId xmlns:a16="http://schemas.microsoft.com/office/drawing/2014/main" id="{A5BAA030-B41A-4B6C-B47B-D6CA033A74EA}"/>
+                <a16:creationId xmlns:a16="http://schemas.microsoft.com/office/drawing/2014/main" id="{B3836B18-38B2-45FB-9E5E-F9035EFFB1AE}"/>
               </a:ext>
             </a:extLst>
           </p:cNvPr>
@@ -8914,7 +8914,7 @@
           <p:cNvPr id="22" name="">
             <a:extLst xmlns:a="http://schemas.openxmlformats.org/drawingml/2006/main">
               <a:ext uri="{FF2B5EF4-FFF2-40B4-BE49-F238E27FC236}">
-                <a16:creationId xmlns:a16="http://schemas.microsoft.com/office/drawing/2014/main" id="{41E84728-7808-41E4-BDA5-9FCD0AF23EC7}"/>
+                <a16:creationId xmlns:a16="http://schemas.microsoft.com/office/drawing/2014/main" id="{A1F56E7D-1AD1-4A30-B338-001879EF5061}"/>
               </a:ext>
             </a:extLst>
           </p:cNvPr>
@@ -8971,7 +8971,7 @@
           <p:cNvPr id="23" name="">
             <a:extLst xmlns:a="http://schemas.openxmlformats.org/drawingml/2006/main">
               <a:ext uri="{FF2B5EF4-FFF2-40B4-BE49-F238E27FC236}">
-                <a16:creationId xmlns:a16="http://schemas.microsoft.com/office/drawing/2014/main" id="{3E6F7012-D6A5-4DA3-9772-F7F4F4884653}"/>
+                <a16:creationId xmlns:a16="http://schemas.microsoft.com/office/drawing/2014/main" id="{93D3A4BC-C0C6-44A6-9418-0C30C7E1FAED}"/>
               </a:ext>
             </a:extLst>
           </p:cNvPr>
@@ -9028,7 +9028,7 @@
           <p:cNvPr id="24" name="">
             <a:extLst xmlns:a="http://schemas.openxmlformats.org/drawingml/2006/main">
               <a:ext uri="{FF2B5EF4-FFF2-40B4-BE49-F238E27FC236}">
-                <a16:creationId xmlns:a16="http://schemas.microsoft.com/office/drawing/2014/main" id="{A8D3924D-BC85-4F80-8B1C-4B0E48753D27}"/>
+                <a16:creationId xmlns:a16="http://schemas.microsoft.com/office/drawing/2014/main" id="{902BA5FF-B178-4B20-800D-A6122DC36FBA}"/>
               </a:ext>
             </a:extLst>
           </p:cNvPr>
@@ -9083,7 +9083,7 @@
     </p:spTree>
     <p:extLst>
       <p:ext uri="{BB962C8B-B14F-4D97-AF65-F5344CB8AC3E}">
-        <p14:creationId xmlns:p14="http://schemas.microsoft.com/office/powerpoint/2010/main" val="157253405"/>
+        <p14:creationId xmlns:p14="http://schemas.microsoft.com/office/powerpoint/2010/main" val="426374296"/>
       </p:ext>
     </p:extLst>
   </p:cSld>
@@ -9114,7 +9114,7 @@
           <p:cNvPr id="31" name="">
             <a:extLst xmlns:a="http://schemas.openxmlformats.org/drawingml/2006/main">
               <a:ext uri="{FF2B5EF4-FFF2-40B4-BE49-F238E27FC236}">
-                <a16:creationId xmlns:a16="http://schemas.microsoft.com/office/drawing/2014/main" id="{93FF54E7-209D-4206-BC7B-FC1BA7D0C9B5}"/>
+                <a16:creationId xmlns:a16="http://schemas.microsoft.com/office/drawing/2014/main" id="{29152D0B-3394-401F-B69C-C69F99616911}"/>
               </a:ext>
             </a:extLst>
           </p:cNvPr>
@@ -9161,7 +9161,7 @@
                 <a:ea typeface="Helvetica Neue"/>
                 <a:cs typeface="Helvetica Neue"/>
               </a:rPr>
-              <a:t>ETHICAL REFLECTION · 2 POINTS</a:t>
+              <a:t>ETHICAL REFLECTION</a:t>
             </a:r>
           </a:p>
         </p:txBody>
@@ -9171,7 +9171,7 @@
           <p:cNvPr id="2" name="">
             <a:extLst xmlns:a="http://schemas.openxmlformats.org/drawingml/2006/main">
               <a:ext uri="{FF2B5EF4-FFF2-40B4-BE49-F238E27FC236}">
-                <a16:creationId xmlns:a16="http://schemas.microsoft.com/office/drawing/2014/main" id="{82DA0545-173D-4A4D-B7E1-7F5C31F5CAE8}"/>
+                <a16:creationId xmlns:a16="http://schemas.microsoft.com/office/drawing/2014/main" id="{B4BBAD2F-93DC-4284-B3FF-51792BA08958}"/>
               </a:ext>
             </a:extLst>
           </p:cNvPr>
@@ -9228,7 +9228,7 @@
           <p:cNvPr id="3" name="">
             <a:extLst xmlns:a="http://schemas.openxmlformats.org/drawingml/2006/main">
               <a:ext uri="{FF2B5EF4-FFF2-40B4-BE49-F238E27FC236}">
-                <a16:creationId xmlns:a16="http://schemas.microsoft.com/office/drawing/2014/main" id="{89E8B16E-B838-470D-8BFF-4B2F0A9247D5}"/>
+                <a16:creationId xmlns:a16="http://schemas.microsoft.com/office/drawing/2014/main" id="{68E40DDA-E7A0-4D2B-A35A-08603116DF05}"/>
               </a:ext>
             </a:extLst>
           </p:cNvPr>
@@ -9259,7 +9259,7 @@
           <p:cNvPr id="4" name="">
             <a:extLst xmlns:a="http://schemas.openxmlformats.org/drawingml/2006/main">
               <a:ext uri="{FF2B5EF4-FFF2-40B4-BE49-F238E27FC236}">
-                <a16:creationId xmlns:a16="http://schemas.microsoft.com/office/drawing/2014/main" id="{537C17B7-832E-46D6-AD72-1820791596BB}"/>
+                <a16:creationId xmlns:a16="http://schemas.microsoft.com/office/drawing/2014/main" id="{D85F22BE-3245-4E8B-A0C0-EDB906BEF839}"/>
               </a:ext>
             </a:extLst>
           </p:cNvPr>
@@ -9294,7 +9294,7 @@
           <p:cNvPr id="5" name="">
             <a:extLst xmlns:a="http://schemas.openxmlformats.org/drawingml/2006/main">
               <a:ext uri="{FF2B5EF4-FFF2-40B4-BE49-F238E27FC236}">
-                <a16:creationId xmlns:a16="http://schemas.microsoft.com/office/drawing/2014/main" id="{A0EF51EC-4C59-46C4-861D-D73B19114C30}"/>
+                <a16:creationId xmlns:a16="http://schemas.microsoft.com/office/drawing/2014/main" id="{99DBFED4-E8DC-45A0-8823-7E494BEDAAEC}"/>
               </a:ext>
             </a:extLst>
           </p:cNvPr>
@@ -9351,7 +9351,7 @@
           <p:cNvPr id="6" name="">
             <a:extLst xmlns:a="http://schemas.openxmlformats.org/drawingml/2006/main">
               <a:ext uri="{FF2B5EF4-FFF2-40B4-BE49-F238E27FC236}">
-                <a16:creationId xmlns:a16="http://schemas.microsoft.com/office/drawing/2014/main" id="{49B80550-42F2-42EE-B70D-E16229C3FC00}"/>
+                <a16:creationId xmlns:a16="http://schemas.microsoft.com/office/drawing/2014/main" id="{5E7FC209-AFED-4336-AFE8-630DF77E4721}"/>
               </a:ext>
             </a:extLst>
           </p:cNvPr>
@@ -9408,7 +9408,7 @@
           <p:cNvPr id="7" name="">
             <a:extLst xmlns:a="http://schemas.openxmlformats.org/drawingml/2006/main">
               <a:ext uri="{FF2B5EF4-FFF2-40B4-BE49-F238E27FC236}">
-                <a16:creationId xmlns:a16="http://schemas.microsoft.com/office/drawing/2014/main" id="{D14866B4-1A4C-421C-A678-10AFE5F5146C}"/>
+                <a16:creationId xmlns:a16="http://schemas.microsoft.com/office/drawing/2014/main" id="{BB20173D-0386-41CE-9B66-47ABEF03D427}"/>
               </a:ext>
             </a:extLst>
           </p:cNvPr>
@@ -9441,7 +9441,7 @@
           <p:cNvPr id="8" name="">
             <a:extLst xmlns:a="http://schemas.openxmlformats.org/drawingml/2006/main">
               <a:ext uri="{FF2B5EF4-FFF2-40B4-BE49-F238E27FC236}">
-                <a16:creationId xmlns:a16="http://schemas.microsoft.com/office/drawing/2014/main" id="{3B65AF63-F535-4C8F-8CDC-760E13A571A4}"/>
+                <a16:creationId xmlns:a16="http://schemas.microsoft.com/office/drawing/2014/main" id="{C9238422-6E8C-4590-9616-A71DDF90AC42}"/>
               </a:ext>
             </a:extLst>
           </p:cNvPr>
@@ -9498,7 +9498,7 @@
           <p:cNvPr id="9" name="">
             <a:extLst xmlns:a="http://schemas.openxmlformats.org/drawingml/2006/main">
               <a:ext uri="{FF2B5EF4-FFF2-40B4-BE49-F238E27FC236}">
-                <a16:creationId xmlns:a16="http://schemas.microsoft.com/office/drawing/2014/main" id="{7F635EEB-470E-4959-A562-C4F4D7828AC0}"/>
+                <a16:creationId xmlns:a16="http://schemas.microsoft.com/office/drawing/2014/main" id="{E24139B5-5385-4517-BB71-624BA1E41463}"/>
               </a:ext>
             </a:extLst>
           </p:cNvPr>
@@ -9555,7 +9555,7 @@
           <p:cNvPr id="10" name="">
             <a:extLst xmlns:a="http://schemas.openxmlformats.org/drawingml/2006/main">
               <a:ext uri="{FF2B5EF4-FFF2-40B4-BE49-F238E27FC236}">
-                <a16:creationId xmlns:a16="http://schemas.microsoft.com/office/drawing/2014/main" id="{5DCBF8E2-7F15-4108-A2E8-2286720361C2}"/>
+                <a16:creationId xmlns:a16="http://schemas.microsoft.com/office/drawing/2014/main" id="{51A7B4EF-17BF-4C63-9EBF-18718D99CD8F}"/>
               </a:ext>
             </a:extLst>
           </p:cNvPr>
@@ -9612,7 +9612,7 @@
           <p:cNvPr id="11" name="">
             <a:extLst xmlns:a="http://schemas.openxmlformats.org/drawingml/2006/main">
               <a:ext uri="{FF2B5EF4-FFF2-40B4-BE49-F238E27FC236}">
-                <a16:creationId xmlns:a16="http://schemas.microsoft.com/office/drawing/2014/main" id="{8A08F61C-4A86-4A00-B3E4-E0B4A63AA969}"/>
+                <a16:creationId xmlns:a16="http://schemas.microsoft.com/office/drawing/2014/main" id="{6AAFF3DF-7114-48C3-806B-74E82C8ACFE2}"/>
               </a:ext>
             </a:extLst>
           </p:cNvPr>
@@ -9645,7 +9645,7 @@
           <p:cNvPr id="12" name="">
             <a:extLst xmlns:a="http://schemas.openxmlformats.org/drawingml/2006/main">
               <a:ext uri="{FF2B5EF4-FFF2-40B4-BE49-F238E27FC236}">
-                <a16:creationId xmlns:a16="http://schemas.microsoft.com/office/drawing/2014/main" id="{72033E10-FD1C-45C9-9747-ED8A528A31A3}"/>
+                <a16:creationId xmlns:a16="http://schemas.microsoft.com/office/drawing/2014/main" id="{2F86373A-52EA-45ED-9299-80A22E2A6A18}"/>
               </a:ext>
             </a:extLst>
           </p:cNvPr>
@@ -9702,7 +9702,7 @@
           <p:cNvPr id="13" name="">
             <a:extLst xmlns:a="http://schemas.openxmlformats.org/drawingml/2006/main">
               <a:ext uri="{FF2B5EF4-FFF2-40B4-BE49-F238E27FC236}">
-                <a16:creationId xmlns:a16="http://schemas.microsoft.com/office/drawing/2014/main" id="{E952CF1F-7C1E-4D9A-9D05-81F218AA4F4B}"/>
+                <a16:creationId xmlns:a16="http://schemas.microsoft.com/office/drawing/2014/main" id="{FD827A51-A748-41E8-BA2B-868A8C075A5A}"/>
               </a:ext>
             </a:extLst>
           </p:cNvPr>
@@ -9759,7 +9759,7 @@
           <p:cNvPr id="14" name="">
             <a:extLst xmlns:a="http://schemas.openxmlformats.org/drawingml/2006/main">
               <a:ext uri="{FF2B5EF4-FFF2-40B4-BE49-F238E27FC236}">
-                <a16:creationId xmlns:a16="http://schemas.microsoft.com/office/drawing/2014/main" id="{0C08D252-F91D-475A-A5ED-16ACE06C5757}"/>
+                <a16:creationId xmlns:a16="http://schemas.microsoft.com/office/drawing/2014/main" id="{C08CC7B5-46F8-48C6-82EE-B25079E85D94}"/>
               </a:ext>
             </a:extLst>
           </p:cNvPr>
@@ -9816,7 +9816,7 @@
           <p:cNvPr id="15" name="">
             <a:extLst xmlns:a="http://schemas.openxmlformats.org/drawingml/2006/main">
               <a:ext uri="{FF2B5EF4-FFF2-40B4-BE49-F238E27FC236}">
-                <a16:creationId xmlns:a16="http://schemas.microsoft.com/office/drawing/2014/main" id="{73343A3F-6942-4B54-BFCD-52B278B2F319}"/>
+                <a16:creationId xmlns:a16="http://schemas.microsoft.com/office/drawing/2014/main" id="{91087398-BCC6-444A-9F3C-0F03CEE9B0A8}"/>
               </a:ext>
             </a:extLst>
           </p:cNvPr>
@@ -9849,7 +9849,7 @@
           <p:cNvPr id="16" name="">
             <a:extLst xmlns:a="http://schemas.openxmlformats.org/drawingml/2006/main">
               <a:ext uri="{FF2B5EF4-FFF2-40B4-BE49-F238E27FC236}">
-                <a16:creationId xmlns:a16="http://schemas.microsoft.com/office/drawing/2014/main" id="{F3244B83-1526-4B1A-BFCE-650E22A79DB6}"/>
+                <a16:creationId xmlns:a16="http://schemas.microsoft.com/office/drawing/2014/main" id="{FA919D44-25D7-4C51-BA41-F701FBBA168F}"/>
               </a:ext>
             </a:extLst>
           </p:cNvPr>
@@ -9906,7 +9906,7 @@
           <p:cNvPr id="17" name="">
             <a:extLst xmlns:a="http://schemas.openxmlformats.org/drawingml/2006/main">
               <a:ext uri="{FF2B5EF4-FFF2-40B4-BE49-F238E27FC236}">
-                <a16:creationId xmlns:a16="http://schemas.microsoft.com/office/drawing/2014/main" id="{D98E7B76-FE26-43D7-B877-959817F4B2C1}"/>
+                <a16:creationId xmlns:a16="http://schemas.microsoft.com/office/drawing/2014/main" id="{0DFE0D22-A745-4332-99CD-4A988C694CF5}"/>
               </a:ext>
             </a:extLst>
           </p:cNvPr>
@@ -9963,7 +9963,7 @@
           <p:cNvPr id="18" name="">
             <a:extLst xmlns:a="http://schemas.openxmlformats.org/drawingml/2006/main">
               <a:ext uri="{FF2B5EF4-FFF2-40B4-BE49-F238E27FC236}">
-                <a16:creationId xmlns:a16="http://schemas.microsoft.com/office/drawing/2014/main" id="{EF06F8FC-952E-4F5F-9254-60976E9CF4C6}"/>
+                <a16:creationId xmlns:a16="http://schemas.microsoft.com/office/drawing/2014/main" id="{C81E5762-09A5-4A7F-A894-D4DFBD25C00A}"/>
               </a:ext>
             </a:extLst>
           </p:cNvPr>
@@ -10020,7 +10020,7 @@
           <p:cNvPr id="19" name="">
             <a:extLst xmlns:a="http://schemas.openxmlformats.org/drawingml/2006/main">
               <a:ext uri="{FF2B5EF4-FFF2-40B4-BE49-F238E27FC236}">
-                <a16:creationId xmlns:a16="http://schemas.microsoft.com/office/drawing/2014/main" id="{02FC2312-83A5-40C5-9E76-2475106AF475}"/>
+                <a16:creationId xmlns:a16="http://schemas.microsoft.com/office/drawing/2014/main" id="{2AE1D314-EC9D-4CC7-923C-86CDB1B22E20}"/>
               </a:ext>
             </a:extLst>
           </p:cNvPr>
@@ -10053,7 +10053,7 @@
           <p:cNvPr id="20" name="">
             <a:extLst xmlns:a="http://schemas.openxmlformats.org/drawingml/2006/main">
               <a:ext uri="{FF2B5EF4-FFF2-40B4-BE49-F238E27FC236}">
-                <a16:creationId xmlns:a16="http://schemas.microsoft.com/office/drawing/2014/main" id="{1B910606-A792-4EE2-93FB-2A2A6D949E5D}"/>
+                <a16:creationId xmlns:a16="http://schemas.microsoft.com/office/drawing/2014/main" id="{2C6DF393-B49D-4ECD-8052-10543E519E30}"/>
               </a:ext>
             </a:extLst>
           </p:cNvPr>
@@ -10110,7 +10110,7 @@
           <p:cNvPr id="21" name="">
             <a:extLst xmlns:a="http://schemas.openxmlformats.org/drawingml/2006/main">
               <a:ext uri="{FF2B5EF4-FFF2-40B4-BE49-F238E27FC236}">
-                <a16:creationId xmlns:a16="http://schemas.microsoft.com/office/drawing/2014/main" id="{B93CF5E5-6CD7-4165-A9B4-A1B9AA18F29E}"/>
+                <a16:creationId xmlns:a16="http://schemas.microsoft.com/office/drawing/2014/main" id="{FC708752-264D-44BF-98D4-B86846BCB5ED}"/>
               </a:ext>
             </a:extLst>
           </p:cNvPr>
@@ -10167,7 +10167,7 @@
           <p:cNvPr id="22" name="">
             <a:extLst xmlns:a="http://schemas.openxmlformats.org/drawingml/2006/main">
               <a:ext uri="{FF2B5EF4-FFF2-40B4-BE49-F238E27FC236}">
-                <a16:creationId xmlns:a16="http://schemas.microsoft.com/office/drawing/2014/main" id="{33EBB5E0-E7D0-46F3-89EE-D6A4174C4FCF}"/>
+                <a16:creationId xmlns:a16="http://schemas.microsoft.com/office/drawing/2014/main" id="{9784046B-125B-4852-87A8-B4258B0950D6}"/>
               </a:ext>
             </a:extLst>
           </p:cNvPr>
@@ -10224,7 +10224,7 @@
           <p:cNvPr id="23" name="">
             <a:extLst xmlns:a="http://schemas.openxmlformats.org/drawingml/2006/main">
               <a:ext uri="{FF2B5EF4-FFF2-40B4-BE49-F238E27FC236}">
-                <a16:creationId xmlns:a16="http://schemas.microsoft.com/office/drawing/2014/main" id="{54BDBDF5-6639-4A54-8041-C7BDB68BF736}"/>
+                <a16:creationId xmlns:a16="http://schemas.microsoft.com/office/drawing/2014/main" id="{5A2F0B00-66EF-4D68-B533-BAB9C0598508}"/>
               </a:ext>
             </a:extLst>
           </p:cNvPr>
@@ -10257,7 +10257,7 @@
           <p:cNvPr id="24" name="">
             <a:extLst xmlns:a="http://schemas.openxmlformats.org/drawingml/2006/main">
               <a:ext uri="{FF2B5EF4-FFF2-40B4-BE49-F238E27FC236}">
-                <a16:creationId xmlns:a16="http://schemas.microsoft.com/office/drawing/2014/main" id="{A1B901F2-EBDC-4C6B-A282-D3E871301C55}"/>
+                <a16:creationId xmlns:a16="http://schemas.microsoft.com/office/drawing/2014/main" id="{BC9B954F-62AB-4353-AE31-22E7E4F3A74C}"/>
               </a:ext>
             </a:extLst>
           </p:cNvPr>
@@ -10314,7 +10314,7 @@
           <p:cNvPr id="25" name="">
             <a:extLst xmlns:a="http://schemas.openxmlformats.org/drawingml/2006/main">
               <a:ext uri="{FF2B5EF4-FFF2-40B4-BE49-F238E27FC236}">
-                <a16:creationId xmlns:a16="http://schemas.microsoft.com/office/drawing/2014/main" id="{89E7503D-F705-45B9-9849-09BCE2479513}"/>
+                <a16:creationId xmlns:a16="http://schemas.microsoft.com/office/drawing/2014/main" id="{EBC8C213-0B63-42BF-95BB-9399BDCB1248}"/>
               </a:ext>
             </a:extLst>
           </p:cNvPr>
@@ -10371,7 +10371,7 @@
           <p:cNvPr id="26" name="">
             <a:extLst xmlns:a="http://schemas.openxmlformats.org/drawingml/2006/main">
               <a:ext uri="{FF2B5EF4-FFF2-40B4-BE49-F238E27FC236}">
-                <a16:creationId xmlns:a16="http://schemas.microsoft.com/office/drawing/2014/main" id="{A18204A7-B7D2-4C7D-8821-23FF02907CEE}"/>
+                <a16:creationId xmlns:a16="http://schemas.microsoft.com/office/drawing/2014/main" id="{3A6EDB74-6AD7-4727-BEE0-7BBDA39C777E}"/>
               </a:ext>
             </a:extLst>
           </p:cNvPr>
@@ -10428,7 +10428,7 @@
           <p:cNvPr id="27" name="">
             <a:extLst xmlns:a="http://schemas.openxmlformats.org/drawingml/2006/main">
               <a:ext uri="{FF2B5EF4-FFF2-40B4-BE49-F238E27FC236}">
-                <a16:creationId xmlns:a16="http://schemas.microsoft.com/office/drawing/2014/main" id="{708573C1-348B-449A-9770-FC157A229CBC}"/>
+                <a16:creationId xmlns:a16="http://schemas.microsoft.com/office/drawing/2014/main" id="{B28EFA4A-52C9-49CA-8724-9B3955C6540F}"/>
               </a:ext>
             </a:extLst>
           </p:cNvPr>
@@ -10461,7 +10461,7 @@
           <p:cNvPr id="28" name="">
             <a:extLst xmlns:a="http://schemas.openxmlformats.org/drawingml/2006/main">
               <a:ext uri="{FF2B5EF4-FFF2-40B4-BE49-F238E27FC236}">
-                <a16:creationId xmlns:a16="http://schemas.microsoft.com/office/drawing/2014/main" id="{E9231457-8B4A-4552-B449-926499A63A26}"/>
+                <a16:creationId xmlns:a16="http://schemas.microsoft.com/office/drawing/2014/main" id="{9C2570BE-A3D1-4B77-AE4C-B26C93E159C9}"/>
               </a:ext>
             </a:extLst>
           </p:cNvPr>
@@ -10518,7 +10518,7 @@
           <p:cNvPr id="29" name="">
             <a:extLst xmlns:a="http://schemas.openxmlformats.org/drawingml/2006/main">
               <a:ext uri="{FF2B5EF4-FFF2-40B4-BE49-F238E27FC236}">
-                <a16:creationId xmlns:a16="http://schemas.microsoft.com/office/drawing/2014/main" id="{C5FCE46F-291F-4886-96FC-5FDBD977D119}"/>
+                <a16:creationId xmlns:a16="http://schemas.microsoft.com/office/drawing/2014/main" id="{458DB914-7B5E-4BF2-8600-48ED8262776B}"/>
               </a:ext>
             </a:extLst>
           </p:cNvPr>
@@ -10631,7 +10631,7 @@
           <p:cNvPr id="30" name="">
             <a:extLst xmlns:a="http://schemas.openxmlformats.org/drawingml/2006/main">
               <a:ext uri="{FF2B5EF4-FFF2-40B4-BE49-F238E27FC236}">
-                <a16:creationId xmlns:a16="http://schemas.microsoft.com/office/drawing/2014/main" id="{1DD6C46B-C9FF-4030-AC83-82FF0670F78F}"/>
+                <a16:creationId xmlns:a16="http://schemas.microsoft.com/office/drawing/2014/main" id="{2135B6FA-77F1-467B-8AA6-01B267CFE541}"/>
               </a:ext>
             </a:extLst>
           </p:cNvPr>
@@ -10686,7 +10686,7 @@
     </p:spTree>
     <p:extLst>
       <p:ext uri="{BB962C8B-B14F-4D97-AF65-F5344CB8AC3E}">
-        <p14:creationId xmlns:p14="http://schemas.microsoft.com/office/powerpoint/2010/main" val="1302293718"/>
+        <p14:creationId xmlns:p14="http://schemas.microsoft.com/office/powerpoint/2010/main" val="201256036"/>
       </p:ext>
     </p:extLst>
   </p:cSld>

</xml_diff>